<commit_message>
Enhance PowerPoint decks with split 2-column hero layout, zero-margin text frames, and polished visual hierarchy
</commit_message>
<xml_diff>
--- a/Technology_Consultants_A_Quien_Enviarme_MX.pptx
+++ b/Technology_Consultants_A_Quien_Enviarme_MX.pptx
@@ -3157,7 +3157,7 @@
         <p:spPr>
           <a:xfrm>
             <a:off x="731520" y="146304"/>
-            <a:ext cx="310896" cy="310896"/>
+            <a:ext cx="301752" cy="301752"/>
           </a:xfrm>
           <a:prstGeom prst="roundRect">
             <a:avLst/>
@@ -3200,7 +3200,7 @@
         <p:spPr>
           <a:xfrm>
             <a:off x="731520" y="128016"/>
-            <a:ext cx="310896" cy="310896"/>
+            <a:ext cx="301752" cy="301752"/>
           </a:xfrm>
           <a:prstGeom prst="rect">
             <a:avLst/>
@@ -3208,7 +3208,7 @@
           <a:noFill/>
         </p:spPr>
         <p:txBody>
-          <a:bodyPr wrap="none" lIns="0" tIns="0" rIns="0" bIns="0">
+          <a:bodyPr wrap="square" lIns="0" rIns="0" tIns="0" bIns="0">
             <a:spAutoFit/>
           </a:bodyPr>
           <a:lstStyle/>
@@ -3244,7 +3244,7 @@
           <a:noFill/>
         </p:spPr>
         <p:txBody>
-          <a:bodyPr wrap="none" lIns="0" tIns="0" rIns="0" bIns="0">
+          <a:bodyPr wrap="square" lIns="0" rIns="0" tIns="0" bIns="0">
             <a:spAutoFit/>
           </a:bodyPr>
           <a:lstStyle/>
@@ -3271,8 +3271,8 @@
         </p:nvSpPr>
         <p:spPr>
           <a:xfrm>
-            <a:off x="5029200" y="182880"/>
-            <a:ext cx="4754880" cy="292608"/>
+            <a:off x="4572000" y="182880"/>
+            <a:ext cx="5212080" cy="292608"/>
           </a:xfrm>
           <a:prstGeom prst="rect">
             <a:avLst/>
@@ -3280,7 +3280,7 @@
           <a:noFill/>
         </p:spPr>
         <p:txBody>
-          <a:bodyPr wrap="none" lIns="0" tIns="0" rIns="0" bIns="0">
+          <a:bodyPr wrap="square" lIns="0" rIns="0" tIns="0" bIns="0">
             <a:spAutoFit/>
           </a:bodyPr>
           <a:lstStyle/>
@@ -3288,7 +3288,7 @@
             <a:pPr algn="r">
               <a:defRPr sz="1000">
                 <a:solidFill>
-                  <a:srgbClr val="C8CDD7"/>
+                  <a:srgbClr val="BEC3CD"/>
                 </a:solidFill>
                 <a:latin typeface="Helvetica Neue"/>
               </a:defRPr>
@@ -3307,8 +3307,8 @@
         </p:nvSpPr>
         <p:spPr>
           <a:xfrm>
-            <a:off x="10058400" y="128016"/>
-            <a:ext cx="1371600" cy="329184"/>
+            <a:off x="9966960" y="128016"/>
+            <a:ext cx="1463040" cy="329184"/>
           </a:xfrm>
           <a:prstGeom prst="roundRect">
             <a:avLst/>
@@ -3350,8 +3350,8 @@
         </p:nvSpPr>
         <p:spPr>
           <a:xfrm>
-            <a:off x="10058400" y="164592"/>
-            <a:ext cx="1371600" cy="274320"/>
+            <a:off x="9966960" y="164592"/>
+            <a:ext cx="1463040" cy="274320"/>
           </a:xfrm>
           <a:prstGeom prst="rect">
             <a:avLst/>
@@ -3359,7 +3359,7 @@
           <a:noFill/>
         </p:spPr>
         <p:txBody>
-          <a:bodyPr wrap="none" lIns="0" tIns="0" rIns="0" bIns="0">
+          <a:bodyPr wrap="square" lIns="0" rIns="0" tIns="0" bIns="0">
             <a:spAutoFit/>
           </a:bodyPr>
           <a:lstStyle/>
@@ -3386,8 +3386,8 @@
         </p:nvSpPr>
         <p:spPr>
           <a:xfrm>
-            <a:off x="731520" y="822960"/>
-            <a:ext cx="10728655" cy="274320"/>
+            <a:off x="731520" y="868680"/>
+            <a:ext cx="6217920" cy="3931920"/>
           </a:xfrm>
           <a:prstGeom prst="rect">
             <a:avLst/>
@@ -3395,13 +3395,16 @@
           <a:noFill/>
         </p:spPr>
         <p:txBody>
-          <a:bodyPr wrap="none" lIns="0" tIns="0" rIns="0" bIns="0">
+          <a:bodyPr wrap="square" lIns="0" rIns="0" tIns="0" bIns="0">
             <a:spAutoFit/>
           </a:bodyPr>
           <a:lstStyle/>
           <a:p>
             <a:pPr>
-              <a:defRPr sz="1000" b="1">
+              <a:spcAft>
+                <a:spcPts val="1200"/>
+              </a:spcAft>
+              <a:defRPr sz="950" b="1">
                 <a:solidFill>
                   <a:srgbClr val="2B59D9"/>
                 </a:solidFill>
@@ -3412,18 +3415,93 @@
               <a:t>SITIOS WEB  ·  AUTOMATIZACIÓN  ·  AGENTES IA    |    ● Proyectos activos · Q3 2026</a:t>
             </a:r>
           </a:p>
-        </p:txBody>
-      </p:sp>
-      <p:sp>
-        <p:nvSpPr>
-          <p:cNvPr id="10" name="TextBox 9"/>
+          <a:p>
+            <a:pPr>
+              <a:spcAft>
+                <a:spcPts val="1400"/>
+              </a:spcAft>
+              <a:defRPr sz="3200" b="1">
+                <a:solidFill>
+                  <a:srgbClr val="16161A"/>
+                </a:solidFill>
+                <a:latin typeface="Helvetica Neue"/>
+              </a:defRPr>
+            </a:pPr>
+            <a:r>
+              <a:t>Desarrollamos tecnología alrededor de tu equipo — no para reemplazarlo.</a:t>
+            </a:r>
+          </a:p>
+          <a:p>
+            <a:pPr>
+              <a:spcAft>
+                <a:spcPts val="2000"/>
+              </a:spcAft>
+              <a:defRPr sz="1350">
+                <a:solidFill>
+                  <a:srgbClr val="454337"/>
+                </a:solidFill>
+                <a:latin typeface="Helvetica Neue"/>
+              </a:defRPr>
+            </a:pPr>
+            <a:r>
+              <a:t>Desarrollamos software que elimina tareas repetitivas de tu equipo — desde aplicaciones web automatizadas hasta agentes de IA con supervisión humana en cada proceso clave donde el dinero, la confianza o el criterio importan.</a:t>
+            </a:r>
+          </a:p>
+        </p:txBody>
+      </p:sp>
+      <p:sp>
+        <p:nvSpPr>
+          <p:cNvPr id="10" name="Rounded Rectangle 9"/>
+          <p:cNvSpPr/>
+          <p:nvPr/>
+        </p:nvSpPr>
+        <p:spPr>
+          <a:xfrm>
+            <a:off x="731520" y="4160520"/>
+            <a:ext cx="2377440" cy="438912"/>
+          </a:xfrm>
+          <a:prstGeom prst="roundRect">
+            <a:avLst/>
+          </a:prstGeom>
+          <a:solidFill>
+            <a:srgbClr val="16161A"/>
+          </a:solidFill>
+          <a:ln>
+            <a:noFill/>
+          </a:ln>
+        </p:spPr>
+        <p:style>
+          <a:lnRef idx="1">
+            <a:schemeClr val="accent1"/>
+          </a:lnRef>
+          <a:fillRef idx="3">
+            <a:schemeClr val="accent1"/>
+          </a:fillRef>
+          <a:effectRef idx="2">
+            <a:schemeClr val="accent1"/>
+          </a:effectRef>
+          <a:fontRef idx="minor">
+            <a:schemeClr val="lt1"/>
+          </a:fontRef>
+        </p:style>
+        <p:txBody>
+          <a:bodyPr rtlCol="0" anchor="ctr"/>
+          <a:lstStyle/>
+          <a:p>
+            <a:pPr algn="ctr"/>
+          </a:p>
+        </p:txBody>
+      </p:sp>
+      <p:sp>
+        <p:nvSpPr>
+          <p:cNvPr id="11" name="TextBox 10"/>
           <p:cNvSpPr txBox="1"/>
           <p:nvPr/>
         </p:nvSpPr>
         <p:spPr>
           <a:xfrm>
-            <a:off x="731520" y="1143000"/>
-            <a:ext cx="10728655" cy="1371600"/>
+            <a:off x="731520" y="4251960"/>
+            <a:ext cx="2377440" cy="320040"/>
           </a:xfrm>
           <a:prstGeom prst="rect">
             <a:avLst/>
@@ -3431,13 +3509,94 @@
           <a:noFill/>
         </p:spPr>
         <p:txBody>
-          <a:bodyPr wrap="square" lIns="0" tIns="0" rIns="0" bIns="0">
+          <a:bodyPr wrap="square" lIns="0" rIns="0" tIns="0" bIns="0">
             <a:spAutoFit/>
           </a:bodyPr>
           <a:lstStyle/>
           <a:p>
-            <a:pPr>
-              <a:defRPr sz="3600" b="1">
+            <a:pPr algn="ctr">
+              <a:defRPr sz="1150" b="1">
+                <a:solidFill>
+                  <a:srgbClr val="FFFFFF"/>
+                </a:solidFill>
+                <a:latin typeface="Helvetica Neue"/>
+              </a:defRPr>
+            </a:pPr>
+            <a:r>
+              <a:t>Agendar llamada →</a:t>
+            </a:r>
+          </a:p>
+        </p:txBody>
+      </p:sp>
+      <p:sp>
+        <p:nvSpPr>
+          <p:cNvPr id="12" name="Rounded Rectangle 11"/>
+          <p:cNvSpPr/>
+          <p:nvPr/>
+        </p:nvSpPr>
+        <p:spPr>
+          <a:xfrm>
+            <a:off x="3246120" y="4160520"/>
+            <a:ext cx="2286000" cy="438912"/>
+          </a:xfrm>
+          <a:prstGeom prst="roundRect">
+            <a:avLst/>
+          </a:prstGeom>
+          <a:solidFill>
+            <a:srgbClr val="FBFAF5"/>
+          </a:solidFill>
+          <a:ln w="12700">
+            <a:solidFill>
+              <a:srgbClr val="E2DDD0"/>
+            </a:solidFill>
+          </a:ln>
+        </p:spPr>
+        <p:style>
+          <a:lnRef idx="1">
+            <a:schemeClr val="accent1"/>
+          </a:lnRef>
+          <a:fillRef idx="3">
+            <a:schemeClr val="accent1"/>
+          </a:fillRef>
+          <a:effectRef idx="2">
+            <a:schemeClr val="accent1"/>
+          </a:effectRef>
+          <a:fontRef idx="minor">
+            <a:schemeClr val="lt1"/>
+          </a:fontRef>
+        </p:style>
+        <p:txBody>
+          <a:bodyPr rtlCol="0" anchor="ctr"/>
+          <a:lstStyle/>
+          <a:p>
+            <a:pPr algn="ctr"/>
+          </a:p>
+        </p:txBody>
+      </p:sp>
+      <p:sp>
+        <p:nvSpPr>
+          <p:cNvPr id="13" name="TextBox 12"/>
+          <p:cNvSpPr txBox="1"/>
+          <p:nvPr/>
+        </p:nvSpPr>
+        <p:spPr>
+          <a:xfrm>
+            <a:off x="3246120" y="4251960"/>
+            <a:ext cx="2286000" cy="320040"/>
+          </a:xfrm>
+          <a:prstGeom prst="rect">
+            <a:avLst/>
+          </a:prstGeom>
+          <a:noFill/>
+        </p:spPr>
+        <p:txBody>
+          <a:bodyPr wrap="square" lIns="0" rIns="0" tIns="0" bIns="0">
+            <a:spAutoFit/>
+          </a:bodyPr>
+          <a:lstStyle/>
+          <a:p>
+            <a:pPr algn="ctr">
+              <a:defRPr sz="1150" b="1">
                 <a:solidFill>
                   <a:srgbClr val="16161A"/>
                 </a:solidFill>
@@ -3445,21 +3604,21 @@
               </a:defRPr>
             </a:pPr>
             <a:r>
-              <a:t>Desarrollamos tecnología alrededor de tu equipo — no para reemplazarlo.</a:t>
-            </a:r>
-          </a:p>
-        </p:txBody>
-      </p:sp>
-      <p:sp>
-        <p:nvSpPr>
-          <p:cNvPr id="11" name="Rounded Rectangle 10"/>
+              <a:t>Guía de Referencia</a:t>
+            </a:r>
+          </a:p>
+        </p:txBody>
+      </p:sp>
+      <p:sp>
+        <p:nvSpPr>
+          <p:cNvPr id="14" name="Rounded Rectangle 13"/>
           <p:cNvSpPr/>
           <p:nvPr/>
         </p:nvSpPr>
         <p:spPr>
           <a:xfrm>
-            <a:off x="731520" y="2606040"/>
-            <a:ext cx="10728655" cy="1463040"/>
+            <a:off x="7315200" y="868680"/>
+            <a:ext cx="4144975" cy="1920240"/>
           </a:xfrm>
           <a:prstGeom prst="roundRect">
             <a:avLst/>
@@ -3497,14 +3656,14 @@
       </p:sp>
       <p:sp>
         <p:nvSpPr>
-          <p:cNvPr id="12" name="TextBox 11"/>
+          <p:cNvPr id="15" name="TextBox 14"/>
           <p:cNvSpPr txBox="1"/>
           <p:nvPr/>
         </p:nvSpPr>
         <p:spPr>
           <a:xfrm>
-            <a:off x="1005840" y="2743200"/>
-            <a:ext cx="10180015" cy="1188720"/>
+            <a:off x="7589520" y="1051560"/>
+            <a:ext cx="3596335" cy="1554480"/>
           </a:xfrm>
           <a:prstGeom prst="rect">
             <a:avLst/>
@@ -3512,15 +3671,44 @@
           <a:noFill/>
         </p:spPr>
         <p:txBody>
-          <a:bodyPr wrap="square">
+          <a:bodyPr wrap="square" lIns="0" rIns="0" tIns="0" bIns="0">
             <a:spAutoFit/>
           </a:bodyPr>
           <a:lstStyle/>
           <a:p>
             <a:pPr>
               <a:spcAft>
-                <a:spcPts val="600"/>
+                <a:spcPts val="800"/>
               </a:spcAft>
+              <a:defRPr sz="1000" b="1">
+                <a:solidFill>
+                  <a:srgbClr val="2B59D9"/>
+                </a:solidFill>
+                <a:latin typeface="Helvetica Neue"/>
+              </a:defRPr>
+            </a:pPr>
+            <a:r>
+              <a:t>● REVISIÓN DE FACTURAS</a:t>
+            </a:r>
+          </a:p>
+          <a:p>
+            <a:pPr>
+              <a:spcAft>
+                <a:spcPts val="1000"/>
+              </a:spcAft>
+              <a:defRPr sz="1500" b="1">
+                <a:solidFill>
+                  <a:srgbClr val="16161A"/>
+                </a:solidFill>
+                <a:latin typeface="Helvetica Neue"/>
+              </a:defRPr>
+            </a:pPr>
+            <a:r>
+              <a:t>245 procesadas automáticamente</a:t>
+            </a:r>
+          </a:p>
+          <a:p>
+            <a:pPr>
               <a:defRPr sz="1100" b="1">
                 <a:solidFill>
                   <a:srgbClr val="D99B26"/>
@@ -3529,43 +3717,68 @@
               </a:defRPr>
             </a:pPr>
             <a:r>
-              <a:t>¿A QUIÉN ENVIARME?  —  GUÍA DE REFERENCIAS PARA SOCIOS</a:t>
-            </a:r>
-          </a:p>
-          <a:p>
-            <a:pPr>
-              <a:defRPr sz="1400">
-                <a:solidFill>
-                  <a:srgbClr val="454337"/>
-                </a:solidFill>
-                <a:latin typeface="Helvetica Neue"/>
-              </a:defRPr>
-            </a:pPr>
-            <a:r>
-              <a:t>Desarrollamos software que elimina tareas repetitivas de tu equipo — desde aplicaciones web automatizadas hasta agentes de IA con supervisión humana en cada proceso clave.</a:t>
-            </a:r>
-          </a:p>
-        </p:txBody>
-      </p:sp>
-      <p:sp>
-        <p:nvSpPr>
-          <p:cNvPr id="13" name="Rounded Rectangle 12"/>
+              <a:t>2 REQUIEREN TU REVISIÓN</a:t>
+            </a:r>
+          </a:p>
+        </p:txBody>
+      </p:sp>
+      <p:sp>
+        <p:nvSpPr>
+          <p:cNvPr id="16" name="TextBox 15"/>
+          <p:cNvSpPr txBox="1"/>
+          <p:nvPr/>
+        </p:nvSpPr>
+        <p:spPr>
+          <a:xfrm>
+            <a:off x="7315200" y="2834640"/>
+            <a:ext cx="4144975" cy="548640"/>
+          </a:xfrm>
+          <a:prstGeom prst="rect">
+            <a:avLst/>
+          </a:prstGeom>
+          <a:noFill/>
+        </p:spPr>
+        <p:txBody>
+          <a:bodyPr wrap="square" lIns="0" rIns="0" tIns="0" bIns="0">
+            <a:spAutoFit/>
+          </a:bodyPr>
+          <a:lstStyle/>
+          <a:p>
+            <a:pPr>
+              <a:defRPr sz="1050">
+                <a:solidFill>
+                  <a:srgbClr val="736E62"/>
+                </a:solidFill>
+                <a:latin typeface="Helvetica Neue"/>
+              </a:defRPr>
+            </a:pPr>
+            <a:r>
+              <a:t>El agente despeja el trabajo rutinario. Las llamadas y decisiones con criterio permanecen en el equipo.</a:t>
+            </a:r>
+          </a:p>
+        </p:txBody>
+      </p:sp>
+      <p:sp>
+        <p:nvSpPr>
+          <p:cNvPr id="17" name="Rounded Rectangle 16"/>
           <p:cNvSpPr/>
           <p:nvPr/>
         </p:nvSpPr>
         <p:spPr>
           <a:xfrm>
-            <a:off x="731520" y="4206240"/>
-            <a:ext cx="2560320" cy="438912"/>
+            <a:off x="7315200" y="3520440"/>
+            <a:ext cx="4144975" cy="1078992"/>
           </a:xfrm>
           <a:prstGeom prst="roundRect">
             <a:avLst/>
           </a:prstGeom>
           <a:solidFill>
-            <a:srgbClr val="16161A"/>
+            <a:srgbClr val="FFFFFF"/>
           </a:solidFill>
-          <a:ln>
-            <a:noFill/>
+          <a:ln w="12700">
+            <a:solidFill>
+              <a:srgbClr val="E2DDD0"/>
+            </a:solidFill>
           </a:ln>
         </p:spPr>
         <p:style>
@@ -3592,14 +3805,14 @@
       </p:sp>
       <p:sp>
         <p:nvSpPr>
-          <p:cNvPr id="14" name="TextBox 13"/>
+          <p:cNvPr id="18" name="TextBox 17"/>
           <p:cNvSpPr txBox="1"/>
           <p:nvPr/>
         </p:nvSpPr>
         <p:spPr>
           <a:xfrm>
-            <a:off x="731520" y="4297680"/>
-            <a:ext cx="2560320" cy="320040"/>
+            <a:off x="7543800" y="3657600"/>
+            <a:ext cx="3687775" cy="822960"/>
           </a:xfrm>
           <a:prstGeom prst="rect">
             <a:avLst/>
@@ -3607,35 +3820,109 @@
           <a:noFill/>
         </p:spPr>
         <p:txBody>
-          <a:bodyPr wrap="none">
+          <a:bodyPr wrap="square" lIns="0" rIns="0" tIns="0" bIns="0">
             <a:spAutoFit/>
           </a:bodyPr>
           <a:lstStyle/>
           <a:p>
-            <a:pPr algn="ctr">
-              <a:defRPr sz="1200" b="1">
-                <a:solidFill>
-                  <a:srgbClr val="FFFFFF"/>
-                </a:solidFill>
-                <a:latin typeface="Helvetica Neue"/>
-              </a:defRPr>
-            </a:pPr>
-            <a:r>
-              <a:t>Agendar llamada →</a:t>
-            </a:r>
-          </a:p>
-        </p:txBody>
-      </p:sp>
-      <p:sp>
-        <p:nvSpPr>
-          <p:cNvPr id="15" name="TextBox 14"/>
+            <a:pPr>
+              <a:defRPr sz="1400" b="1">
+                <a:solidFill>
+                  <a:srgbClr val="16161A"/>
+                </a:solidFill>
+                <a:latin typeface="Helvetica Neue"/>
+              </a:defRPr>
+            </a:pPr>
+            <a:r>
+              <a:t>Roberto Guido</a:t>
+            </a:r>
+          </a:p>
+          <a:p>
+            <a:pPr>
+              <a:defRPr sz="1100">
+                <a:solidFill>
+                  <a:srgbClr val="2B59D9"/>
+                </a:solidFill>
+                <a:latin typeface="Helvetica Neue"/>
+              </a:defRPr>
+            </a:pPr>
+            <a:r>
+              <a:t>Fundador e Ingeniero Principal</a:t>
+            </a:r>
+          </a:p>
+          <a:p>
+            <a:pPr>
+              <a:spcBef>
+                <a:spcPts val="200"/>
+              </a:spcBef>
+              <a:defRPr sz="1000">
+                <a:solidFill>
+                  <a:srgbClr val="736E62"/>
+                </a:solidFill>
+                <a:latin typeface="Helvetica Neue"/>
+              </a:defRPr>
+            </a:pPr>
+            <a:r>
+              <a:t>Ingeniero Eléctrico (UC San Diego) · MBA (NYU Stern)</a:t>
+            </a:r>
+          </a:p>
+        </p:txBody>
+      </p:sp>
+      <p:sp>
+        <p:nvSpPr>
+          <p:cNvPr id="19" name="Rounded Rectangle 18"/>
+          <p:cNvSpPr/>
+          <p:nvPr/>
+        </p:nvSpPr>
+        <p:spPr>
+          <a:xfrm>
+            <a:off x="731520" y="4892040"/>
+            <a:ext cx="2514600" cy="1188720"/>
+          </a:xfrm>
+          <a:prstGeom prst="roundRect">
+            <a:avLst/>
+          </a:prstGeom>
+          <a:solidFill>
+            <a:srgbClr val="FFFFFF"/>
+          </a:solidFill>
+          <a:ln w="12700">
+            <a:solidFill>
+              <a:srgbClr val="E2DDD0"/>
+            </a:solidFill>
+          </a:ln>
+        </p:spPr>
+        <p:style>
+          <a:lnRef idx="1">
+            <a:schemeClr val="accent1"/>
+          </a:lnRef>
+          <a:fillRef idx="3">
+            <a:schemeClr val="accent1"/>
+          </a:fillRef>
+          <a:effectRef idx="2">
+            <a:schemeClr val="accent1"/>
+          </a:effectRef>
+          <a:fontRef idx="minor">
+            <a:schemeClr val="lt1"/>
+          </a:fontRef>
+        </p:style>
+        <p:txBody>
+          <a:bodyPr rtlCol="0" anchor="ctr"/>
+          <a:lstStyle/>
+          <a:p>
+            <a:pPr algn="ctr"/>
+          </a:p>
+        </p:txBody>
+      </p:sp>
+      <p:sp>
+        <p:nvSpPr>
+          <p:cNvPr id="20" name="TextBox 19"/>
           <p:cNvSpPr txBox="1"/>
           <p:nvPr/>
         </p:nvSpPr>
         <p:spPr>
           <a:xfrm>
-            <a:off x="3657600" y="4206240"/>
-            <a:ext cx="7772400" cy="457200"/>
+            <a:off x="914400" y="5010912"/>
+            <a:ext cx="2148840" cy="960120"/>
           </a:xfrm>
           <a:prstGeom prst="rect">
             <a:avLst/>
@@ -3643,13 +3930,16 @@
           <a:noFill/>
         </p:spPr>
         <p:txBody>
-          <a:bodyPr wrap="none">
+          <a:bodyPr wrap="square" lIns="0" rIns="0" tIns="0" bIns="0">
             <a:spAutoFit/>
           </a:bodyPr>
           <a:lstStyle/>
           <a:p>
             <a:pPr>
-              <a:defRPr sz="1200" b="1">
+              <a:spcAft>
+                <a:spcPts val="400"/>
+              </a:spcAft>
+              <a:defRPr sz="1300" b="1">
                 <a:solidFill>
                   <a:srgbClr val="16161A"/>
                 </a:solidFill>
@@ -3657,21 +3947,79 @@
               </a:defRPr>
             </a:pPr>
             <a:r>
-              <a:t>Roberto Guido  |  Fundador e Ingeniero Principal  (Ing. Eléctrico UC San Diego · MBA NYU Stern)</a:t>
-            </a:r>
-          </a:p>
-        </p:txBody>
-      </p:sp>
-      <p:sp>
-        <p:nvSpPr>
-          <p:cNvPr id="16" name="TextBox 15"/>
+              <a:t>En producción.</a:t>
+            </a:r>
+          </a:p>
+          <a:p>
+            <a:pPr>
+              <a:defRPr sz="1050">
+                <a:solidFill>
+                  <a:srgbClr val="454337"/>
+                </a:solidFill>
+                <a:latin typeface="Helvetica Neue"/>
+              </a:defRPr>
+            </a:pPr>
+            <a:r>
+              <a:t>Usuarios reales hoy en nuestros productos.</a:t>
+            </a:r>
+          </a:p>
+        </p:txBody>
+      </p:sp>
+      <p:sp>
+        <p:nvSpPr>
+          <p:cNvPr id="21" name="Rounded Rectangle 20"/>
+          <p:cNvSpPr/>
+          <p:nvPr/>
+        </p:nvSpPr>
+        <p:spPr>
+          <a:xfrm>
+            <a:off x="3429000" y="4892040"/>
+            <a:ext cx="2514600" cy="1188720"/>
+          </a:xfrm>
+          <a:prstGeom prst="roundRect">
+            <a:avLst/>
+          </a:prstGeom>
+          <a:solidFill>
+            <a:srgbClr val="FFFFFF"/>
+          </a:solidFill>
+          <a:ln w="12700">
+            <a:solidFill>
+              <a:srgbClr val="E2DDD0"/>
+            </a:solidFill>
+          </a:ln>
+        </p:spPr>
+        <p:style>
+          <a:lnRef idx="1">
+            <a:schemeClr val="accent1"/>
+          </a:lnRef>
+          <a:fillRef idx="3">
+            <a:schemeClr val="accent1"/>
+          </a:fillRef>
+          <a:effectRef idx="2">
+            <a:schemeClr val="accent1"/>
+          </a:effectRef>
+          <a:fontRef idx="minor">
+            <a:schemeClr val="lt1"/>
+          </a:fontRef>
+        </p:style>
+        <p:txBody>
+          <a:bodyPr rtlCol="0" anchor="ctr"/>
+          <a:lstStyle/>
+          <a:p>
+            <a:pPr algn="ctr"/>
+          </a:p>
+        </p:txBody>
+      </p:sp>
+      <p:sp>
+        <p:nvSpPr>
+          <p:cNvPr id="22" name="TextBox 21"/>
           <p:cNvSpPr txBox="1"/>
           <p:nvPr/>
         </p:nvSpPr>
         <p:spPr>
           <a:xfrm>
-            <a:off x="731520" y="4892040"/>
-            <a:ext cx="2468880" cy="1097280"/>
+            <a:off x="3611880" y="5010912"/>
+            <a:ext cx="2148840" cy="960120"/>
           </a:xfrm>
           <a:prstGeom prst="rect">
             <a:avLst/>
@@ -3679,16 +4027,16 @@
           <a:noFill/>
         </p:spPr>
         <p:txBody>
-          <a:bodyPr wrap="square" lIns="0" tIns="0" rIns="0" bIns="0">
+          <a:bodyPr wrap="square" lIns="0" rIns="0" tIns="0" bIns="0">
             <a:spAutoFit/>
           </a:bodyPr>
           <a:lstStyle/>
           <a:p>
             <a:pPr>
               <a:spcAft>
-                <a:spcPts val="200"/>
+                <a:spcPts val="400"/>
               </a:spcAft>
-              <a:defRPr sz="1400" b="1">
+              <a:defRPr sz="1300" b="1">
                 <a:solidFill>
                   <a:srgbClr val="16161A"/>
                 </a:solidFill>
@@ -3696,12 +4044,12 @@
               </a:defRPr>
             </a:pPr>
             <a:r>
-              <a:t>En producción.</a:t>
-            </a:r>
-          </a:p>
-          <a:p>
-            <a:pPr>
-              <a:defRPr sz="1100">
+              <a:t>Equipo senior.</a:t>
+            </a:r>
+          </a:p>
+          <a:p>
+            <a:pPr>
+              <a:defRPr sz="1050">
                 <a:solidFill>
                   <a:srgbClr val="454337"/>
                 </a:solidFill>
@@ -3709,21 +4057,66 @@
               </a:defRPr>
             </a:pPr>
             <a:r>
-              <a:t>Usuarios reales hoy en nuestros productos.</a:t>
-            </a:r>
-          </a:p>
-        </p:txBody>
-      </p:sp>
-      <p:sp>
-        <p:nvSpPr>
-          <p:cNvPr id="17" name="TextBox 16"/>
+              <a:t>Quienes presentan tu proyecto lo construyen.</a:t>
+            </a:r>
+          </a:p>
+        </p:txBody>
+      </p:sp>
+      <p:sp>
+        <p:nvSpPr>
+          <p:cNvPr id="23" name="Rounded Rectangle 22"/>
+          <p:cNvSpPr/>
+          <p:nvPr/>
+        </p:nvSpPr>
+        <p:spPr>
+          <a:xfrm>
+            <a:off x="6126480" y="4892040"/>
+            <a:ext cx="2514600" cy="1188720"/>
+          </a:xfrm>
+          <a:prstGeom prst="roundRect">
+            <a:avLst/>
+          </a:prstGeom>
+          <a:solidFill>
+            <a:srgbClr val="FFFFFF"/>
+          </a:solidFill>
+          <a:ln w="12700">
+            <a:solidFill>
+              <a:srgbClr val="E2DDD0"/>
+            </a:solidFill>
+          </a:ln>
+        </p:spPr>
+        <p:style>
+          <a:lnRef idx="1">
+            <a:schemeClr val="accent1"/>
+          </a:lnRef>
+          <a:fillRef idx="3">
+            <a:schemeClr val="accent1"/>
+          </a:fillRef>
+          <a:effectRef idx="2">
+            <a:schemeClr val="accent1"/>
+          </a:effectRef>
+          <a:fontRef idx="minor">
+            <a:schemeClr val="lt1"/>
+          </a:fontRef>
+        </p:style>
+        <p:txBody>
+          <a:bodyPr rtlCol="0" anchor="ctr"/>
+          <a:lstStyle/>
+          <a:p>
+            <a:pPr algn="ctr"/>
+          </a:p>
+        </p:txBody>
+      </p:sp>
+      <p:sp>
+        <p:nvSpPr>
+          <p:cNvPr id="24" name="TextBox 23"/>
           <p:cNvSpPr txBox="1"/>
           <p:nvPr/>
         </p:nvSpPr>
         <p:spPr>
           <a:xfrm>
-            <a:off x="3429000" y="4892040"/>
-            <a:ext cx="2468880" cy="1097280"/>
+            <a:off x="6309360" y="5010912"/>
+            <a:ext cx="2148840" cy="960120"/>
           </a:xfrm>
           <a:prstGeom prst="rect">
             <a:avLst/>
@@ -3731,16 +4124,16 @@
           <a:noFill/>
         </p:spPr>
         <p:txBody>
-          <a:bodyPr wrap="square" lIns="0" tIns="0" rIns="0" bIns="0">
+          <a:bodyPr wrap="square" lIns="0" rIns="0" tIns="0" bIns="0">
             <a:spAutoFit/>
           </a:bodyPr>
           <a:lstStyle/>
           <a:p>
             <a:pPr>
               <a:spcAft>
-                <a:spcPts val="200"/>
+                <a:spcPts val="400"/>
               </a:spcAft>
-              <a:defRPr sz="1400" b="1">
+              <a:defRPr sz="1300" b="1">
                 <a:solidFill>
                   <a:srgbClr val="16161A"/>
                 </a:solidFill>
@@ -3748,12 +4141,12 @@
               </a:defRPr>
             </a:pPr>
             <a:r>
-              <a:t>Equipo senior.</a:t>
-            </a:r>
-          </a:p>
-          <a:p>
-            <a:pPr>
-              <a:defRPr sz="1100">
+              <a:t>Código primero.</a:t>
+            </a:r>
+          </a:p>
+          <a:p>
+            <a:pPr>
+              <a:defRPr sz="1050">
                 <a:solidFill>
                   <a:srgbClr val="454337"/>
                 </a:solidFill>
@@ -3761,21 +4154,66 @@
               </a:defRPr>
             </a:pPr>
             <a:r>
-              <a:t>Quienes presentan tu proyecto lo construyen.</a:t>
-            </a:r>
-          </a:p>
-        </p:txBody>
-      </p:sp>
-      <p:sp>
-        <p:nvSpPr>
-          <p:cNvPr id="18" name="TextBox 17"/>
+              <a:t>Software funcional antes que diapositivas.</a:t>
+            </a:r>
+          </a:p>
+        </p:txBody>
+      </p:sp>
+      <p:sp>
+        <p:nvSpPr>
+          <p:cNvPr id="25" name="Rounded Rectangle 24"/>
+          <p:cNvSpPr/>
+          <p:nvPr/>
+        </p:nvSpPr>
+        <p:spPr>
+          <a:xfrm>
+            <a:off x="8823960" y="4892040"/>
+            <a:ext cx="2514600" cy="1188720"/>
+          </a:xfrm>
+          <a:prstGeom prst="roundRect">
+            <a:avLst/>
+          </a:prstGeom>
+          <a:solidFill>
+            <a:srgbClr val="FFFFFF"/>
+          </a:solidFill>
+          <a:ln w="12700">
+            <a:solidFill>
+              <a:srgbClr val="E2DDD0"/>
+            </a:solidFill>
+          </a:ln>
+        </p:spPr>
+        <p:style>
+          <a:lnRef idx="1">
+            <a:schemeClr val="accent1"/>
+          </a:lnRef>
+          <a:fillRef idx="3">
+            <a:schemeClr val="accent1"/>
+          </a:fillRef>
+          <a:effectRef idx="2">
+            <a:schemeClr val="accent1"/>
+          </a:effectRef>
+          <a:fontRef idx="minor">
+            <a:schemeClr val="lt1"/>
+          </a:fontRef>
+        </p:style>
+        <p:txBody>
+          <a:bodyPr rtlCol="0" anchor="ctr"/>
+          <a:lstStyle/>
+          <a:p>
+            <a:pPr algn="ctr"/>
+          </a:p>
+        </p:txBody>
+      </p:sp>
+      <p:sp>
+        <p:nvSpPr>
+          <p:cNvPr id="26" name="TextBox 25"/>
           <p:cNvSpPr txBox="1"/>
           <p:nvPr/>
         </p:nvSpPr>
         <p:spPr>
           <a:xfrm>
-            <a:off x="6126480" y="4892040"/>
-            <a:ext cx="2468880" cy="1097280"/>
+            <a:off x="9006840" y="5010912"/>
+            <a:ext cx="2148840" cy="960120"/>
           </a:xfrm>
           <a:prstGeom prst="rect">
             <a:avLst/>
@@ -3783,16 +4221,16 @@
           <a:noFill/>
         </p:spPr>
         <p:txBody>
-          <a:bodyPr wrap="square" lIns="0" tIns="0" rIns="0" bIns="0">
+          <a:bodyPr wrap="square" lIns="0" rIns="0" tIns="0" bIns="0">
             <a:spAutoFit/>
           </a:bodyPr>
           <a:lstStyle/>
           <a:p>
             <a:pPr>
               <a:spcAft>
-                <a:spcPts val="200"/>
+                <a:spcPts val="400"/>
               </a:spcAft>
-              <a:defRPr sz="1400" b="1">
+              <a:defRPr sz="1300" b="1">
                 <a:solidFill>
                   <a:srgbClr val="16161A"/>
                 </a:solidFill>
@@ -3800,12 +4238,12 @@
               </a:defRPr>
             </a:pPr>
             <a:r>
-              <a:t>Código primero.</a:t>
-            </a:r>
-          </a:p>
-          <a:p>
-            <a:pPr>
-              <a:defRPr sz="1100">
+              <a:t>Un solo equipo.</a:t>
+            </a:r>
+          </a:p>
+          <a:p>
+            <a:pPr>
+              <a:defRPr sz="1050">
                 <a:solidFill>
                   <a:srgbClr val="454337"/>
                 </a:solidFill>
@@ -3813,66 +4251,14 @@
               </a:defRPr>
             </a:pPr>
             <a:r>
-              <a:t>Software funcional antes que diapositivas.</a:t>
-            </a:r>
-          </a:p>
-        </p:txBody>
-      </p:sp>
-      <p:sp>
-        <p:nvSpPr>
-          <p:cNvPr id="19" name="TextBox 18"/>
-          <p:cNvSpPr txBox="1"/>
-          <p:nvPr/>
-        </p:nvSpPr>
-        <p:spPr>
-          <a:xfrm>
-            <a:off x="8823960" y="4892040"/>
-            <a:ext cx="2468880" cy="1097280"/>
-          </a:xfrm>
-          <a:prstGeom prst="rect">
-            <a:avLst/>
-          </a:prstGeom>
-          <a:noFill/>
-        </p:spPr>
-        <p:txBody>
-          <a:bodyPr wrap="square" lIns="0" tIns="0" rIns="0" bIns="0">
-            <a:spAutoFit/>
-          </a:bodyPr>
-          <a:lstStyle/>
-          <a:p>
-            <a:pPr>
-              <a:spcAft>
-                <a:spcPts val="200"/>
-              </a:spcAft>
-              <a:defRPr sz="1400" b="1">
-                <a:solidFill>
-                  <a:srgbClr val="16161A"/>
-                </a:solidFill>
-                <a:latin typeface="Helvetica Neue"/>
-              </a:defRPr>
-            </a:pPr>
-            <a:r>
-              <a:t>Un solo equipo.</a:t>
-            </a:r>
-          </a:p>
-          <a:p>
-            <a:pPr>
-              <a:defRPr sz="1100">
-                <a:solidFill>
-                  <a:srgbClr val="454337"/>
-                </a:solidFill>
-                <a:latin typeface="Helvetica Neue"/>
-              </a:defRPr>
-            </a:pPr>
-            <a:r>
-              <a:t>Interfaces y automatizaciones: mismo stack.</a:t>
-            </a:r>
-          </a:p>
-        </p:txBody>
-      </p:sp>
-      <p:sp>
-        <p:nvSpPr>
-          <p:cNvPr id="20" name="Rectangle 19"/>
+              <a:t>Interfaces y automatizaciones: mismo equipo.</a:t>
+            </a:r>
+          </a:p>
+        </p:txBody>
+      </p:sp>
+      <p:sp>
+        <p:nvSpPr>
+          <p:cNvPr id="27" name="Rectangle 26"/>
           <p:cNvSpPr/>
           <p:nvPr/>
         </p:nvSpPr>
@@ -3915,7 +4301,7 @@
       </p:sp>
       <p:sp>
         <p:nvSpPr>
-          <p:cNvPr id="21" name="TextBox 20"/>
+          <p:cNvPr id="28" name="TextBox 27"/>
           <p:cNvSpPr txBox="1"/>
           <p:nvPr/>
         </p:nvSpPr>
@@ -3930,7 +4316,7 @@
           <a:noFill/>
         </p:spPr>
         <p:txBody>
-          <a:bodyPr wrap="none" lIns="0" tIns="0" rIns="0" bIns="0">
+          <a:bodyPr wrap="square" lIns="0" rIns="0" tIns="0" bIns="0">
             <a:spAutoFit/>
           </a:bodyPr>
           <a:lstStyle/>
@@ -3938,7 +4324,7 @@
             <a:pPr>
               <a:defRPr sz="1000">
                 <a:solidFill>
-                  <a:srgbClr val="5F5C52"/>
+                  <a:srgbClr val="736E62"/>
                 </a:solidFill>
                 <a:latin typeface="Helvetica Neue"/>
               </a:defRPr>
@@ -3951,7 +4337,7 @@
       </p:sp>
       <p:sp>
         <p:nvSpPr>
-          <p:cNvPr id="22" name="TextBox 21"/>
+          <p:cNvPr id="29" name="TextBox 28"/>
           <p:cNvSpPr txBox="1"/>
           <p:nvPr/>
         </p:nvSpPr>
@@ -3966,7 +4352,7 @@
           <a:noFill/>
         </p:spPr>
         <p:txBody>
-          <a:bodyPr wrap="none" lIns="0" tIns="0" rIns="0" bIns="0">
+          <a:bodyPr wrap="square" lIns="0" rIns="0" tIns="0" bIns="0">
             <a:spAutoFit/>
           </a:bodyPr>
           <a:lstStyle/>
@@ -3974,7 +4360,7 @@
             <a:pPr algn="r">
               <a:defRPr sz="1000">
                 <a:solidFill>
-                  <a:srgbClr val="5F5C52"/>
+                  <a:srgbClr val="736E62"/>
                 </a:solidFill>
                 <a:latin typeface="Helvetica Neue"/>
               </a:defRPr>
@@ -4065,7 +4451,7 @@
         <p:spPr>
           <a:xfrm>
             <a:off x="731520" y="146304"/>
-            <a:ext cx="310896" cy="310896"/>
+            <a:ext cx="301752" cy="301752"/>
           </a:xfrm>
           <a:prstGeom prst="roundRect">
             <a:avLst/>
@@ -4108,7 +4494,7 @@
         <p:spPr>
           <a:xfrm>
             <a:off x="731520" y="128016"/>
-            <a:ext cx="310896" cy="310896"/>
+            <a:ext cx="301752" cy="301752"/>
           </a:xfrm>
           <a:prstGeom prst="rect">
             <a:avLst/>
@@ -4116,7 +4502,7 @@
           <a:noFill/>
         </p:spPr>
         <p:txBody>
-          <a:bodyPr wrap="none" lIns="0" tIns="0" rIns="0" bIns="0">
+          <a:bodyPr wrap="square" lIns="0" rIns="0" tIns="0" bIns="0">
             <a:spAutoFit/>
           </a:bodyPr>
           <a:lstStyle/>
@@ -4152,7 +4538,7 @@
           <a:noFill/>
         </p:spPr>
         <p:txBody>
-          <a:bodyPr wrap="none" lIns="0" tIns="0" rIns="0" bIns="0">
+          <a:bodyPr wrap="square" lIns="0" rIns="0" tIns="0" bIns="0">
             <a:spAutoFit/>
           </a:bodyPr>
           <a:lstStyle/>
@@ -4179,8 +4565,8 @@
         </p:nvSpPr>
         <p:spPr>
           <a:xfrm>
-            <a:off x="5029200" y="182880"/>
-            <a:ext cx="4754880" cy="292608"/>
+            <a:off x="4572000" y="182880"/>
+            <a:ext cx="5212080" cy="292608"/>
           </a:xfrm>
           <a:prstGeom prst="rect">
             <a:avLst/>
@@ -4188,7 +4574,7 @@
           <a:noFill/>
         </p:spPr>
         <p:txBody>
-          <a:bodyPr wrap="none" lIns="0" tIns="0" rIns="0" bIns="0">
+          <a:bodyPr wrap="square" lIns="0" rIns="0" tIns="0" bIns="0">
             <a:spAutoFit/>
           </a:bodyPr>
           <a:lstStyle/>
@@ -4196,7 +4582,7 @@
             <a:pPr algn="r">
               <a:defRPr sz="1000">
                 <a:solidFill>
-                  <a:srgbClr val="C8CDD7"/>
+                  <a:srgbClr val="BEC3CD"/>
                 </a:solidFill>
                 <a:latin typeface="Helvetica Neue"/>
               </a:defRPr>
@@ -4215,8 +4601,8 @@
         </p:nvSpPr>
         <p:spPr>
           <a:xfrm>
-            <a:off x="10058400" y="128016"/>
-            <a:ext cx="1371600" cy="329184"/>
+            <a:off x="9966960" y="128016"/>
+            <a:ext cx="1463040" cy="329184"/>
           </a:xfrm>
           <a:prstGeom prst="roundRect">
             <a:avLst/>
@@ -4258,8 +4644,8 @@
         </p:nvSpPr>
         <p:spPr>
           <a:xfrm>
-            <a:off x="10058400" y="164592"/>
-            <a:ext cx="1371600" cy="274320"/>
+            <a:off x="9966960" y="164592"/>
+            <a:ext cx="1463040" cy="274320"/>
           </a:xfrm>
           <a:prstGeom prst="rect">
             <a:avLst/>
@@ -4267,7 +4653,7 @@
           <a:noFill/>
         </p:spPr>
         <p:txBody>
-          <a:bodyPr wrap="none" lIns="0" tIns="0" rIns="0" bIns="0">
+          <a:bodyPr wrap="square" lIns="0" rIns="0" tIns="0" bIns="0">
             <a:spAutoFit/>
           </a:bodyPr>
           <a:lstStyle/>
@@ -4295,7 +4681,7 @@
         <p:spPr>
           <a:xfrm>
             <a:off x="731520" y="777240"/>
-            <a:ext cx="10728655" cy="274320"/>
+            <a:ext cx="10728655" cy="228600"/>
           </a:xfrm>
           <a:prstGeom prst="rect">
             <a:avLst/>
@@ -4303,13 +4689,13 @@
           <a:noFill/>
         </p:spPr>
         <p:txBody>
-          <a:bodyPr wrap="none" lIns="0" tIns="0" rIns="0" bIns="0">
+          <a:bodyPr wrap="square" lIns="0" rIns="0" tIns="0" bIns="0">
             <a:spAutoFit/>
           </a:bodyPr>
           <a:lstStyle/>
           <a:p>
             <a:pPr>
-              <a:defRPr sz="1100" b="1">
+              <a:defRPr sz="1000" b="1">
                 <a:solidFill>
                   <a:srgbClr val="2B59D9"/>
                 </a:solidFill>
@@ -4330,7 +4716,7 @@
         </p:nvSpPr>
         <p:spPr>
           <a:xfrm>
-            <a:off x="731520" y="1051560"/>
+            <a:off x="731520" y="1024128"/>
             <a:ext cx="10728655" cy="640080"/>
           </a:xfrm>
           <a:prstGeom prst="rect">
@@ -4339,7 +4725,7 @@
           <a:noFill/>
         </p:spPr>
         <p:txBody>
-          <a:bodyPr wrap="square" lIns="0" tIns="0" rIns="0" bIns="0">
+          <a:bodyPr wrap="square" lIns="0" rIns="0" tIns="0" bIns="0">
             <a:spAutoFit/>
           </a:bodyPr>
           <a:lstStyle/>
@@ -4411,7 +4797,7 @@
         </p:nvSpPr>
         <p:spPr>
           <a:xfrm>
-            <a:off x="1051560" y="2240279"/>
+            <a:off x="1051560" y="2194559"/>
             <a:ext cx="2688336" cy="3566160"/>
           </a:xfrm>
           <a:prstGeom prst="rect">
@@ -4420,14 +4806,14 @@
           <a:noFill/>
         </p:spPr>
         <p:txBody>
-          <a:bodyPr wrap="square">
+          <a:bodyPr wrap="square" lIns="0" rIns="0" tIns="0" bIns="0">
             <a:spAutoFit/>
           </a:bodyPr>
           <a:lstStyle/>
           <a:p>
             <a:pPr>
               <a:spcAft>
-                <a:spcPts val="1200"/>
+                <a:spcPts val="1000"/>
               </a:spcAft>
               <a:defRPr sz="2200" b="1">
                 <a:solidFill>
@@ -4438,6 +4824,22 @@
             </a:pPr>
             <a:r>
               <a:t>01</a:t>
+            </a:r>
+          </a:p>
+          <a:p>
+            <a:pPr>
+              <a:spcAft>
+                <a:spcPts val="1000"/>
+              </a:spcAft>
+              <a:defRPr sz="1800" b="1">
+                <a:solidFill>
+                  <a:srgbClr val="16161A"/>
+                </a:solidFill>
+                <a:latin typeface="Helvetica Neue"/>
+              </a:defRPr>
+            </a:pPr>
+            <a:r>
+              <a:t>Interfaces Personalizadas</a:t>
             </a:r>
           </a:p>
           <a:p>
@@ -4445,7 +4847,23 @@
               <a:spcAft>
                 <a:spcPts val="1400"/>
               </a:spcAft>
-              <a:defRPr sz="1900" b="1">
+              <a:defRPr sz="1200">
+                <a:solidFill>
+                  <a:srgbClr val="454337"/>
+                </a:solidFill>
+                <a:latin typeface="Helvetica Neue"/>
+              </a:defRPr>
+            </a:pPr>
+            <a:r>
+              <a:t>Aplicaciones web en React de alto rendimiento, diseñadas para la velocidad e intuición de tu equipo.</a:t>
+            </a:r>
+          </a:p>
+          <a:p>
+            <a:pPr>
+              <a:spcAft>
+                <a:spcPts val="600"/>
+              </a:spcAft>
+              <a:defRPr sz="1100">
                 <a:solidFill>
                   <a:srgbClr val="16161A"/>
                 </a:solidFill>
@@ -4453,20 +4871,39 @@
               </a:defRPr>
             </a:pPr>
             <a:r>
-              <a:t>Interfaces Personalizadas</a:t>
-            </a:r>
-          </a:p>
-          <a:p>
-            <a:pPr>
-              <a:defRPr sz="1300">
-                <a:solidFill>
-                  <a:srgbClr val="454337"/>
-                </a:solidFill>
-                <a:latin typeface="Helvetica Neue"/>
-              </a:defRPr>
-            </a:pPr>
-            <a:r>
-              <a:t>Interfaces web en React de alto rendimiento, diseñadas para la velocidad e intuición de tu equipo en sus tareas diarias.</a:t>
+              <a:t>•  Desarrollo web en React y TypeScript</a:t>
+            </a:r>
+          </a:p>
+          <a:p>
+            <a:pPr>
+              <a:spcAft>
+                <a:spcPts val="600"/>
+              </a:spcAft>
+              <a:defRPr sz="1100">
+                <a:solidFill>
+                  <a:srgbClr val="16161A"/>
+                </a:solidFill>
+                <a:latin typeface="Helvetica Neue"/>
+              </a:defRPr>
+            </a:pPr>
+            <a:r>
+              <a:t>•  Diseño UX accesible y responsivo</a:t>
+            </a:r>
+          </a:p>
+          <a:p>
+            <a:pPr>
+              <a:spcAft>
+                <a:spcPts val="600"/>
+              </a:spcAft>
+              <a:defRPr sz="1100">
+                <a:solidFill>
+                  <a:srgbClr val="16161A"/>
+                </a:solidFill>
+                <a:latin typeface="Helvetica Neue"/>
+              </a:defRPr>
+            </a:pPr>
+            <a:r>
+              <a:t>•  Flujos directos de pedidos y pagos</a:t>
             </a:r>
           </a:p>
         </p:txBody>
@@ -4524,7 +4961,7 @@
         </p:nvSpPr>
         <p:spPr>
           <a:xfrm>
-            <a:off x="4654296" y="2240279"/>
+            <a:off x="4654296" y="2194559"/>
             <a:ext cx="2688336" cy="3566160"/>
           </a:xfrm>
           <a:prstGeom prst="rect">
@@ -4533,14 +4970,14 @@
           <a:noFill/>
         </p:spPr>
         <p:txBody>
-          <a:bodyPr wrap="square">
+          <a:bodyPr wrap="square" lIns="0" rIns="0" tIns="0" bIns="0">
             <a:spAutoFit/>
           </a:bodyPr>
           <a:lstStyle/>
           <a:p>
             <a:pPr>
               <a:spcAft>
-                <a:spcPts val="1200"/>
+                <a:spcPts val="1000"/>
               </a:spcAft>
               <a:defRPr sz="2200" b="1">
                 <a:solidFill>
@@ -4551,6 +4988,22 @@
             </a:pPr>
             <a:r>
               <a:t>02</a:t>
+            </a:r>
+          </a:p>
+          <a:p>
+            <a:pPr>
+              <a:spcAft>
+                <a:spcPts val="1000"/>
+              </a:spcAft>
+              <a:defRPr sz="1800" b="1">
+                <a:solidFill>
+                  <a:srgbClr val="16161A"/>
+                </a:solidFill>
+                <a:latin typeface="Helvetica Neue"/>
+              </a:defRPr>
+            </a:pPr>
+            <a:r>
+              <a:t>Integración de Sistemas</a:t>
             </a:r>
           </a:p>
           <a:p>
@@ -4558,7 +5011,23 @@
               <a:spcAft>
                 <a:spcPts val="1400"/>
               </a:spcAft>
-              <a:defRPr sz="1900" b="1">
+              <a:defRPr sz="1200">
+                <a:solidFill>
+                  <a:srgbClr val="454337"/>
+                </a:solidFill>
+                <a:latin typeface="Helvetica Neue"/>
+              </a:defRPr>
+            </a:pPr>
+            <a:r>
+              <a:t>Integraciones financieras avanzadas, arquitectura de bases de datos y APIs empresariales.</a:t>
+            </a:r>
+          </a:p>
+          <a:p>
+            <a:pPr>
+              <a:spcAft>
+                <a:spcPts val="600"/>
+              </a:spcAft>
+              <a:defRPr sz="1100">
                 <a:solidFill>
                   <a:srgbClr val="16161A"/>
                 </a:solidFill>
@@ -4566,20 +5035,39 @@
               </a:defRPr>
             </a:pPr>
             <a:r>
-              <a:t>Integración de Sistemas</a:t>
-            </a:r>
-          </a:p>
-          <a:p>
-            <a:pPr>
-              <a:defRPr sz="1300">
-                <a:solidFill>
-                  <a:srgbClr val="454337"/>
-                </a:solidFill>
-                <a:latin typeface="Helvetica Neue"/>
-              </a:defRPr>
-            </a:pPr>
-            <a:r>
-              <a:t>Integraciones financieras avanzadas (Workday Finance y Adaptive Planning), bases de datos PostgreSQL y APIs empresariales.</a:t>
+              <a:t>•  Workday Finance y Adaptive Planning</a:t>
+            </a:r>
+          </a:p>
+          <a:p>
+            <a:pPr>
+              <a:spcAft>
+                <a:spcPts val="600"/>
+              </a:spcAft>
+              <a:defRPr sz="1100">
+                <a:solidFill>
+                  <a:srgbClr val="16161A"/>
+                </a:solidFill>
+                <a:latin typeface="Helvetica Neue"/>
+              </a:defRPr>
+            </a:pPr>
+            <a:r>
+              <a:t>•  Arquitectura en PostgreSQL</a:t>
+            </a:r>
+          </a:p>
+          <a:p>
+            <a:pPr>
+              <a:spcAft>
+                <a:spcPts val="600"/>
+              </a:spcAft>
+              <a:defRPr sz="1100">
+                <a:solidFill>
+                  <a:srgbClr val="16161A"/>
+                </a:solidFill>
+                <a:latin typeface="Helvetica Neue"/>
+              </a:defRPr>
+            </a:pPr>
+            <a:r>
+              <a:t>•  Pipelines de APIs REST y GraphQL</a:t>
             </a:r>
           </a:p>
         </p:txBody>
@@ -4637,7 +5125,7 @@
         </p:nvSpPr>
         <p:spPr>
           <a:xfrm>
-            <a:off x="8257032" y="2240279"/>
+            <a:off x="8257032" y="2194559"/>
             <a:ext cx="2688336" cy="3566160"/>
           </a:xfrm>
           <a:prstGeom prst="rect">
@@ -4646,14 +5134,14 @@
           <a:noFill/>
         </p:spPr>
         <p:txBody>
-          <a:bodyPr wrap="square">
+          <a:bodyPr wrap="square" lIns="0" rIns="0" tIns="0" bIns="0">
             <a:spAutoFit/>
           </a:bodyPr>
           <a:lstStyle/>
           <a:p>
             <a:pPr>
               <a:spcAft>
-                <a:spcPts val="1200"/>
+                <a:spcPts val="1000"/>
               </a:spcAft>
               <a:defRPr sz="2200" b="1">
                 <a:solidFill>
@@ -4664,6 +5152,22 @@
             </a:pPr>
             <a:r>
               <a:t>03</a:t>
+            </a:r>
+          </a:p>
+          <a:p>
+            <a:pPr>
+              <a:spcAft>
+                <a:spcPts val="1000"/>
+              </a:spcAft>
+              <a:defRPr sz="1800" b="1">
+                <a:solidFill>
+                  <a:srgbClr val="16161A"/>
+                </a:solidFill>
+                <a:latin typeface="Helvetica Neue"/>
+              </a:defRPr>
+            </a:pPr>
+            <a:r>
+              <a:t>IA Aplicada y Automatización</a:t>
             </a:r>
           </a:p>
           <a:p>
@@ -4671,7 +5175,23 @@
               <a:spcAft>
                 <a:spcPts val="1400"/>
               </a:spcAft>
-              <a:defRPr sz="1900" b="1">
+              <a:defRPr sz="1200">
+                <a:solidFill>
+                  <a:srgbClr val="454337"/>
+                </a:solidFill>
+                <a:latin typeface="Helvetica Neue"/>
+              </a:defRPr>
+            </a:pPr>
+            <a:r>
+              <a:t>Servidores MCP personalizados y agentes de IA con supervisión humana.</a:t>
+            </a:r>
+          </a:p>
+          <a:p>
+            <a:pPr>
+              <a:spcAft>
+                <a:spcPts val="600"/>
+              </a:spcAft>
+              <a:defRPr sz="1100">
                 <a:solidFill>
                   <a:srgbClr val="16161A"/>
                 </a:solidFill>
@@ -4679,20 +5199,39 @@
               </a:defRPr>
             </a:pPr>
             <a:r>
-              <a:t>IA Aplicada y Automatización</a:t>
-            </a:r>
-          </a:p>
-          <a:p>
-            <a:pPr>
-              <a:defRPr sz="1300">
-                <a:solidFill>
-                  <a:srgbClr val="454337"/>
-                </a:solidFill>
-                <a:latin typeface="Helvetica Neue"/>
-              </a:defRPr>
-            </a:pPr>
-            <a:r>
-              <a:t>Servidores MCP personalizados, flujos con LLMs y agentes de IA con supervisión humana (HITL) para absoluta seguridad operativa.</a:t>
+              <a:t>•  Despliegue de servidores MCP</a:t>
+            </a:r>
+          </a:p>
+          <a:p>
+            <a:pPr>
+              <a:spcAft>
+                <a:spcPts val="600"/>
+              </a:spcAft>
+              <a:defRPr sz="1100">
+                <a:solidFill>
+                  <a:srgbClr val="16161A"/>
+                </a:solidFill>
+                <a:latin typeface="Helvetica Neue"/>
+              </a:defRPr>
+            </a:pPr>
+            <a:r>
+              <a:t>•  Orquestación de LLMs y extracción</a:t>
+            </a:r>
+          </a:p>
+          <a:p>
+            <a:pPr>
+              <a:spcAft>
+                <a:spcPts val="600"/>
+              </a:spcAft>
+              <a:defRPr sz="1100">
+                <a:solidFill>
+                  <a:srgbClr val="16161A"/>
+                </a:solidFill>
+                <a:latin typeface="Helvetica Neue"/>
+              </a:defRPr>
+            </a:pPr>
+            <a:r>
+              <a:t>•  Controles de seguridad humana (HITL)</a:t>
             </a:r>
           </a:p>
         </p:txBody>
@@ -4757,7 +5296,7 @@
           <a:noFill/>
         </p:spPr>
         <p:txBody>
-          <a:bodyPr wrap="none" lIns="0" tIns="0" rIns="0" bIns="0">
+          <a:bodyPr wrap="square" lIns="0" rIns="0" tIns="0" bIns="0">
             <a:spAutoFit/>
           </a:bodyPr>
           <a:lstStyle/>
@@ -4765,7 +5304,7 @@
             <a:pPr>
               <a:defRPr sz="1000">
                 <a:solidFill>
-                  <a:srgbClr val="5F5C52"/>
+                  <a:srgbClr val="736E62"/>
                 </a:solidFill>
                 <a:latin typeface="Helvetica Neue"/>
               </a:defRPr>
@@ -4793,7 +5332,7 @@
           <a:noFill/>
         </p:spPr>
         <p:txBody>
-          <a:bodyPr wrap="none" lIns="0" tIns="0" rIns="0" bIns="0">
+          <a:bodyPr wrap="square" lIns="0" rIns="0" tIns="0" bIns="0">
             <a:spAutoFit/>
           </a:bodyPr>
           <a:lstStyle/>
@@ -4801,7 +5340,7 @@
             <a:pPr algn="r">
               <a:defRPr sz="1000">
                 <a:solidFill>
-                  <a:srgbClr val="5F5C52"/>
+                  <a:srgbClr val="736E62"/>
                 </a:solidFill>
                 <a:latin typeface="Helvetica Neue"/>
               </a:defRPr>
@@ -4892,7 +5431,7 @@
         <p:spPr>
           <a:xfrm>
             <a:off x="731520" y="146304"/>
-            <a:ext cx="310896" cy="310896"/>
+            <a:ext cx="301752" cy="301752"/>
           </a:xfrm>
           <a:prstGeom prst="roundRect">
             <a:avLst/>
@@ -4935,7 +5474,7 @@
         <p:spPr>
           <a:xfrm>
             <a:off x="731520" y="128016"/>
-            <a:ext cx="310896" cy="310896"/>
+            <a:ext cx="301752" cy="301752"/>
           </a:xfrm>
           <a:prstGeom prst="rect">
             <a:avLst/>
@@ -4943,7 +5482,7 @@
           <a:noFill/>
         </p:spPr>
         <p:txBody>
-          <a:bodyPr wrap="none" lIns="0" tIns="0" rIns="0" bIns="0">
+          <a:bodyPr wrap="square" lIns="0" rIns="0" tIns="0" bIns="0">
             <a:spAutoFit/>
           </a:bodyPr>
           <a:lstStyle/>
@@ -4979,7 +5518,7 @@
           <a:noFill/>
         </p:spPr>
         <p:txBody>
-          <a:bodyPr wrap="none" lIns="0" tIns="0" rIns="0" bIns="0">
+          <a:bodyPr wrap="square" lIns="0" rIns="0" tIns="0" bIns="0">
             <a:spAutoFit/>
           </a:bodyPr>
           <a:lstStyle/>
@@ -5006,8 +5545,8 @@
         </p:nvSpPr>
         <p:spPr>
           <a:xfrm>
-            <a:off x="5029200" y="182880"/>
-            <a:ext cx="4754880" cy="292608"/>
+            <a:off x="4572000" y="182880"/>
+            <a:ext cx="5212080" cy="292608"/>
           </a:xfrm>
           <a:prstGeom prst="rect">
             <a:avLst/>
@@ -5015,7 +5554,7 @@
           <a:noFill/>
         </p:spPr>
         <p:txBody>
-          <a:bodyPr wrap="none" lIns="0" tIns="0" rIns="0" bIns="0">
+          <a:bodyPr wrap="square" lIns="0" rIns="0" tIns="0" bIns="0">
             <a:spAutoFit/>
           </a:bodyPr>
           <a:lstStyle/>
@@ -5023,7 +5562,7 @@
             <a:pPr algn="r">
               <a:defRPr sz="1000">
                 <a:solidFill>
-                  <a:srgbClr val="C8CDD7"/>
+                  <a:srgbClr val="BEC3CD"/>
                 </a:solidFill>
                 <a:latin typeface="Helvetica Neue"/>
               </a:defRPr>
@@ -5042,8 +5581,8 @@
         </p:nvSpPr>
         <p:spPr>
           <a:xfrm>
-            <a:off x="10058400" y="128016"/>
-            <a:ext cx="1371600" cy="329184"/>
+            <a:off x="9966960" y="128016"/>
+            <a:ext cx="1463040" cy="329184"/>
           </a:xfrm>
           <a:prstGeom prst="roundRect">
             <a:avLst/>
@@ -5085,8 +5624,8 @@
         </p:nvSpPr>
         <p:spPr>
           <a:xfrm>
-            <a:off x="10058400" y="164592"/>
-            <a:ext cx="1371600" cy="274320"/>
+            <a:off x="9966960" y="164592"/>
+            <a:ext cx="1463040" cy="274320"/>
           </a:xfrm>
           <a:prstGeom prst="rect">
             <a:avLst/>
@@ -5094,7 +5633,7 @@
           <a:noFill/>
         </p:spPr>
         <p:txBody>
-          <a:bodyPr wrap="none" lIns="0" tIns="0" rIns="0" bIns="0">
+          <a:bodyPr wrap="square" lIns="0" rIns="0" tIns="0" bIns="0">
             <a:spAutoFit/>
           </a:bodyPr>
           <a:lstStyle/>
@@ -5122,7 +5661,7 @@
         <p:spPr>
           <a:xfrm>
             <a:off x="731520" y="777240"/>
-            <a:ext cx="10728655" cy="274320"/>
+            <a:ext cx="10728655" cy="228600"/>
           </a:xfrm>
           <a:prstGeom prst="rect">
             <a:avLst/>
@@ -5130,13 +5669,13 @@
           <a:noFill/>
         </p:spPr>
         <p:txBody>
-          <a:bodyPr wrap="none" lIns="0" tIns="0" rIns="0" bIns="0">
+          <a:bodyPr wrap="square" lIns="0" rIns="0" tIns="0" bIns="0">
             <a:spAutoFit/>
           </a:bodyPr>
           <a:lstStyle/>
           <a:p>
             <a:pPr>
-              <a:defRPr sz="1100" b="1">
+              <a:defRPr sz="1000" b="1">
                 <a:solidFill>
                   <a:srgbClr val="2B59D9"/>
                 </a:solidFill>
@@ -5157,7 +5696,7 @@
         </p:nvSpPr>
         <p:spPr>
           <a:xfrm>
-            <a:off x="731520" y="1051560"/>
+            <a:off x="731520" y="1024128"/>
             <a:ext cx="10728655" cy="640080"/>
           </a:xfrm>
           <a:prstGeom prst="rect">
@@ -5166,7 +5705,7 @@
           <a:noFill/>
         </p:spPr>
         <p:txBody>
-          <a:bodyPr wrap="square" lIns="0" tIns="0" rIns="0" bIns="0">
+          <a:bodyPr wrap="square" lIns="0" rIns="0" tIns="0" bIns="0">
             <a:spAutoFit/>
           </a:bodyPr>
           <a:lstStyle/>
@@ -5238,8 +5777,8 @@
         </p:nvSpPr>
         <p:spPr>
           <a:xfrm>
-            <a:off x="1005840" y="2194559"/>
-            <a:ext cx="4608576" cy="3566160"/>
+            <a:off x="1051560" y="2194559"/>
+            <a:ext cx="4517136" cy="3566160"/>
           </a:xfrm>
           <a:prstGeom prst="rect">
             <a:avLst/>
@@ -5247,7 +5786,7 @@
           <a:noFill/>
         </p:spPr>
         <p:txBody>
-          <a:bodyPr wrap="square">
+          <a:bodyPr wrap="square" lIns="0" rIns="0" tIns="0" bIns="0">
             <a:spAutoFit/>
           </a:bodyPr>
           <a:lstStyle/>
@@ -5272,7 +5811,7 @@
               <a:spcAft>
                 <a:spcPts val="1000"/>
               </a:spcAft>
-              <a:defRPr b="1" sz="1300">
+              <a:defRPr b="1" sz="1250">
                 <a:solidFill>
                   <a:srgbClr val="16161A"/>
                 </a:solidFill>
@@ -5280,7 +5819,7 @@
               </a:defRPr>
             </a:pPr>
             <a:r>
-              <a:t>• Empresas Medianas (Mid-Market): </a:t>
+              <a:t>•  Empresas Medianas (Mid-Market): </a:t>
             </a:r>
             <a:r>
               <a:rPr b="0">
@@ -5296,7 +5835,7 @@
               <a:spcAft>
                 <a:spcPts val="1000"/>
               </a:spcAft>
-              <a:defRPr b="1" sz="1300">
+              <a:defRPr b="1" sz="1250">
                 <a:solidFill>
                   <a:srgbClr val="16161A"/>
                 </a:solidFill>
@@ -5304,7 +5843,7 @@
               </a:defRPr>
             </a:pPr>
             <a:r>
-              <a:t>• PyMEs en Aceleración: </a:t>
+              <a:t>•  PyMEs en Aceleración: </a:t>
             </a:r>
             <a:r>
               <a:rPr b="0">
@@ -5320,7 +5859,7 @@
               <a:spcAft>
                 <a:spcPts val="1000"/>
               </a:spcAft>
-              <a:defRPr b="1" sz="1300">
+              <a:defRPr b="1" sz="1250">
                 <a:solidFill>
                   <a:srgbClr val="16161A"/>
                 </a:solidFill>
@@ -5328,7 +5867,7 @@
               </a:defRPr>
             </a:pPr>
             <a:r>
-              <a:t>• Startups con VC: </a:t>
+              <a:t>•  Startups con VC: </a:t>
             </a:r>
             <a:r>
               <a:rPr b="0">
@@ -5344,7 +5883,7 @@
               <a:spcAft>
                 <a:spcPts val="1000"/>
               </a:spcAft>
-              <a:defRPr b="1" sz="1300">
+              <a:defRPr b="1" sz="1250">
                 <a:solidFill>
                   <a:srgbClr val="16161A"/>
                 </a:solidFill>
@@ -5352,7 +5891,7 @@
               </a:defRPr>
             </a:pPr>
             <a:r>
-              <a:t>• Portafolio de PE / VC: </a:t>
+              <a:t>•  Portafolio de PE / VC: </a:t>
             </a:r>
             <a:r>
               <a:rPr b="0">
@@ -5418,8 +5957,8 @@
         </p:nvSpPr>
         <p:spPr>
           <a:xfrm>
-            <a:off x="6574536" y="2194559"/>
-            <a:ext cx="4608576" cy="3566160"/>
+            <a:off x="6620256" y="2194559"/>
+            <a:ext cx="4517136" cy="3566160"/>
           </a:xfrm>
           <a:prstGeom prst="rect">
             <a:avLst/>
@@ -5427,7 +5966,7 @@
           <a:noFill/>
         </p:spPr>
         <p:txBody>
-          <a:bodyPr wrap="square">
+          <a:bodyPr wrap="square" lIns="0" rIns="0" tIns="0" bIns="0">
             <a:spAutoFit/>
           </a:bodyPr>
           <a:lstStyle/>
@@ -5452,7 +5991,7 @@
               <a:spcAft>
                 <a:spcPts val="1000"/>
               </a:spcAft>
-              <a:defRPr b="1" sz="1300">
+              <a:defRPr b="1" sz="1250">
                 <a:solidFill>
                   <a:srgbClr val="16161A"/>
                 </a:solidFill>
@@ -5460,7 +5999,7 @@
               </a:defRPr>
             </a:pPr>
             <a:r>
-              <a:t>• CTOs y VPs de Ingeniería: </a:t>
+              <a:t>•  CTOs y VPs de Ingeniería: </a:t>
             </a:r>
             <a:r>
               <a:rPr b="0">
@@ -5476,7 +6015,7 @@
               <a:spcAft>
                 <a:spcPts val="1000"/>
               </a:spcAft>
-              <a:defRPr b="1" sz="1300">
+              <a:defRPr b="1" sz="1250">
                 <a:solidFill>
                   <a:srgbClr val="16161A"/>
                 </a:solidFill>
@@ -5484,7 +6023,7 @@
               </a:defRPr>
             </a:pPr>
             <a:r>
-              <a:t>• CFOs y Directores de Finanzas: </a:t>
+              <a:t>•  CFOs y Directores de Finanzas: </a:t>
             </a:r>
             <a:r>
               <a:rPr b="0">
@@ -5500,7 +6039,7 @@
               <a:spcAft>
                 <a:spcPts val="1000"/>
               </a:spcAft>
-              <a:defRPr b="1" sz="1300">
+              <a:defRPr b="1" sz="1250">
                 <a:solidFill>
                   <a:srgbClr val="16161A"/>
                 </a:solidFill>
@@ -5508,7 +6047,7 @@
               </a:defRPr>
             </a:pPr>
             <a:r>
-              <a:t>• VPs de Operaciones: </a:t>
+              <a:t>•  VPs de Operaciones: </a:t>
             </a:r>
             <a:r>
               <a:rPr b="0">
@@ -5524,7 +6063,7 @@
               <a:spcAft>
                 <a:spcPts val="1000"/>
               </a:spcAft>
-              <a:defRPr b="1" sz="1300">
+              <a:defRPr b="1" sz="1250">
                 <a:solidFill>
                   <a:srgbClr val="16161A"/>
                 </a:solidFill>
@@ -5532,7 +6071,7 @@
               </a:defRPr>
             </a:pPr>
             <a:r>
-              <a:t>• Fundadores y Líderes de Producto: </a:t>
+              <a:t>•  Fundadores y Líderes de Producto: </a:t>
             </a:r>
             <a:r>
               <a:rPr b="0">
@@ -5605,7 +6144,7 @@
           <a:noFill/>
         </p:spPr>
         <p:txBody>
-          <a:bodyPr wrap="none" lIns="0" tIns="0" rIns="0" bIns="0">
+          <a:bodyPr wrap="square" lIns="0" rIns="0" tIns="0" bIns="0">
             <a:spAutoFit/>
           </a:bodyPr>
           <a:lstStyle/>
@@ -5613,7 +6152,7 @@
             <a:pPr>
               <a:defRPr sz="1000">
                 <a:solidFill>
-                  <a:srgbClr val="5F5C52"/>
+                  <a:srgbClr val="736E62"/>
                 </a:solidFill>
                 <a:latin typeface="Helvetica Neue"/>
               </a:defRPr>
@@ -5641,7 +6180,7 @@
           <a:noFill/>
         </p:spPr>
         <p:txBody>
-          <a:bodyPr wrap="none" lIns="0" tIns="0" rIns="0" bIns="0">
+          <a:bodyPr wrap="square" lIns="0" rIns="0" tIns="0" bIns="0">
             <a:spAutoFit/>
           </a:bodyPr>
           <a:lstStyle/>
@@ -5649,7 +6188,7 @@
             <a:pPr algn="r">
               <a:defRPr sz="1000">
                 <a:solidFill>
-                  <a:srgbClr val="5F5C52"/>
+                  <a:srgbClr val="736E62"/>
                 </a:solidFill>
                 <a:latin typeface="Helvetica Neue"/>
               </a:defRPr>
@@ -5740,7 +6279,7 @@
         <p:spPr>
           <a:xfrm>
             <a:off x="731520" y="146304"/>
-            <a:ext cx="310896" cy="310896"/>
+            <a:ext cx="301752" cy="301752"/>
           </a:xfrm>
           <a:prstGeom prst="roundRect">
             <a:avLst/>
@@ -5783,7 +6322,7 @@
         <p:spPr>
           <a:xfrm>
             <a:off x="731520" y="128016"/>
-            <a:ext cx="310896" cy="310896"/>
+            <a:ext cx="301752" cy="301752"/>
           </a:xfrm>
           <a:prstGeom prst="rect">
             <a:avLst/>
@@ -5791,7 +6330,7 @@
           <a:noFill/>
         </p:spPr>
         <p:txBody>
-          <a:bodyPr wrap="none" lIns="0" tIns="0" rIns="0" bIns="0">
+          <a:bodyPr wrap="square" lIns="0" rIns="0" tIns="0" bIns="0">
             <a:spAutoFit/>
           </a:bodyPr>
           <a:lstStyle/>
@@ -5827,7 +6366,7 @@
           <a:noFill/>
         </p:spPr>
         <p:txBody>
-          <a:bodyPr wrap="none" lIns="0" tIns="0" rIns="0" bIns="0">
+          <a:bodyPr wrap="square" lIns="0" rIns="0" tIns="0" bIns="0">
             <a:spAutoFit/>
           </a:bodyPr>
           <a:lstStyle/>
@@ -5854,8 +6393,8 @@
         </p:nvSpPr>
         <p:spPr>
           <a:xfrm>
-            <a:off x="5029200" y="182880"/>
-            <a:ext cx="4754880" cy="292608"/>
+            <a:off x="4572000" y="182880"/>
+            <a:ext cx="5212080" cy="292608"/>
           </a:xfrm>
           <a:prstGeom prst="rect">
             <a:avLst/>
@@ -5863,7 +6402,7 @@
           <a:noFill/>
         </p:spPr>
         <p:txBody>
-          <a:bodyPr wrap="none" lIns="0" tIns="0" rIns="0" bIns="0">
+          <a:bodyPr wrap="square" lIns="0" rIns="0" tIns="0" bIns="0">
             <a:spAutoFit/>
           </a:bodyPr>
           <a:lstStyle/>
@@ -5871,7 +6410,7 @@
             <a:pPr algn="r">
               <a:defRPr sz="1000">
                 <a:solidFill>
-                  <a:srgbClr val="C8CDD7"/>
+                  <a:srgbClr val="BEC3CD"/>
                 </a:solidFill>
                 <a:latin typeface="Helvetica Neue"/>
               </a:defRPr>
@@ -5890,8 +6429,8 @@
         </p:nvSpPr>
         <p:spPr>
           <a:xfrm>
-            <a:off x="10058400" y="128016"/>
-            <a:ext cx="1371600" cy="329184"/>
+            <a:off x="9966960" y="128016"/>
+            <a:ext cx="1463040" cy="329184"/>
           </a:xfrm>
           <a:prstGeom prst="roundRect">
             <a:avLst/>
@@ -5933,8 +6472,8 @@
         </p:nvSpPr>
         <p:spPr>
           <a:xfrm>
-            <a:off x="10058400" y="164592"/>
-            <a:ext cx="1371600" cy="274320"/>
+            <a:off x="9966960" y="164592"/>
+            <a:ext cx="1463040" cy="274320"/>
           </a:xfrm>
           <a:prstGeom prst="rect">
             <a:avLst/>
@@ -5942,7 +6481,7 @@
           <a:noFill/>
         </p:spPr>
         <p:txBody>
-          <a:bodyPr wrap="none" lIns="0" tIns="0" rIns="0" bIns="0">
+          <a:bodyPr wrap="square" lIns="0" rIns="0" tIns="0" bIns="0">
             <a:spAutoFit/>
           </a:bodyPr>
           <a:lstStyle/>
@@ -5970,7 +6509,7 @@
         <p:spPr>
           <a:xfrm>
             <a:off x="731520" y="777240"/>
-            <a:ext cx="10728655" cy="274320"/>
+            <a:ext cx="10728655" cy="228600"/>
           </a:xfrm>
           <a:prstGeom prst="rect">
             <a:avLst/>
@@ -5978,13 +6517,13 @@
           <a:noFill/>
         </p:spPr>
         <p:txBody>
-          <a:bodyPr wrap="none" lIns="0" tIns="0" rIns="0" bIns="0">
+          <a:bodyPr wrap="square" lIns="0" rIns="0" tIns="0" bIns="0">
             <a:spAutoFit/>
           </a:bodyPr>
           <a:lstStyle/>
           <a:p>
             <a:pPr>
-              <a:defRPr sz="1100" b="1">
+              <a:defRPr sz="1000" b="1">
                 <a:solidFill>
                   <a:srgbClr val="2B59D9"/>
                 </a:solidFill>
@@ -6005,7 +6544,7 @@
         </p:nvSpPr>
         <p:spPr>
           <a:xfrm>
-            <a:off x="731520" y="1051560"/>
+            <a:off x="731520" y="1024128"/>
             <a:ext cx="10728655" cy="640080"/>
           </a:xfrm>
           <a:prstGeom prst="rect">
@@ -6014,7 +6553,7 @@
           <a:noFill/>
         </p:spPr>
         <p:txBody>
-          <a:bodyPr wrap="square" lIns="0" tIns="0" rIns="0" bIns="0">
+          <a:bodyPr wrap="square" lIns="0" rIns="0" tIns="0" bIns="0">
             <a:spAutoFit/>
           </a:bodyPr>
           <a:lstStyle/>
@@ -6086,8 +6625,8 @@
         </p:nvSpPr>
         <p:spPr>
           <a:xfrm>
-            <a:off x="1005840" y="2011679"/>
-            <a:ext cx="10180015" cy="1005840"/>
+            <a:off x="1051560" y="2039111"/>
+            <a:ext cx="10058400" cy="914400"/>
           </a:xfrm>
           <a:prstGeom prst="rect">
             <a:avLst/>
@@ -6095,7 +6634,7 @@
           <a:noFill/>
         </p:spPr>
         <p:txBody>
-          <a:bodyPr wrap="square">
+          <a:bodyPr wrap="square" lIns="0" rIns="0" tIns="0" bIns="0">
             <a:spAutoFit/>
           </a:bodyPr>
           <a:lstStyle/>
@@ -6117,7 +6656,7 @@
           </a:p>
           <a:p>
             <a:pPr>
-              <a:defRPr sz="1400">
+              <a:defRPr sz="1350">
                 <a:solidFill>
                   <a:srgbClr val="16161A"/>
                 </a:solidFill>
@@ -6183,8 +6722,8 @@
         </p:nvSpPr>
         <p:spPr>
           <a:xfrm>
-            <a:off x="1005840" y="3428999"/>
-            <a:ext cx="10180015" cy="1005840"/>
+            <a:off x="1051560" y="3456431"/>
+            <a:ext cx="10058400" cy="914400"/>
           </a:xfrm>
           <a:prstGeom prst="rect">
             <a:avLst/>
@@ -6192,7 +6731,7 @@
           <a:noFill/>
         </p:spPr>
         <p:txBody>
-          <a:bodyPr wrap="square">
+          <a:bodyPr wrap="square" lIns="0" rIns="0" tIns="0" bIns="0">
             <a:spAutoFit/>
           </a:bodyPr>
           <a:lstStyle/>
@@ -6214,7 +6753,7 @@
           </a:p>
           <a:p>
             <a:pPr>
-              <a:defRPr sz="1400">
+              <a:defRPr sz="1350">
                 <a:solidFill>
                   <a:srgbClr val="16161A"/>
                 </a:solidFill>
@@ -6280,8 +6819,8 @@
         </p:nvSpPr>
         <p:spPr>
           <a:xfrm>
-            <a:off x="1005840" y="4846320"/>
-            <a:ext cx="10180015" cy="1005840"/>
+            <a:off x="1051560" y="4873752"/>
+            <a:ext cx="10058400" cy="914400"/>
           </a:xfrm>
           <a:prstGeom prst="rect">
             <a:avLst/>
@@ -6289,7 +6828,7 @@
           <a:noFill/>
         </p:spPr>
         <p:txBody>
-          <a:bodyPr wrap="square">
+          <a:bodyPr wrap="square" lIns="0" rIns="0" tIns="0" bIns="0">
             <a:spAutoFit/>
           </a:bodyPr>
           <a:lstStyle/>
@@ -6311,7 +6850,7 @@
           </a:p>
           <a:p>
             <a:pPr>
-              <a:defRPr sz="1400">
+              <a:defRPr sz="1350">
                 <a:solidFill>
                   <a:srgbClr val="16161A"/>
                 </a:solidFill>
@@ -6384,7 +6923,7 @@
           <a:noFill/>
         </p:spPr>
         <p:txBody>
-          <a:bodyPr wrap="none" lIns="0" tIns="0" rIns="0" bIns="0">
+          <a:bodyPr wrap="square" lIns="0" rIns="0" tIns="0" bIns="0">
             <a:spAutoFit/>
           </a:bodyPr>
           <a:lstStyle/>
@@ -6392,7 +6931,7 @@
             <a:pPr>
               <a:defRPr sz="1000">
                 <a:solidFill>
-                  <a:srgbClr val="5F5C52"/>
+                  <a:srgbClr val="736E62"/>
                 </a:solidFill>
                 <a:latin typeface="Helvetica Neue"/>
               </a:defRPr>
@@ -6420,7 +6959,7 @@
           <a:noFill/>
         </p:spPr>
         <p:txBody>
-          <a:bodyPr wrap="none" lIns="0" tIns="0" rIns="0" bIns="0">
+          <a:bodyPr wrap="square" lIns="0" rIns="0" tIns="0" bIns="0">
             <a:spAutoFit/>
           </a:bodyPr>
           <a:lstStyle/>
@@ -6428,7 +6967,7 @@
             <a:pPr algn="r">
               <a:defRPr sz="1000">
                 <a:solidFill>
-                  <a:srgbClr val="5F5C52"/>
+                  <a:srgbClr val="736E62"/>
                 </a:solidFill>
                 <a:latin typeface="Helvetica Neue"/>
               </a:defRPr>
@@ -6519,7 +7058,7 @@
         <p:spPr>
           <a:xfrm>
             <a:off x="731520" y="146304"/>
-            <a:ext cx="310896" cy="310896"/>
+            <a:ext cx="301752" cy="301752"/>
           </a:xfrm>
           <a:prstGeom prst="roundRect">
             <a:avLst/>
@@ -6562,7 +7101,7 @@
         <p:spPr>
           <a:xfrm>
             <a:off x="731520" y="128016"/>
-            <a:ext cx="310896" cy="310896"/>
+            <a:ext cx="301752" cy="301752"/>
           </a:xfrm>
           <a:prstGeom prst="rect">
             <a:avLst/>
@@ -6570,7 +7109,7 @@
           <a:noFill/>
         </p:spPr>
         <p:txBody>
-          <a:bodyPr wrap="none" lIns="0" tIns="0" rIns="0" bIns="0">
+          <a:bodyPr wrap="square" lIns="0" rIns="0" tIns="0" bIns="0">
             <a:spAutoFit/>
           </a:bodyPr>
           <a:lstStyle/>
@@ -6606,7 +7145,7 @@
           <a:noFill/>
         </p:spPr>
         <p:txBody>
-          <a:bodyPr wrap="none" lIns="0" tIns="0" rIns="0" bIns="0">
+          <a:bodyPr wrap="square" lIns="0" rIns="0" tIns="0" bIns="0">
             <a:spAutoFit/>
           </a:bodyPr>
           <a:lstStyle/>
@@ -6633,8 +7172,8 @@
         </p:nvSpPr>
         <p:spPr>
           <a:xfrm>
-            <a:off x="5029200" y="182880"/>
-            <a:ext cx="4754880" cy="292608"/>
+            <a:off x="4572000" y="182880"/>
+            <a:ext cx="5212080" cy="292608"/>
           </a:xfrm>
           <a:prstGeom prst="rect">
             <a:avLst/>
@@ -6642,7 +7181,7 @@
           <a:noFill/>
         </p:spPr>
         <p:txBody>
-          <a:bodyPr wrap="none" lIns="0" tIns="0" rIns="0" bIns="0">
+          <a:bodyPr wrap="square" lIns="0" rIns="0" tIns="0" bIns="0">
             <a:spAutoFit/>
           </a:bodyPr>
           <a:lstStyle/>
@@ -6650,7 +7189,7 @@
             <a:pPr algn="r">
               <a:defRPr sz="1000">
                 <a:solidFill>
-                  <a:srgbClr val="C8CDD7"/>
+                  <a:srgbClr val="BEC3CD"/>
                 </a:solidFill>
                 <a:latin typeface="Helvetica Neue"/>
               </a:defRPr>
@@ -6669,8 +7208,8 @@
         </p:nvSpPr>
         <p:spPr>
           <a:xfrm>
-            <a:off x="10058400" y="128016"/>
-            <a:ext cx="1371600" cy="329184"/>
+            <a:off x="9966960" y="128016"/>
+            <a:ext cx="1463040" cy="329184"/>
           </a:xfrm>
           <a:prstGeom prst="roundRect">
             <a:avLst/>
@@ -6712,8 +7251,8 @@
         </p:nvSpPr>
         <p:spPr>
           <a:xfrm>
-            <a:off x="10058400" y="164592"/>
-            <a:ext cx="1371600" cy="274320"/>
+            <a:off x="9966960" y="164592"/>
+            <a:ext cx="1463040" cy="274320"/>
           </a:xfrm>
           <a:prstGeom prst="rect">
             <a:avLst/>
@@ -6721,7 +7260,7 @@
           <a:noFill/>
         </p:spPr>
         <p:txBody>
-          <a:bodyPr wrap="none" lIns="0" tIns="0" rIns="0" bIns="0">
+          <a:bodyPr wrap="square" lIns="0" rIns="0" tIns="0" bIns="0">
             <a:spAutoFit/>
           </a:bodyPr>
           <a:lstStyle/>
@@ -6749,7 +7288,7 @@
         <p:spPr>
           <a:xfrm>
             <a:off x="731520" y="777240"/>
-            <a:ext cx="10728655" cy="274320"/>
+            <a:ext cx="10728655" cy="228600"/>
           </a:xfrm>
           <a:prstGeom prst="rect">
             <a:avLst/>
@@ -6757,13 +7296,13 @@
           <a:noFill/>
         </p:spPr>
         <p:txBody>
-          <a:bodyPr wrap="none" lIns="0" tIns="0" rIns="0" bIns="0">
+          <a:bodyPr wrap="square" lIns="0" rIns="0" tIns="0" bIns="0">
             <a:spAutoFit/>
           </a:bodyPr>
           <a:lstStyle/>
           <a:p>
             <a:pPr>
-              <a:defRPr sz="1100" b="1">
+              <a:defRPr sz="1000" b="1">
                 <a:solidFill>
                   <a:srgbClr val="2B59D9"/>
                 </a:solidFill>
@@ -6784,7 +7323,7 @@
         </p:nvSpPr>
         <p:spPr>
           <a:xfrm>
-            <a:off x="731520" y="1051560"/>
+            <a:off x="731520" y="1024128"/>
             <a:ext cx="10728655" cy="640080"/>
           </a:xfrm>
           <a:prstGeom prst="rect">
@@ -6793,7 +7332,7 @@
           <a:noFill/>
         </p:spPr>
         <p:txBody>
-          <a:bodyPr wrap="square" lIns="0" tIns="0" rIns="0" bIns="0">
+          <a:bodyPr wrap="square" lIns="0" rIns="0" tIns="0" bIns="0">
             <a:spAutoFit/>
           </a:bodyPr>
           <a:lstStyle/>
@@ -6874,7 +7413,7 @@
           <a:noFill/>
         </p:spPr>
         <p:txBody>
-          <a:bodyPr wrap="square">
+          <a:bodyPr wrap="square" lIns="0" rIns="0" tIns="0" bIns="0">
             <a:spAutoFit/>
           </a:bodyPr>
           <a:lstStyle/>
@@ -6899,7 +7438,7 @@
               <a:spcAft>
                 <a:spcPts val="1200"/>
               </a:spcAft>
-              <a:defRPr sz="1900" b="1">
+              <a:defRPr sz="1800" b="1">
                 <a:solidFill>
                   <a:srgbClr val="16161A"/>
                 </a:solidFill>
@@ -6912,7 +7451,7 @@
           </a:p>
           <a:p>
             <a:pPr>
-              <a:defRPr sz="1300">
+              <a:defRPr sz="1250">
                 <a:solidFill>
                   <a:srgbClr val="454337"/>
                 </a:solidFill>
@@ -6987,7 +7526,7 @@
           <a:noFill/>
         </p:spPr>
         <p:txBody>
-          <a:bodyPr wrap="square">
+          <a:bodyPr wrap="square" lIns="0" rIns="0" tIns="0" bIns="0">
             <a:spAutoFit/>
           </a:bodyPr>
           <a:lstStyle/>
@@ -7012,7 +7551,7 @@
               <a:spcAft>
                 <a:spcPts val="1200"/>
               </a:spcAft>
-              <a:defRPr sz="1900" b="1">
+              <a:defRPr sz="1800" b="1">
                 <a:solidFill>
                   <a:srgbClr val="16161A"/>
                 </a:solidFill>
@@ -7025,7 +7564,7 @@
           </a:p>
           <a:p>
             <a:pPr>
-              <a:defRPr sz="1300">
+              <a:defRPr sz="1250">
                 <a:solidFill>
                   <a:srgbClr val="454337"/>
                 </a:solidFill>
@@ -7100,7 +7639,7 @@
           <a:noFill/>
         </p:spPr>
         <p:txBody>
-          <a:bodyPr wrap="square">
+          <a:bodyPr wrap="square" lIns="0" rIns="0" tIns="0" bIns="0">
             <a:spAutoFit/>
           </a:bodyPr>
           <a:lstStyle/>
@@ -7125,7 +7664,7 @@
               <a:spcAft>
                 <a:spcPts val="1200"/>
               </a:spcAft>
-              <a:defRPr sz="1900" b="1">
+              <a:defRPr sz="1800" b="1">
                 <a:solidFill>
                   <a:srgbClr val="16161A"/>
                 </a:solidFill>
@@ -7138,7 +7677,7 @@
           </a:p>
           <a:p>
             <a:pPr>
-              <a:defRPr sz="1300">
+              <a:defRPr sz="1250">
                 <a:solidFill>
                   <a:srgbClr val="454337"/>
                 </a:solidFill>
@@ -7204,8 +7743,8 @@
         </p:nvSpPr>
         <p:spPr>
           <a:xfrm>
-            <a:off x="914400" y="5230368"/>
-            <a:ext cx="2148840" cy="914400"/>
+            <a:off x="914400" y="5257800"/>
+            <a:ext cx="2148840" cy="868680"/>
           </a:xfrm>
           <a:prstGeom prst="rect">
             <a:avLst/>
@@ -7213,7 +7752,7 @@
           <a:noFill/>
         </p:spPr>
         <p:txBody>
-          <a:bodyPr wrap="square">
+          <a:bodyPr wrap="square" lIns="0" rIns="0" tIns="0" bIns="0">
             <a:spAutoFit/>
           </a:bodyPr>
           <a:lstStyle/>
@@ -7301,8 +7840,8 @@
         </p:nvSpPr>
         <p:spPr>
           <a:xfrm>
-            <a:off x="3611880" y="5230368"/>
-            <a:ext cx="2148840" cy="914400"/>
+            <a:off x="3611880" y="5257800"/>
+            <a:ext cx="2148840" cy="868680"/>
           </a:xfrm>
           <a:prstGeom prst="rect">
             <a:avLst/>
@@ -7310,7 +7849,7 @@
           <a:noFill/>
         </p:spPr>
         <p:txBody>
-          <a:bodyPr wrap="square">
+          <a:bodyPr wrap="square" lIns="0" rIns="0" tIns="0" bIns="0">
             <a:spAutoFit/>
           </a:bodyPr>
           <a:lstStyle/>
@@ -7398,8 +7937,8 @@
         </p:nvSpPr>
         <p:spPr>
           <a:xfrm>
-            <a:off x="6309360" y="5230368"/>
-            <a:ext cx="2148840" cy="914400"/>
+            <a:off x="6309360" y="5257800"/>
+            <a:ext cx="2148840" cy="868680"/>
           </a:xfrm>
           <a:prstGeom prst="rect">
             <a:avLst/>
@@ -7407,7 +7946,7 @@
           <a:noFill/>
         </p:spPr>
         <p:txBody>
-          <a:bodyPr wrap="square">
+          <a:bodyPr wrap="square" lIns="0" rIns="0" tIns="0" bIns="0">
             <a:spAutoFit/>
           </a:bodyPr>
           <a:lstStyle/>
@@ -7495,8 +8034,8 @@
         </p:nvSpPr>
         <p:spPr>
           <a:xfrm>
-            <a:off x="9006840" y="5230368"/>
-            <a:ext cx="2148840" cy="914400"/>
+            <a:off x="9006840" y="5257800"/>
+            <a:ext cx="2148840" cy="868680"/>
           </a:xfrm>
           <a:prstGeom prst="rect">
             <a:avLst/>
@@ -7504,7 +8043,7 @@
           <a:noFill/>
         </p:spPr>
         <p:txBody>
-          <a:bodyPr wrap="square">
+          <a:bodyPr wrap="square" lIns="0" rIns="0" tIns="0" bIns="0">
             <a:spAutoFit/>
           </a:bodyPr>
           <a:lstStyle/>
@@ -7534,7 +8073,7 @@
               </a:defRPr>
             </a:pPr>
             <a:r>
-              <a:t>Interfaces y automatizaciones: mismo stack.</a:t>
+              <a:t>Interfaces y automatizaciones: mismo equipo.</a:t>
             </a:r>
           </a:p>
         </p:txBody>
@@ -7599,7 +8138,7 @@
           <a:noFill/>
         </p:spPr>
         <p:txBody>
-          <a:bodyPr wrap="none" lIns="0" tIns="0" rIns="0" bIns="0">
+          <a:bodyPr wrap="square" lIns="0" rIns="0" tIns="0" bIns="0">
             <a:spAutoFit/>
           </a:bodyPr>
           <a:lstStyle/>
@@ -7607,7 +8146,7 @@
             <a:pPr>
               <a:defRPr sz="1000">
                 <a:solidFill>
-                  <a:srgbClr val="5F5C52"/>
+                  <a:srgbClr val="736E62"/>
                 </a:solidFill>
                 <a:latin typeface="Helvetica Neue"/>
               </a:defRPr>
@@ -7635,7 +8174,7 @@
           <a:noFill/>
         </p:spPr>
         <p:txBody>
-          <a:bodyPr wrap="none" lIns="0" tIns="0" rIns="0" bIns="0">
+          <a:bodyPr wrap="square" lIns="0" rIns="0" tIns="0" bIns="0">
             <a:spAutoFit/>
           </a:bodyPr>
           <a:lstStyle/>
@@ -7643,7 +8182,7 @@
             <a:pPr algn="r">
               <a:defRPr sz="1000">
                 <a:solidFill>
-                  <a:srgbClr val="5F5C52"/>
+                  <a:srgbClr val="736E62"/>
                 </a:solidFill>
                 <a:latin typeface="Helvetica Neue"/>
               </a:defRPr>
@@ -7734,7 +8273,7 @@
         <p:spPr>
           <a:xfrm>
             <a:off x="731520" y="146304"/>
-            <a:ext cx="310896" cy="310896"/>
+            <a:ext cx="301752" cy="301752"/>
           </a:xfrm>
           <a:prstGeom prst="roundRect">
             <a:avLst/>
@@ -7777,7 +8316,7 @@
         <p:spPr>
           <a:xfrm>
             <a:off x="731520" y="128016"/>
-            <a:ext cx="310896" cy="310896"/>
+            <a:ext cx="301752" cy="301752"/>
           </a:xfrm>
           <a:prstGeom prst="rect">
             <a:avLst/>
@@ -7785,7 +8324,7 @@
           <a:noFill/>
         </p:spPr>
         <p:txBody>
-          <a:bodyPr wrap="none" lIns="0" tIns="0" rIns="0" bIns="0">
+          <a:bodyPr wrap="square" lIns="0" rIns="0" tIns="0" bIns="0">
             <a:spAutoFit/>
           </a:bodyPr>
           <a:lstStyle/>
@@ -7821,7 +8360,7 @@
           <a:noFill/>
         </p:spPr>
         <p:txBody>
-          <a:bodyPr wrap="none" lIns="0" tIns="0" rIns="0" bIns="0">
+          <a:bodyPr wrap="square" lIns="0" rIns="0" tIns="0" bIns="0">
             <a:spAutoFit/>
           </a:bodyPr>
           <a:lstStyle/>
@@ -7848,8 +8387,8 @@
         </p:nvSpPr>
         <p:spPr>
           <a:xfrm>
-            <a:off x="5029200" y="182880"/>
-            <a:ext cx="4754880" cy="292608"/>
+            <a:off x="4572000" y="182880"/>
+            <a:ext cx="5212080" cy="292608"/>
           </a:xfrm>
           <a:prstGeom prst="rect">
             <a:avLst/>
@@ -7857,7 +8396,7 @@
           <a:noFill/>
         </p:spPr>
         <p:txBody>
-          <a:bodyPr wrap="none" lIns="0" tIns="0" rIns="0" bIns="0">
+          <a:bodyPr wrap="square" lIns="0" rIns="0" tIns="0" bIns="0">
             <a:spAutoFit/>
           </a:bodyPr>
           <a:lstStyle/>
@@ -7865,7 +8404,7 @@
             <a:pPr algn="r">
               <a:defRPr sz="1000">
                 <a:solidFill>
-                  <a:srgbClr val="C8CDD7"/>
+                  <a:srgbClr val="BEC3CD"/>
                 </a:solidFill>
                 <a:latin typeface="Helvetica Neue"/>
               </a:defRPr>
@@ -7884,8 +8423,8 @@
         </p:nvSpPr>
         <p:spPr>
           <a:xfrm>
-            <a:off x="10058400" y="128016"/>
-            <a:ext cx="1371600" cy="329184"/>
+            <a:off x="9966960" y="128016"/>
+            <a:ext cx="1463040" cy="329184"/>
           </a:xfrm>
           <a:prstGeom prst="roundRect">
             <a:avLst/>
@@ -7927,8 +8466,8 @@
         </p:nvSpPr>
         <p:spPr>
           <a:xfrm>
-            <a:off x="10058400" y="164592"/>
-            <a:ext cx="1371600" cy="274320"/>
+            <a:off x="9966960" y="164592"/>
+            <a:ext cx="1463040" cy="274320"/>
           </a:xfrm>
           <a:prstGeom prst="rect">
             <a:avLst/>
@@ -7936,7 +8475,7 @@
           <a:noFill/>
         </p:spPr>
         <p:txBody>
-          <a:bodyPr wrap="none" lIns="0" tIns="0" rIns="0" bIns="0">
+          <a:bodyPr wrap="square" lIns="0" rIns="0" tIns="0" bIns="0">
             <a:spAutoFit/>
           </a:bodyPr>
           <a:lstStyle/>
@@ -7964,7 +8503,7 @@
         <p:spPr>
           <a:xfrm>
             <a:off x="731520" y="777240"/>
-            <a:ext cx="10728655" cy="274320"/>
+            <a:ext cx="10728655" cy="228600"/>
           </a:xfrm>
           <a:prstGeom prst="rect">
             <a:avLst/>
@@ -7972,13 +8511,13 @@
           <a:noFill/>
         </p:spPr>
         <p:txBody>
-          <a:bodyPr wrap="none" lIns="0" tIns="0" rIns="0" bIns="0">
+          <a:bodyPr wrap="square" lIns="0" rIns="0" tIns="0" bIns="0">
             <a:spAutoFit/>
           </a:bodyPr>
           <a:lstStyle/>
           <a:p>
             <a:pPr>
-              <a:defRPr sz="1100" b="1">
+              <a:defRPr sz="1000" b="1">
                 <a:solidFill>
                   <a:srgbClr val="2B59D9"/>
                 </a:solidFill>
@@ -7999,7 +8538,7 @@
         </p:nvSpPr>
         <p:spPr>
           <a:xfrm>
-            <a:off x="731520" y="1051560"/>
+            <a:off x="731520" y="1024128"/>
             <a:ext cx="10728655" cy="640080"/>
           </a:xfrm>
           <a:prstGeom prst="rect">
@@ -8008,7 +8547,7 @@
           <a:noFill/>
         </p:spPr>
         <p:txBody>
-          <a:bodyPr wrap="square" lIns="0" tIns="0" rIns="0" bIns="0">
+          <a:bodyPr wrap="square" lIns="0" rIns="0" tIns="0" bIns="0">
             <a:spAutoFit/>
           </a:bodyPr>
           <a:lstStyle/>
@@ -8080,8 +8619,8 @@
         </p:nvSpPr>
         <p:spPr>
           <a:xfrm>
-            <a:off x="1005840" y="2194559"/>
-            <a:ext cx="4608576" cy="3566160"/>
+            <a:off x="1051560" y="2194559"/>
+            <a:ext cx="4517136" cy="3566160"/>
           </a:xfrm>
           <a:prstGeom prst="rect">
             <a:avLst/>
@@ -8089,7 +8628,7 @@
           <a:noFill/>
         </p:spPr>
         <p:txBody>
-          <a:bodyPr wrap="square">
+          <a:bodyPr wrap="square" lIns="0" rIns="0" tIns="0" bIns="0">
             <a:spAutoFit/>
           </a:bodyPr>
           <a:lstStyle/>
@@ -8114,7 +8653,7 @@
               <a:spcAft>
                 <a:spcPts val="800"/>
               </a:spcAft>
-              <a:defRPr sz="1300">
+              <a:defRPr sz="1250">
                 <a:solidFill>
                   <a:srgbClr val="454337"/>
                 </a:solidFill>
@@ -8122,7 +8661,7 @@
               </a:defRPr>
             </a:pPr>
             <a:r>
-              <a:t>✕ Búsqueda de maquila offshore o tarifas por hora de bajo costo.</a:t>
+              <a:t>✕  Búsqueda de maquila offshore o tarifas por hora de bajo costo.</a:t>
             </a:r>
           </a:p>
           <a:p>
@@ -8130,7 +8669,7 @@
               <a:spcAft>
                 <a:spcPts val="800"/>
               </a:spcAft>
-              <a:defRPr sz="1300">
+              <a:defRPr sz="1250">
                 <a:solidFill>
                   <a:srgbClr val="454337"/>
                 </a:solidFill>
@@ -8138,7 +8677,7 @@
               </a:defRPr>
             </a:pPr>
             <a:r>
-              <a:t>✕ Sitios web básicos en WordPress o plantillas genéricas sin código.</a:t>
+              <a:t>✕  Sitios web básicos en WordPress o plantillas genéricas sin código.</a:t>
             </a:r>
           </a:p>
           <a:p>
@@ -8146,7 +8685,7 @@
               <a:spcAft>
                 <a:spcPts val="800"/>
               </a:spcAft>
-              <a:defRPr sz="1300">
+              <a:defRPr sz="1250">
                 <a:solidFill>
                   <a:srgbClr val="454337"/>
                 </a:solidFill>
@@ -8154,7 +8693,7 @@
               </a:defRPr>
             </a:pPr>
             <a:r>
-              <a:t>✕ Sin presupuesto de ingeniería o sin intención de invertir en arquitectura.</a:t>
+              <a:t>✕  Sin presupuesto de ingeniería o sin intención de invertir en arquitectura.</a:t>
             </a:r>
           </a:p>
           <a:p>
@@ -8162,7 +8701,7 @@
               <a:spcAft>
                 <a:spcPts val="800"/>
               </a:spcAft>
-              <a:defRPr sz="1300">
+              <a:defRPr sz="1250">
                 <a:solidFill>
                   <a:srgbClr val="454337"/>
                 </a:solidFill>
@@ -8170,7 +8709,7 @@
               </a:defRPr>
             </a:pPr>
             <a:r>
-              <a:t>✕ Objetivos de negocio difusos sin métricas claras de resultado.</a:t>
+              <a:t>✕  Objetivos de negocio difusos sin métricas claras de resultado.</a:t>
             </a:r>
           </a:p>
         </p:txBody>
@@ -8228,8 +8767,8 @@
         </p:nvSpPr>
         <p:spPr>
           <a:xfrm>
-            <a:off x="6574536" y="2194559"/>
-            <a:ext cx="4608576" cy="3566160"/>
+            <a:off x="6620256" y="2194559"/>
+            <a:ext cx="4517136" cy="3566160"/>
           </a:xfrm>
           <a:prstGeom prst="rect">
             <a:avLst/>
@@ -8237,7 +8776,7 @@
           <a:noFill/>
         </p:spPr>
         <p:txBody>
-          <a:bodyPr wrap="square">
+          <a:bodyPr wrap="square" lIns="0" rIns="0" tIns="0" bIns="0">
             <a:spAutoFit/>
           </a:bodyPr>
           <a:lstStyle/>
@@ -8262,7 +8801,7 @@
               <a:spcAft>
                 <a:spcPts val="800"/>
               </a:spcAft>
-              <a:defRPr sz="1300">
+              <a:defRPr sz="1250">
                 <a:solidFill>
                   <a:srgbClr val="454337"/>
                 </a:solidFill>
@@ -8270,7 +8809,7 @@
               </a:defRPr>
             </a:pPr>
             <a:r>
-              <a:t>✕ Envoltorios superficiales de IA sin integración a backend o APIs reales.</a:t>
+              <a:t>✕  Envoltorios superficiales de IA sin integración a backend o APIs reales.</a:t>
             </a:r>
           </a:p>
           <a:p>
@@ -8278,7 +8817,7 @@
               <a:spcAft>
                 <a:spcPts val="800"/>
               </a:spcAft>
-              <a:defRPr sz="1300">
+              <a:defRPr sz="1250">
                 <a:solidFill>
                   <a:srgbClr val="454337"/>
                 </a:solidFill>
@@ -8286,7 +8825,7 @@
               </a:defRPr>
             </a:pPr>
             <a:r>
-              <a:t>✕ Poca disposición para mantener orden de datos, seguridad o supervisión humana.</a:t>
+              <a:t>✕  Poca disposición para mantener orden de datos, seguridad o supervisión humana.</a:t>
             </a:r>
           </a:p>
           <a:p>
@@ -8294,7 +8833,7 @@
               <a:spcAft>
                 <a:spcPts val="800"/>
               </a:spcAft>
-              <a:defRPr sz="1300">
+              <a:defRPr sz="1250">
                 <a:solidFill>
                   <a:srgbClr val="454337"/>
                 </a:solidFill>
@@ -8302,7 +8841,7 @@
               </a:defRPr>
             </a:pPr>
             <a:r>
-              <a:t>✕ Expectativas de magia de IA sin diseño estructurado de procesos.</a:t>
+              <a:t>✕  Expectativas de magia de IA sin diseño estructurado de procesos.</a:t>
             </a:r>
           </a:p>
           <a:p>
@@ -8310,7 +8849,7 @@
               <a:spcAft>
                 <a:spcPts val="800"/>
               </a:spcAft>
-              <a:defRPr sz="1300">
+              <a:defRPr sz="1250">
                 <a:solidFill>
                   <a:srgbClr val="454337"/>
                 </a:solidFill>
@@ -8318,7 +8857,7 @@
               </a:defRPr>
             </a:pPr>
             <a:r>
-              <a:t>✕ Sin un experto interno del negocio para validar los resultados de la IA.</a:t>
+              <a:t>✕  Sin un experto interno del negocio para validar los resultados de la IA.</a:t>
             </a:r>
           </a:p>
         </p:txBody>
@@ -8383,7 +8922,7 @@
           <a:noFill/>
         </p:spPr>
         <p:txBody>
-          <a:bodyPr wrap="none" lIns="0" tIns="0" rIns="0" bIns="0">
+          <a:bodyPr wrap="square" lIns="0" rIns="0" tIns="0" bIns="0">
             <a:spAutoFit/>
           </a:bodyPr>
           <a:lstStyle/>
@@ -8391,7 +8930,7 @@
             <a:pPr>
               <a:defRPr sz="1000">
                 <a:solidFill>
-                  <a:srgbClr val="5F5C52"/>
+                  <a:srgbClr val="736E62"/>
                 </a:solidFill>
                 <a:latin typeface="Helvetica Neue"/>
               </a:defRPr>
@@ -8419,7 +8958,7 @@
           <a:noFill/>
         </p:spPr>
         <p:txBody>
-          <a:bodyPr wrap="none" lIns="0" tIns="0" rIns="0" bIns="0">
+          <a:bodyPr wrap="square" lIns="0" rIns="0" tIns="0" bIns="0">
             <a:spAutoFit/>
           </a:bodyPr>
           <a:lstStyle/>
@@ -8427,7 +8966,7 @@
             <a:pPr algn="r">
               <a:defRPr sz="1000">
                 <a:solidFill>
-                  <a:srgbClr val="5F5C52"/>
+                  <a:srgbClr val="736E62"/>
                 </a:solidFill>
                 <a:latin typeface="Helvetica Neue"/>
               </a:defRPr>
@@ -8518,7 +9057,7 @@
         <p:spPr>
           <a:xfrm>
             <a:off x="731520" y="146304"/>
-            <a:ext cx="310896" cy="310896"/>
+            <a:ext cx="301752" cy="301752"/>
           </a:xfrm>
           <a:prstGeom prst="roundRect">
             <a:avLst/>
@@ -8561,7 +9100,7 @@
         <p:spPr>
           <a:xfrm>
             <a:off x="731520" y="128016"/>
-            <a:ext cx="310896" cy="310896"/>
+            <a:ext cx="301752" cy="301752"/>
           </a:xfrm>
           <a:prstGeom prst="rect">
             <a:avLst/>
@@ -8569,7 +9108,7 @@
           <a:noFill/>
         </p:spPr>
         <p:txBody>
-          <a:bodyPr wrap="none" lIns="0" tIns="0" rIns="0" bIns="0">
+          <a:bodyPr wrap="square" lIns="0" rIns="0" tIns="0" bIns="0">
             <a:spAutoFit/>
           </a:bodyPr>
           <a:lstStyle/>
@@ -8605,7 +9144,7 @@
           <a:noFill/>
         </p:spPr>
         <p:txBody>
-          <a:bodyPr wrap="none" lIns="0" tIns="0" rIns="0" bIns="0">
+          <a:bodyPr wrap="square" lIns="0" rIns="0" tIns="0" bIns="0">
             <a:spAutoFit/>
           </a:bodyPr>
           <a:lstStyle/>
@@ -8632,8 +9171,8 @@
         </p:nvSpPr>
         <p:spPr>
           <a:xfrm>
-            <a:off x="5029200" y="182880"/>
-            <a:ext cx="4754880" cy="292608"/>
+            <a:off x="4572000" y="182880"/>
+            <a:ext cx="5212080" cy="292608"/>
           </a:xfrm>
           <a:prstGeom prst="rect">
             <a:avLst/>
@@ -8641,7 +9180,7 @@
           <a:noFill/>
         </p:spPr>
         <p:txBody>
-          <a:bodyPr wrap="none" lIns="0" tIns="0" rIns="0" bIns="0">
+          <a:bodyPr wrap="square" lIns="0" rIns="0" tIns="0" bIns="0">
             <a:spAutoFit/>
           </a:bodyPr>
           <a:lstStyle/>
@@ -8649,7 +9188,7 @@
             <a:pPr algn="r">
               <a:defRPr sz="1000">
                 <a:solidFill>
-                  <a:srgbClr val="C8CDD7"/>
+                  <a:srgbClr val="BEC3CD"/>
                 </a:solidFill>
                 <a:latin typeface="Helvetica Neue"/>
               </a:defRPr>
@@ -8668,8 +9207,8 @@
         </p:nvSpPr>
         <p:spPr>
           <a:xfrm>
-            <a:off x="10058400" y="128016"/>
-            <a:ext cx="1371600" cy="329184"/>
+            <a:off x="9966960" y="128016"/>
+            <a:ext cx="1463040" cy="329184"/>
           </a:xfrm>
           <a:prstGeom prst="roundRect">
             <a:avLst/>
@@ -8711,8 +9250,8 @@
         </p:nvSpPr>
         <p:spPr>
           <a:xfrm>
-            <a:off x="10058400" y="164592"/>
-            <a:ext cx="1371600" cy="274320"/>
+            <a:off x="9966960" y="164592"/>
+            <a:ext cx="1463040" cy="274320"/>
           </a:xfrm>
           <a:prstGeom prst="rect">
             <a:avLst/>
@@ -8720,7 +9259,7 @@
           <a:noFill/>
         </p:spPr>
         <p:txBody>
-          <a:bodyPr wrap="none" lIns="0" tIns="0" rIns="0" bIns="0">
+          <a:bodyPr wrap="square" lIns="0" rIns="0" tIns="0" bIns="0">
             <a:spAutoFit/>
           </a:bodyPr>
           <a:lstStyle/>
@@ -8748,7 +9287,7 @@
         <p:spPr>
           <a:xfrm>
             <a:off x="731520" y="777240"/>
-            <a:ext cx="10728655" cy="274320"/>
+            <a:ext cx="10728655" cy="228600"/>
           </a:xfrm>
           <a:prstGeom prst="rect">
             <a:avLst/>
@@ -8756,13 +9295,13 @@
           <a:noFill/>
         </p:spPr>
         <p:txBody>
-          <a:bodyPr wrap="none" lIns="0" tIns="0" rIns="0" bIns="0">
+          <a:bodyPr wrap="square" lIns="0" rIns="0" tIns="0" bIns="0">
             <a:spAutoFit/>
           </a:bodyPr>
           <a:lstStyle/>
           <a:p>
             <a:pPr>
-              <a:defRPr sz="1100" b="1">
+              <a:defRPr sz="1000" b="1">
                 <a:solidFill>
                   <a:srgbClr val="2B59D9"/>
                 </a:solidFill>
@@ -8783,7 +9322,7 @@
         </p:nvSpPr>
         <p:spPr>
           <a:xfrm>
-            <a:off x="731520" y="1051560"/>
+            <a:off x="731520" y="1024128"/>
             <a:ext cx="10728655" cy="640080"/>
           </a:xfrm>
           <a:prstGeom prst="rect">
@@ -8792,7 +9331,7 @@
           <a:noFill/>
         </p:spPr>
         <p:txBody>
-          <a:bodyPr wrap="square" lIns="0" tIns="0" rIns="0" bIns="0">
+          <a:bodyPr wrap="square" lIns="0" rIns="0" tIns="0" bIns="0">
             <a:spAutoFit/>
           </a:bodyPr>
           <a:lstStyle/>
@@ -8873,7 +9412,7 @@
           <a:noFill/>
         </p:spPr>
         <p:txBody>
-          <a:bodyPr wrap="square">
+          <a:bodyPr wrap="square" lIns="0" rIns="0" tIns="0" bIns="0">
             <a:spAutoFit/>
           </a:bodyPr>
           <a:lstStyle/>
@@ -8986,7 +9525,7 @@
           <a:noFill/>
         </p:spPr>
         <p:txBody>
-          <a:bodyPr wrap="square">
+          <a:bodyPr wrap="square" lIns="0" rIns="0" tIns="0" bIns="0">
             <a:spAutoFit/>
           </a:bodyPr>
           <a:lstStyle/>
@@ -9099,7 +9638,7 @@
           <a:noFill/>
         </p:spPr>
         <p:txBody>
-          <a:bodyPr wrap="square">
+          <a:bodyPr wrap="square" lIns="0" rIns="0" tIns="0" bIns="0">
             <a:spAutoFit/>
           </a:bodyPr>
           <a:lstStyle/>
@@ -9210,7 +9749,7 @@
           <a:noFill/>
         </p:spPr>
         <p:txBody>
-          <a:bodyPr wrap="none" lIns="0" tIns="0" rIns="0" bIns="0">
+          <a:bodyPr wrap="square" lIns="0" rIns="0" tIns="0" bIns="0">
             <a:spAutoFit/>
           </a:bodyPr>
           <a:lstStyle/>
@@ -9218,7 +9757,7 @@
             <a:pPr>
               <a:defRPr sz="1000">
                 <a:solidFill>
-                  <a:srgbClr val="5F5C52"/>
+                  <a:srgbClr val="736E62"/>
                 </a:solidFill>
                 <a:latin typeface="Helvetica Neue"/>
               </a:defRPr>
@@ -9246,7 +9785,7 @@
           <a:noFill/>
         </p:spPr>
         <p:txBody>
-          <a:bodyPr wrap="none" lIns="0" tIns="0" rIns="0" bIns="0">
+          <a:bodyPr wrap="square" lIns="0" rIns="0" tIns="0" bIns="0">
             <a:spAutoFit/>
           </a:bodyPr>
           <a:lstStyle/>
@@ -9254,7 +9793,7 @@
             <a:pPr algn="r">
               <a:defRPr sz="1000">
                 <a:solidFill>
-                  <a:srgbClr val="5F5C52"/>
+                  <a:srgbClr val="736E62"/>
                 </a:solidFill>
                 <a:latin typeface="Helvetica Neue"/>
               </a:defRPr>
@@ -9345,7 +9884,7 @@
         <p:spPr>
           <a:xfrm>
             <a:off x="731520" y="146304"/>
-            <a:ext cx="310896" cy="310896"/>
+            <a:ext cx="301752" cy="301752"/>
           </a:xfrm>
           <a:prstGeom prst="roundRect">
             <a:avLst/>
@@ -9388,7 +9927,7 @@
         <p:spPr>
           <a:xfrm>
             <a:off x="731520" y="128016"/>
-            <a:ext cx="310896" cy="310896"/>
+            <a:ext cx="301752" cy="301752"/>
           </a:xfrm>
           <a:prstGeom prst="rect">
             <a:avLst/>
@@ -9396,7 +9935,7 @@
           <a:noFill/>
         </p:spPr>
         <p:txBody>
-          <a:bodyPr wrap="none" lIns="0" tIns="0" rIns="0" bIns="0">
+          <a:bodyPr wrap="square" lIns="0" rIns="0" tIns="0" bIns="0">
             <a:spAutoFit/>
           </a:bodyPr>
           <a:lstStyle/>
@@ -9432,7 +9971,7 @@
           <a:noFill/>
         </p:spPr>
         <p:txBody>
-          <a:bodyPr wrap="none" lIns="0" tIns="0" rIns="0" bIns="0">
+          <a:bodyPr wrap="square" lIns="0" rIns="0" tIns="0" bIns="0">
             <a:spAutoFit/>
           </a:bodyPr>
           <a:lstStyle/>
@@ -9459,8 +9998,8 @@
         </p:nvSpPr>
         <p:spPr>
           <a:xfrm>
-            <a:off x="5029200" y="182880"/>
-            <a:ext cx="4754880" cy="292608"/>
+            <a:off x="4572000" y="182880"/>
+            <a:ext cx="5212080" cy="292608"/>
           </a:xfrm>
           <a:prstGeom prst="rect">
             <a:avLst/>
@@ -9468,7 +10007,7 @@
           <a:noFill/>
         </p:spPr>
         <p:txBody>
-          <a:bodyPr wrap="none" lIns="0" tIns="0" rIns="0" bIns="0">
+          <a:bodyPr wrap="square" lIns="0" rIns="0" tIns="0" bIns="0">
             <a:spAutoFit/>
           </a:bodyPr>
           <a:lstStyle/>
@@ -9476,7 +10015,7 @@
             <a:pPr algn="r">
               <a:defRPr sz="1000">
                 <a:solidFill>
-                  <a:srgbClr val="C8CDD7"/>
+                  <a:srgbClr val="BEC3CD"/>
                 </a:solidFill>
                 <a:latin typeface="Helvetica Neue"/>
               </a:defRPr>
@@ -9495,8 +10034,8 @@
         </p:nvSpPr>
         <p:spPr>
           <a:xfrm>
-            <a:off x="10058400" y="128016"/>
-            <a:ext cx="1371600" cy="329184"/>
+            <a:off x="9966960" y="128016"/>
+            <a:ext cx="1463040" cy="329184"/>
           </a:xfrm>
           <a:prstGeom prst="roundRect">
             <a:avLst/>
@@ -9538,8 +10077,8 @@
         </p:nvSpPr>
         <p:spPr>
           <a:xfrm>
-            <a:off x="10058400" y="164592"/>
-            <a:ext cx="1371600" cy="274320"/>
+            <a:off x="9966960" y="164592"/>
+            <a:ext cx="1463040" cy="274320"/>
           </a:xfrm>
           <a:prstGeom prst="rect">
             <a:avLst/>
@@ -9547,7 +10086,7 @@
           <a:noFill/>
         </p:spPr>
         <p:txBody>
-          <a:bodyPr wrap="none" lIns="0" tIns="0" rIns="0" bIns="0">
+          <a:bodyPr wrap="square" lIns="0" rIns="0" tIns="0" bIns="0">
             <a:spAutoFit/>
           </a:bodyPr>
           <a:lstStyle/>
@@ -9575,7 +10114,7 @@
         <p:spPr>
           <a:xfrm>
             <a:off x="731520" y="777240"/>
-            <a:ext cx="10728655" cy="274320"/>
+            <a:ext cx="10728655" cy="228600"/>
           </a:xfrm>
           <a:prstGeom prst="rect">
             <a:avLst/>
@@ -9583,13 +10122,13 @@
           <a:noFill/>
         </p:spPr>
         <p:txBody>
-          <a:bodyPr wrap="none" lIns="0" tIns="0" rIns="0" bIns="0">
+          <a:bodyPr wrap="square" lIns="0" rIns="0" tIns="0" bIns="0">
             <a:spAutoFit/>
           </a:bodyPr>
           <a:lstStyle/>
           <a:p>
             <a:pPr>
-              <a:defRPr sz="1100" b="1">
+              <a:defRPr sz="1000" b="1">
                 <a:solidFill>
                   <a:srgbClr val="2B59D9"/>
                 </a:solidFill>
@@ -9610,7 +10149,7 @@
         </p:nvSpPr>
         <p:spPr>
           <a:xfrm>
-            <a:off x="731520" y="1051560"/>
+            <a:off x="731520" y="1024128"/>
             <a:ext cx="10728655" cy="640080"/>
           </a:xfrm>
           <a:prstGeom prst="rect">
@@ -9619,7 +10158,7 @@
           <a:noFill/>
         </p:spPr>
         <p:txBody>
-          <a:bodyPr wrap="square" lIns="0" tIns="0" rIns="0" bIns="0">
+          <a:bodyPr wrap="square" lIns="0" rIns="0" tIns="0" bIns="0">
             <a:spAutoFit/>
           </a:bodyPr>
           <a:lstStyle/>
@@ -9691,8 +10230,8 @@
         </p:nvSpPr>
         <p:spPr>
           <a:xfrm>
-            <a:off x="1005840" y="2057400"/>
-            <a:ext cx="10180015" cy="2651760"/>
+            <a:off x="1051560" y="2103120"/>
+            <a:ext cx="10058400" cy="2560320"/>
           </a:xfrm>
           <a:prstGeom prst="rect">
             <a:avLst/>
@@ -9700,7 +10239,7 @@
           <a:noFill/>
         </p:spPr>
         <p:txBody>
-          <a:bodyPr wrap="square">
+          <a:bodyPr wrap="square" lIns="0" rIns="0" tIns="0" bIns="0">
             <a:spAutoFit/>
           </a:bodyPr>
           <a:lstStyle/>
@@ -9725,7 +10264,7 @@
               <a:spcAft>
                 <a:spcPts val="800"/>
               </a:spcAft>
-              <a:defRPr sz="1500">
+              <a:defRPr sz="1450">
                 <a:solidFill>
                   <a:srgbClr val="16161A"/>
                 </a:solidFill>
@@ -9738,7 +10277,7 @@
           </a:p>
           <a:p>
             <a:pPr>
-              <a:defRPr sz="1500">
+              <a:defRPr sz="1450">
                 <a:solidFill>
                   <a:srgbClr val="16161A"/>
                 </a:solidFill>
@@ -9768,7 +10307,7 @@
           <a:noFill/>
         </p:spPr>
         <p:txBody>
-          <a:bodyPr wrap="square">
+          <a:bodyPr wrap="square" lIns="0" rIns="0" tIns="0" bIns="0">
             <a:spAutoFit/>
           </a:bodyPr>
           <a:lstStyle/>
@@ -9863,7 +10402,7 @@
           <a:noFill/>
         </p:spPr>
         <p:txBody>
-          <a:bodyPr wrap="none" lIns="0" tIns="0" rIns="0" bIns="0">
+          <a:bodyPr wrap="square" lIns="0" rIns="0" tIns="0" bIns="0">
             <a:spAutoFit/>
           </a:bodyPr>
           <a:lstStyle/>
@@ -9871,7 +10410,7 @@
             <a:pPr>
               <a:defRPr sz="1000">
                 <a:solidFill>
-                  <a:srgbClr val="5F5C52"/>
+                  <a:srgbClr val="736E62"/>
                 </a:solidFill>
                 <a:latin typeface="Helvetica Neue"/>
               </a:defRPr>
@@ -9899,7 +10438,7 @@
           <a:noFill/>
         </p:spPr>
         <p:txBody>
-          <a:bodyPr wrap="none" lIns="0" tIns="0" rIns="0" bIns="0">
+          <a:bodyPr wrap="square" lIns="0" rIns="0" tIns="0" bIns="0">
             <a:spAutoFit/>
           </a:bodyPr>
           <a:lstStyle/>
@@ -9907,7 +10446,7 @@
             <a:pPr algn="r">
               <a:defRPr sz="1000">
                 <a:solidFill>
-                  <a:srgbClr val="5F5C52"/>
+                  <a:srgbClr val="736E62"/>
                 </a:solidFill>
                 <a:latin typeface="Helvetica Neue"/>
               </a:defRPr>

</xml_diff>

<commit_message>
Eliminate card containers from PPTX decks; switch to canvas-native typography layout with subtle accent line dividers
</commit_message>
<xml_diff>
--- a/Technology_Consultants_A_Quien_Enviarme_MX.pptx
+++ b/Technology_Consultants_A_Quien_Enviarme_MX.pptx
@@ -3147,7 +3147,7 @@
         </p:nvSpPr>
         <p:spPr>
           <a:xfrm>
-            <a:off x="731520" y="1005840"/>
+            <a:off x="731520" y="1051560"/>
             <a:ext cx="10728655" cy="1280160"/>
           </a:xfrm>
           <a:prstGeom prst="rect">
@@ -3183,7 +3183,7 @@
         </p:nvSpPr>
         <p:spPr>
           <a:xfrm>
-            <a:off x="731520" y="2377440"/>
+            <a:off x="731520" y="2423160"/>
             <a:ext cx="10728655" cy="822960"/>
           </a:xfrm>
           <a:prstGeom prst="rect">
@@ -3198,7 +3198,7 @@
           <a:lstStyle/>
           <a:p>
             <a:pPr>
-              <a:defRPr sz="1400">
+              <a:defRPr sz="1450">
                 <a:solidFill>
                   <a:srgbClr val="454337"/>
                 </a:solidFill>
@@ -3213,615 +3213,13 @@
       </p:sp>
       <p:sp>
         <p:nvSpPr>
-          <p:cNvPr id="5" name="Rounded Rectangle 4"/>
+          <p:cNvPr id="5" name="Rectangle 4"/>
           <p:cNvSpPr/>
           <p:nvPr/>
         </p:nvSpPr>
         <p:spPr>
           <a:xfrm>
-            <a:off x="731520" y="3337560"/>
-            <a:ext cx="5157216" cy="1691640"/>
-          </a:xfrm>
-          <a:prstGeom prst="roundRect">
-            <a:avLst/>
-          </a:prstGeom>
-          <a:solidFill>
-            <a:srgbClr val="FFFFFF"/>
-          </a:solidFill>
-          <a:ln w="12700">
-            <a:solidFill>
-              <a:srgbClr val="E2DDD0"/>
-            </a:solidFill>
-          </a:ln>
-        </p:spPr>
-        <p:style>
-          <a:lnRef idx="1">
-            <a:schemeClr val="accent1"/>
-          </a:lnRef>
-          <a:fillRef idx="3">
-            <a:schemeClr val="accent1"/>
-          </a:fillRef>
-          <a:effectRef idx="2">
-            <a:schemeClr val="accent1"/>
-          </a:effectRef>
-          <a:fontRef idx="minor">
-            <a:schemeClr val="lt1"/>
-          </a:fontRef>
-        </p:style>
-        <p:txBody>
-          <a:bodyPr rtlCol="0" anchor="ctr"/>
-          <a:lstStyle/>
-          <a:p>
-            <a:pPr algn="ctr"/>
-          </a:p>
-        </p:txBody>
-      </p:sp>
-      <p:sp>
-        <p:nvSpPr>
-          <p:cNvPr id="6" name="TextBox 5"/>
-          <p:cNvSpPr txBox="1"/>
-          <p:nvPr/>
-        </p:nvSpPr>
-        <p:spPr>
-          <a:xfrm>
-            <a:off x="1005840" y="3538728"/>
-            <a:ext cx="4608576" cy="1289304"/>
-          </a:xfrm>
-          <a:prstGeom prst="rect">
-            <a:avLst/>
-          </a:prstGeom>
-          <a:noFill/>
-        </p:spPr>
-        <p:txBody>
-          <a:bodyPr wrap="square" lIns="0" rIns="0" tIns="0" bIns="0">
-            <a:spAutoFit/>
-          </a:bodyPr>
-          <a:lstStyle/>
-          <a:p>
-            <a:pPr>
-              <a:spcAft>
-                <a:spcPts val="600"/>
-              </a:spcAft>
-              <a:defRPr sz="1050" b="1">
-                <a:solidFill>
-                  <a:srgbClr val="2B59D9"/>
-                </a:solidFill>
-                <a:latin typeface="Helvetica Neue"/>
-              </a:defRPr>
-            </a:pPr>
-            <a:r>
-              <a:t>CAPACIDADES CLAVE</a:t>
-            </a:r>
-          </a:p>
-          <a:p>
-            <a:pPr>
-              <a:defRPr sz="1250">
-                <a:solidFill>
-                  <a:srgbClr val="16161A"/>
-                </a:solidFill>
-                <a:latin typeface="Helvetica Neue"/>
-              </a:defRPr>
-            </a:pPr>
-            <a:r>
-              <a:t>Aplicaciones Web en React y TypeScript  ·  Integraciones en Workday Finance y Adaptive  ·  Agentes de IA con Supervisión Humana (HITL)</a:t>
-            </a:r>
-          </a:p>
-        </p:txBody>
-      </p:sp>
-      <p:sp>
-        <p:nvSpPr>
-          <p:cNvPr id="7" name="Rounded Rectangle 6"/>
-          <p:cNvSpPr/>
-          <p:nvPr/>
-        </p:nvSpPr>
-        <p:spPr>
-          <a:xfrm>
-            <a:off x="6300216" y="3337560"/>
-            <a:ext cx="5157216" cy="1691640"/>
-          </a:xfrm>
-          <a:prstGeom prst="roundRect">
-            <a:avLst/>
-          </a:prstGeom>
-          <a:solidFill>
-            <a:srgbClr val="FFFFFF"/>
-          </a:solidFill>
-          <a:ln w="12700">
-            <a:solidFill>
-              <a:srgbClr val="E2DDD0"/>
-            </a:solidFill>
-          </a:ln>
-        </p:spPr>
-        <p:style>
-          <a:lnRef idx="1">
-            <a:schemeClr val="accent1"/>
-          </a:lnRef>
-          <a:fillRef idx="3">
-            <a:schemeClr val="accent1"/>
-          </a:fillRef>
-          <a:effectRef idx="2">
-            <a:schemeClr val="accent1"/>
-          </a:effectRef>
-          <a:fontRef idx="minor">
-            <a:schemeClr val="lt1"/>
-          </a:fontRef>
-        </p:style>
-        <p:txBody>
-          <a:bodyPr rtlCol="0" anchor="ctr"/>
-          <a:lstStyle/>
-          <a:p>
-            <a:pPr algn="ctr"/>
-          </a:p>
-        </p:txBody>
-      </p:sp>
-      <p:sp>
-        <p:nvSpPr>
-          <p:cNvPr id="8" name="TextBox 7"/>
-          <p:cNvSpPr txBox="1"/>
-          <p:nvPr/>
-        </p:nvSpPr>
-        <p:spPr>
-          <a:xfrm>
-            <a:off x="6574536" y="3538728"/>
-            <a:ext cx="4608576" cy="1289304"/>
-          </a:xfrm>
-          <a:prstGeom prst="rect">
-            <a:avLst/>
-          </a:prstGeom>
-          <a:noFill/>
-        </p:spPr>
-        <p:txBody>
-          <a:bodyPr wrap="square" lIns="0" rIns="0" tIns="0" bIns="0">
-            <a:spAutoFit/>
-          </a:bodyPr>
-          <a:lstStyle/>
-          <a:p>
-            <a:pPr>
-              <a:spcAft>
-                <a:spcPts val="600"/>
-              </a:spcAft>
-              <a:defRPr sz="1050" b="1">
-                <a:solidFill>
-                  <a:srgbClr val="D99B26"/>
-                </a:solidFill>
-                <a:latin typeface="Helvetica Neue"/>
-              </a:defRPr>
-            </a:pPr>
-            <a:r>
-              <a:t>LIDERAZGO DE LA PRÁCTICA</a:t>
-            </a:r>
-          </a:p>
-          <a:p>
-            <a:pPr>
-              <a:spcAft>
-                <a:spcPts val="400"/>
-              </a:spcAft>
-              <a:defRPr sz="1300" b="1">
-                <a:solidFill>
-                  <a:srgbClr val="16161A"/>
-                </a:solidFill>
-                <a:latin typeface="Helvetica Neue"/>
-              </a:defRPr>
-            </a:pPr>
-            <a:r>
-              <a:t>Roberto Guido  —  Fundador e Ingeniero Principal</a:t>
-            </a:r>
-          </a:p>
-          <a:p>
-            <a:pPr>
-              <a:defRPr sz="1150">
-                <a:solidFill>
-                  <a:srgbClr val="454337"/>
-                </a:solidFill>
-                <a:latin typeface="Helvetica Neue"/>
-              </a:defRPr>
-            </a:pPr>
-            <a:r>
-              <a:t>Ingeniero Eléctrico (UC San Diego)  ·  MBA (NYU Stern)</a:t>
-            </a:r>
-            <a:br/>
-            <a:r>
-              <a:t>Operando en San Diego, CA y Tijuana, MX</a:t>
-            </a:r>
-          </a:p>
-        </p:txBody>
-      </p:sp>
-      <p:sp>
-        <p:nvSpPr>
-          <p:cNvPr id="9" name="Rounded Rectangle 8"/>
-          <p:cNvSpPr/>
-          <p:nvPr/>
-        </p:nvSpPr>
-        <p:spPr>
-          <a:xfrm>
-            <a:off x="731520" y="5166360"/>
-            <a:ext cx="2514600" cy="960120"/>
-          </a:xfrm>
-          <a:prstGeom prst="roundRect">
-            <a:avLst/>
-          </a:prstGeom>
-          <a:solidFill>
-            <a:srgbClr val="FFFFFF"/>
-          </a:solidFill>
-          <a:ln w="12700">
-            <a:solidFill>
-              <a:srgbClr val="E2DDD0"/>
-            </a:solidFill>
-          </a:ln>
-        </p:spPr>
-        <p:style>
-          <a:lnRef idx="1">
-            <a:schemeClr val="accent1"/>
-          </a:lnRef>
-          <a:fillRef idx="3">
-            <a:schemeClr val="accent1"/>
-          </a:fillRef>
-          <a:effectRef idx="2">
-            <a:schemeClr val="accent1"/>
-          </a:effectRef>
-          <a:fontRef idx="minor">
-            <a:schemeClr val="lt1"/>
-          </a:fontRef>
-        </p:style>
-        <p:txBody>
-          <a:bodyPr rtlCol="0" anchor="ctr"/>
-          <a:lstStyle/>
-          <a:p>
-            <a:pPr algn="ctr"/>
-          </a:p>
-        </p:txBody>
-      </p:sp>
-      <p:sp>
-        <p:nvSpPr>
-          <p:cNvPr id="10" name="TextBox 9"/>
-          <p:cNvSpPr txBox="1"/>
-          <p:nvPr/>
-        </p:nvSpPr>
-        <p:spPr>
-          <a:xfrm>
-            <a:off x="896112" y="5257800"/>
-            <a:ext cx="2185416" cy="777240"/>
-          </a:xfrm>
-          <a:prstGeom prst="rect">
-            <a:avLst/>
-          </a:prstGeom>
-          <a:noFill/>
-        </p:spPr>
-        <p:txBody>
-          <a:bodyPr wrap="square" lIns="0" rIns="0" tIns="0" bIns="0">
-            <a:spAutoFit/>
-          </a:bodyPr>
-          <a:lstStyle/>
-          <a:p>
-            <a:pPr>
-              <a:defRPr sz="1200" b="1">
-                <a:solidFill>
-                  <a:srgbClr val="16161A"/>
-                </a:solidFill>
-                <a:latin typeface="Helvetica Neue"/>
-              </a:defRPr>
-            </a:pPr>
-            <a:r>
-              <a:t>En producción.</a:t>
-            </a:r>
-          </a:p>
-          <a:p>
-            <a:pPr>
-              <a:spcBef>
-                <a:spcPts val="200"/>
-              </a:spcBef>
-              <a:defRPr sz="1000">
-                <a:solidFill>
-                  <a:srgbClr val="454337"/>
-                </a:solidFill>
-                <a:latin typeface="Helvetica Neue"/>
-              </a:defRPr>
-            </a:pPr>
-            <a:r>
-              <a:t>Usuarios reales hoy en nuestros productos.</a:t>
-            </a:r>
-          </a:p>
-        </p:txBody>
-      </p:sp>
-      <p:sp>
-        <p:nvSpPr>
-          <p:cNvPr id="11" name="Rounded Rectangle 10"/>
-          <p:cNvSpPr/>
-          <p:nvPr/>
-        </p:nvSpPr>
-        <p:spPr>
-          <a:xfrm>
-            <a:off x="3429000" y="5166360"/>
-            <a:ext cx="2514600" cy="960120"/>
-          </a:xfrm>
-          <a:prstGeom prst="roundRect">
-            <a:avLst/>
-          </a:prstGeom>
-          <a:solidFill>
-            <a:srgbClr val="FFFFFF"/>
-          </a:solidFill>
-          <a:ln w="12700">
-            <a:solidFill>
-              <a:srgbClr val="E2DDD0"/>
-            </a:solidFill>
-          </a:ln>
-        </p:spPr>
-        <p:style>
-          <a:lnRef idx="1">
-            <a:schemeClr val="accent1"/>
-          </a:lnRef>
-          <a:fillRef idx="3">
-            <a:schemeClr val="accent1"/>
-          </a:fillRef>
-          <a:effectRef idx="2">
-            <a:schemeClr val="accent1"/>
-          </a:effectRef>
-          <a:fontRef idx="minor">
-            <a:schemeClr val="lt1"/>
-          </a:fontRef>
-        </p:style>
-        <p:txBody>
-          <a:bodyPr rtlCol="0" anchor="ctr"/>
-          <a:lstStyle/>
-          <a:p>
-            <a:pPr algn="ctr"/>
-          </a:p>
-        </p:txBody>
-      </p:sp>
-      <p:sp>
-        <p:nvSpPr>
-          <p:cNvPr id="12" name="TextBox 11"/>
-          <p:cNvSpPr txBox="1"/>
-          <p:nvPr/>
-        </p:nvSpPr>
-        <p:spPr>
-          <a:xfrm>
-            <a:off x="3593592" y="5257800"/>
-            <a:ext cx="2185416" cy="777240"/>
-          </a:xfrm>
-          <a:prstGeom prst="rect">
-            <a:avLst/>
-          </a:prstGeom>
-          <a:noFill/>
-        </p:spPr>
-        <p:txBody>
-          <a:bodyPr wrap="square" lIns="0" rIns="0" tIns="0" bIns="0">
-            <a:spAutoFit/>
-          </a:bodyPr>
-          <a:lstStyle/>
-          <a:p>
-            <a:pPr>
-              <a:defRPr sz="1200" b="1">
-                <a:solidFill>
-                  <a:srgbClr val="16161A"/>
-                </a:solidFill>
-                <a:latin typeface="Helvetica Neue"/>
-              </a:defRPr>
-            </a:pPr>
-            <a:r>
-              <a:t>Equipo senior.</a:t>
-            </a:r>
-          </a:p>
-          <a:p>
-            <a:pPr>
-              <a:spcBef>
-                <a:spcPts val="200"/>
-              </a:spcBef>
-              <a:defRPr sz="1000">
-                <a:solidFill>
-                  <a:srgbClr val="454337"/>
-                </a:solidFill>
-                <a:latin typeface="Helvetica Neue"/>
-              </a:defRPr>
-            </a:pPr>
-            <a:r>
-              <a:t>Quienes presentan tu proyecto lo construyen.</a:t>
-            </a:r>
-          </a:p>
-        </p:txBody>
-      </p:sp>
-      <p:sp>
-        <p:nvSpPr>
-          <p:cNvPr id="13" name="Rounded Rectangle 12"/>
-          <p:cNvSpPr/>
-          <p:nvPr/>
-        </p:nvSpPr>
-        <p:spPr>
-          <a:xfrm>
-            <a:off x="6126480" y="5166360"/>
-            <a:ext cx="2514600" cy="960120"/>
-          </a:xfrm>
-          <a:prstGeom prst="roundRect">
-            <a:avLst/>
-          </a:prstGeom>
-          <a:solidFill>
-            <a:srgbClr val="FFFFFF"/>
-          </a:solidFill>
-          <a:ln w="12700">
-            <a:solidFill>
-              <a:srgbClr val="E2DDD0"/>
-            </a:solidFill>
-          </a:ln>
-        </p:spPr>
-        <p:style>
-          <a:lnRef idx="1">
-            <a:schemeClr val="accent1"/>
-          </a:lnRef>
-          <a:fillRef idx="3">
-            <a:schemeClr val="accent1"/>
-          </a:fillRef>
-          <a:effectRef idx="2">
-            <a:schemeClr val="accent1"/>
-          </a:effectRef>
-          <a:fontRef idx="minor">
-            <a:schemeClr val="lt1"/>
-          </a:fontRef>
-        </p:style>
-        <p:txBody>
-          <a:bodyPr rtlCol="0" anchor="ctr"/>
-          <a:lstStyle/>
-          <a:p>
-            <a:pPr algn="ctr"/>
-          </a:p>
-        </p:txBody>
-      </p:sp>
-      <p:sp>
-        <p:nvSpPr>
-          <p:cNvPr id="14" name="TextBox 13"/>
-          <p:cNvSpPr txBox="1"/>
-          <p:nvPr/>
-        </p:nvSpPr>
-        <p:spPr>
-          <a:xfrm>
-            <a:off x="6291072" y="5257800"/>
-            <a:ext cx="2185416" cy="777240"/>
-          </a:xfrm>
-          <a:prstGeom prst="rect">
-            <a:avLst/>
-          </a:prstGeom>
-          <a:noFill/>
-        </p:spPr>
-        <p:txBody>
-          <a:bodyPr wrap="square" lIns="0" rIns="0" tIns="0" bIns="0">
-            <a:spAutoFit/>
-          </a:bodyPr>
-          <a:lstStyle/>
-          <a:p>
-            <a:pPr>
-              <a:defRPr sz="1200" b="1">
-                <a:solidFill>
-                  <a:srgbClr val="16161A"/>
-                </a:solidFill>
-                <a:latin typeface="Helvetica Neue"/>
-              </a:defRPr>
-            </a:pPr>
-            <a:r>
-              <a:t>Código primero.</a:t>
-            </a:r>
-          </a:p>
-          <a:p>
-            <a:pPr>
-              <a:spcBef>
-                <a:spcPts val="200"/>
-              </a:spcBef>
-              <a:defRPr sz="1000">
-                <a:solidFill>
-                  <a:srgbClr val="454337"/>
-                </a:solidFill>
-                <a:latin typeface="Helvetica Neue"/>
-              </a:defRPr>
-            </a:pPr>
-            <a:r>
-              <a:t>Software funcional antes que diapositivas.</a:t>
-            </a:r>
-          </a:p>
-        </p:txBody>
-      </p:sp>
-      <p:sp>
-        <p:nvSpPr>
-          <p:cNvPr id="15" name="Rounded Rectangle 14"/>
-          <p:cNvSpPr/>
-          <p:nvPr/>
-        </p:nvSpPr>
-        <p:spPr>
-          <a:xfrm>
-            <a:off x="8823960" y="5166360"/>
-            <a:ext cx="2514600" cy="960120"/>
-          </a:xfrm>
-          <a:prstGeom prst="roundRect">
-            <a:avLst/>
-          </a:prstGeom>
-          <a:solidFill>
-            <a:srgbClr val="FFFFFF"/>
-          </a:solidFill>
-          <a:ln w="12700">
-            <a:solidFill>
-              <a:srgbClr val="E2DDD0"/>
-            </a:solidFill>
-          </a:ln>
-        </p:spPr>
-        <p:style>
-          <a:lnRef idx="1">
-            <a:schemeClr val="accent1"/>
-          </a:lnRef>
-          <a:fillRef idx="3">
-            <a:schemeClr val="accent1"/>
-          </a:fillRef>
-          <a:effectRef idx="2">
-            <a:schemeClr val="accent1"/>
-          </a:effectRef>
-          <a:fontRef idx="minor">
-            <a:schemeClr val="lt1"/>
-          </a:fontRef>
-        </p:style>
-        <p:txBody>
-          <a:bodyPr rtlCol="0" anchor="ctr"/>
-          <a:lstStyle/>
-          <a:p>
-            <a:pPr algn="ctr"/>
-          </a:p>
-        </p:txBody>
-      </p:sp>
-      <p:sp>
-        <p:nvSpPr>
-          <p:cNvPr id="16" name="TextBox 15"/>
-          <p:cNvSpPr txBox="1"/>
-          <p:nvPr/>
-        </p:nvSpPr>
-        <p:spPr>
-          <a:xfrm>
-            <a:off x="8988552" y="5257800"/>
-            <a:ext cx="2185416" cy="777240"/>
-          </a:xfrm>
-          <a:prstGeom prst="rect">
-            <a:avLst/>
-          </a:prstGeom>
-          <a:noFill/>
-        </p:spPr>
-        <p:txBody>
-          <a:bodyPr wrap="square" lIns="0" rIns="0" tIns="0" bIns="0">
-            <a:spAutoFit/>
-          </a:bodyPr>
-          <a:lstStyle/>
-          <a:p>
-            <a:pPr>
-              <a:defRPr sz="1200" b="1">
-                <a:solidFill>
-                  <a:srgbClr val="16161A"/>
-                </a:solidFill>
-                <a:latin typeface="Helvetica Neue"/>
-              </a:defRPr>
-            </a:pPr>
-            <a:r>
-              <a:t>Un solo equipo.</a:t>
-            </a:r>
-          </a:p>
-          <a:p>
-            <a:pPr>
-              <a:spcBef>
-                <a:spcPts val="200"/>
-              </a:spcBef>
-              <a:defRPr sz="1000">
-                <a:solidFill>
-                  <a:srgbClr val="454337"/>
-                </a:solidFill>
-                <a:latin typeface="Helvetica Neue"/>
-              </a:defRPr>
-            </a:pPr>
-            <a:r>
-              <a:t>Interfaces y automatizaciones: mismo equipo.</a:t>
-            </a:r>
-          </a:p>
-        </p:txBody>
-      </p:sp>
-      <p:sp>
-        <p:nvSpPr>
-          <p:cNvPr id="17" name="Rectangle 16"/>
-          <p:cNvSpPr/>
-          <p:nvPr/>
-        </p:nvSpPr>
-        <p:spPr>
-          <a:xfrm>
-            <a:off x="731520" y="6263640"/>
+            <a:off x="731520" y="3429000"/>
             <a:ext cx="10728655" cy="12700"/>
           </a:xfrm>
           <a:prstGeom prst="rect">
@@ -3858,14 +3256,14 @@
       </p:sp>
       <p:sp>
         <p:nvSpPr>
-          <p:cNvPr id="18" name="TextBox 17"/>
+          <p:cNvPr id="6" name="TextBox 5"/>
           <p:cNvSpPr txBox="1"/>
           <p:nvPr/>
         </p:nvSpPr>
         <p:spPr>
           <a:xfrm>
-            <a:off x="731520" y="6355080"/>
-            <a:ext cx="7315200" cy="320040"/>
+            <a:off x="731520" y="3611880"/>
+            <a:ext cx="5157216" cy="1371600"/>
           </a:xfrm>
           <a:prstGeom prst="rect">
             <a:avLst/>
@@ -3879,6 +3277,424 @@
           <a:lstStyle/>
           <a:p>
             <a:pPr>
+              <a:spcAft>
+                <a:spcPts val="600"/>
+              </a:spcAft>
+              <a:defRPr sz="1050" b="1">
+                <a:solidFill>
+                  <a:srgbClr val="2B59D9"/>
+                </a:solidFill>
+                <a:latin typeface="Helvetica Neue"/>
+              </a:defRPr>
+            </a:pPr>
+            <a:r>
+              <a:t>CAPACIDADES CLAVE</a:t>
+            </a:r>
+          </a:p>
+          <a:p>
+            <a:pPr>
+              <a:defRPr sz="1250">
+                <a:solidFill>
+                  <a:srgbClr val="16161A"/>
+                </a:solidFill>
+                <a:latin typeface="Helvetica Neue"/>
+              </a:defRPr>
+            </a:pPr>
+            <a:r>
+              <a:t>Aplicaciones Web en React y TypeScript  ·  Integraciones en Workday Finance y Adaptive  ·  Agentes de IA con Supervisión Humana (HITL)</a:t>
+            </a:r>
+          </a:p>
+        </p:txBody>
+      </p:sp>
+      <p:sp>
+        <p:nvSpPr>
+          <p:cNvPr id="7" name="TextBox 6"/>
+          <p:cNvSpPr txBox="1"/>
+          <p:nvPr/>
+        </p:nvSpPr>
+        <p:spPr>
+          <a:xfrm>
+            <a:off x="6300216" y="3611880"/>
+            <a:ext cx="5157216" cy="1371600"/>
+          </a:xfrm>
+          <a:prstGeom prst="rect">
+            <a:avLst/>
+          </a:prstGeom>
+          <a:noFill/>
+        </p:spPr>
+        <p:txBody>
+          <a:bodyPr wrap="square" lIns="0" rIns="0" tIns="0" bIns="0">
+            <a:spAutoFit/>
+          </a:bodyPr>
+          <a:lstStyle/>
+          <a:p>
+            <a:pPr>
+              <a:spcAft>
+                <a:spcPts val="600"/>
+              </a:spcAft>
+              <a:defRPr sz="1050" b="1">
+                <a:solidFill>
+                  <a:srgbClr val="D99B26"/>
+                </a:solidFill>
+                <a:latin typeface="Helvetica Neue"/>
+              </a:defRPr>
+            </a:pPr>
+            <a:r>
+              <a:t>LIDERAZGO DE LA PRÁCTICA</a:t>
+            </a:r>
+          </a:p>
+          <a:p>
+            <a:pPr>
+              <a:spcAft>
+                <a:spcPts val="400"/>
+              </a:spcAft>
+              <a:defRPr sz="1300" b="1">
+                <a:solidFill>
+                  <a:srgbClr val="16161A"/>
+                </a:solidFill>
+                <a:latin typeface="Helvetica Neue"/>
+              </a:defRPr>
+            </a:pPr>
+            <a:r>
+              <a:t>Roberto Guido  —  Fundador e Ingeniero Principal</a:t>
+            </a:r>
+          </a:p>
+          <a:p>
+            <a:pPr>
+              <a:defRPr sz="1150">
+                <a:solidFill>
+                  <a:srgbClr val="454337"/>
+                </a:solidFill>
+                <a:latin typeface="Helvetica Neue"/>
+              </a:defRPr>
+            </a:pPr>
+            <a:r>
+              <a:t>Ingeniero Eléctrico (UC San Diego)  ·  MBA (NYU Stern)</a:t>
+            </a:r>
+            <a:br/>
+            <a:r>
+              <a:t>Operando en San Diego, CA y Tijuana, MX</a:t>
+            </a:r>
+          </a:p>
+        </p:txBody>
+      </p:sp>
+      <p:sp>
+        <p:nvSpPr>
+          <p:cNvPr id="8" name="Rectangle 7"/>
+          <p:cNvSpPr/>
+          <p:nvPr/>
+        </p:nvSpPr>
+        <p:spPr>
+          <a:xfrm>
+            <a:off x="731520" y="4983480"/>
+            <a:ext cx="10728655" cy="12700"/>
+          </a:xfrm>
+          <a:prstGeom prst="rect">
+            <a:avLst/>
+          </a:prstGeom>
+          <a:solidFill>
+            <a:srgbClr val="E2DDD0"/>
+          </a:solidFill>
+          <a:ln>
+            <a:noFill/>
+          </a:ln>
+        </p:spPr>
+        <p:style>
+          <a:lnRef idx="1">
+            <a:schemeClr val="accent1"/>
+          </a:lnRef>
+          <a:fillRef idx="3">
+            <a:schemeClr val="accent1"/>
+          </a:fillRef>
+          <a:effectRef idx="2">
+            <a:schemeClr val="accent1"/>
+          </a:effectRef>
+          <a:fontRef idx="minor">
+            <a:schemeClr val="lt1"/>
+          </a:fontRef>
+        </p:style>
+        <p:txBody>
+          <a:bodyPr rtlCol="0" anchor="ctr"/>
+          <a:lstStyle/>
+          <a:p>
+            <a:pPr algn="ctr"/>
+          </a:p>
+        </p:txBody>
+      </p:sp>
+      <p:sp>
+        <p:nvSpPr>
+          <p:cNvPr id="9" name="TextBox 8"/>
+          <p:cNvSpPr txBox="1"/>
+          <p:nvPr/>
+        </p:nvSpPr>
+        <p:spPr>
+          <a:xfrm>
+            <a:off x="731520" y="5120640"/>
+            <a:ext cx="2514600" cy="1005840"/>
+          </a:xfrm>
+          <a:prstGeom prst="rect">
+            <a:avLst/>
+          </a:prstGeom>
+          <a:noFill/>
+        </p:spPr>
+        <p:txBody>
+          <a:bodyPr wrap="square" lIns="0" rIns="0" tIns="0" bIns="0">
+            <a:spAutoFit/>
+          </a:bodyPr>
+          <a:lstStyle/>
+          <a:p>
+            <a:pPr>
+              <a:spcAft>
+                <a:spcPts val="200"/>
+              </a:spcAft>
+              <a:defRPr sz="1300" b="1">
+                <a:solidFill>
+                  <a:srgbClr val="16161A"/>
+                </a:solidFill>
+                <a:latin typeface="Helvetica Neue"/>
+              </a:defRPr>
+            </a:pPr>
+            <a:r>
+              <a:t>En producción.</a:t>
+            </a:r>
+          </a:p>
+          <a:p>
+            <a:pPr>
+              <a:defRPr sz="1050">
+                <a:solidFill>
+                  <a:srgbClr val="454337"/>
+                </a:solidFill>
+                <a:latin typeface="Helvetica Neue"/>
+              </a:defRPr>
+            </a:pPr>
+            <a:r>
+              <a:t>Usuarios reales hoy en nuestros productos.</a:t>
+            </a:r>
+          </a:p>
+        </p:txBody>
+      </p:sp>
+      <p:sp>
+        <p:nvSpPr>
+          <p:cNvPr id="10" name="TextBox 9"/>
+          <p:cNvSpPr txBox="1"/>
+          <p:nvPr/>
+        </p:nvSpPr>
+        <p:spPr>
+          <a:xfrm>
+            <a:off x="3429000" y="5120640"/>
+            <a:ext cx="2514600" cy="1005840"/>
+          </a:xfrm>
+          <a:prstGeom prst="rect">
+            <a:avLst/>
+          </a:prstGeom>
+          <a:noFill/>
+        </p:spPr>
+        <p:txBody>
+          <a:bodyPr wrap="square" lIns="0" rIns="0" tIns="0" bIns="0">
+            <a:spAutoFit/>
+          </a:bodyPr>
+          <a:lstStyle/>
+          <a:p>
+            <a:pPr>
+              <a:spcAft>
+                <a:spcPts val="200"/>
+              </a:spcAft>
+              <a:defRPr sz="1300" b="1">
+                <a:solidFill>
+                  <a:srgbClr val="16161A"/>
+                </a:solidFill>
+                <a:latin typeface="Helvetica Neue"/>
+              </a:defRPr>
+            </a:pPr>
+            <a:r>
+              <a:t>Equipo senior.</a:t>
+            </a:r>
+          </a:p>
+          <a:p>
+            <a:pPr>
+              <a:defRPr sz="1050">
+                <a:solidFill>
+                  <a:srgbClr val="454337"/>
+                </a:solidFill>
+                <a:latin typeface="Helvetica Neue"/>
+              </a:defRPr>
+            </a:pPr>
+            <a:r>
+              <a:t>Quienes presentan tu proyecto lo construyen.</a:t>
+            </a:r>
+          </a:p>
+        </p:txBody>
+      </p:sp>
+      <p:sp>
+        <p:nvSpPr>
+          <p:cNvPr id="11" name="TextBox 10"/>
+          <p:cNvSpPr txBox="1"/>
+          <p:nvPr/>
+        </p:nvSpPr>
+        <p:spPr>
+          <a:xfrm>
+            <a:off x="6126480" y="5120640"/>
+            <a:ext cx="2514600" cy="1005840"/>
+          </a:xfrm>
+          <a:prstGeom prst="rect">
+            <a:avLst/>
+          </a:prstGeom>
+          <a:noFill/>
+        </p:spPr>
+        <p:txBody>
+          <a:bodyPr wrap="square" lIns="0" rIns="0" tIns="0" bIns="0">
+            <a:spAutoFit/>
+          </a:bodyPr>
+          <a:lstStyle/>
+          <a:p>
+            <a:pPr>
+              <a:spcAft>
+                <a:spcPts val="200"/>
+              </a:spcAft>
+              <a:defRPr sz="1300" b="1">
+                <a:solidFill>
+                  <a:srgbClr val="16161A"/>
+                </a:solidFill>
+                <a:latin typeface="Helvetica Neue"/>
+              </a:defRPr>
+            </a:pPr>
+            <a:r>
+              <a:t>Código primero.</a:t>
+            </a:r>
+          </a:p>
+          <a:p>
+            <a:pPr>
+              <a:defRPr sz="1050">
+                <a:solidFill>
+                  <a:srgbClr val="454337"/>
+                </a:solidFill>
+                <a:latin typeface="Helvetica Neue"/>
+              </a:defRPr>
+            </a:pPr>
+            <a:r>
+              <a:t>Software funcional antes que diapositivas.</a:t>
+            </a:r>
+          </a:p>
+        </p:txBody>
+      </p:sp>
+      <p:sp>
+        <p:nvSpPr>
+          <p:cNvPr id="12" name="TextBox 11"/>
+          <p:cNvSpPr txBox="1"/>
+          <p:nvPr/>
+        </p:nvSpPr>
+        <p:spPr>
+          <a:xfrm>
+            <a:off x="8823960" y="5120640"/>
+            <a:ext cx="2514600" cy="1005840"/>
+          </a:xfrm>
+          <a:prstGeom prst="rect">
+            <a:avLst/>
+          </a:prstGeom>
+          <a:noFill/>
+        </p:spPr>
+        <p:txBody>
+          <a:bodyPr wrap="square" lIns="0" rIns="0" tIns="0" bIns="0">
+            <a:spAutoFit/>
+          </a:bodyPr>
+          <a:lstStyle/>
+          <a:p>
+            <a:pPr>
+              <a:spcAft>
+                <a:spcPts val="200"/>
+              </a:spcAft>
+              <a:defRPr sz="1300" b="1">
+                <a:solidFill>
+                  <a:srgbClr val="16161A"/>
+                </a:solidFill>
+                <a:latin typeface="Helvetica Neue"/>
+              </a:defRPr>
+            </a:pPr>
+            <a:r>
+              <a:t>Un solo equipo.</a:t>
+            </a:r>
+          </a:p>
+          <a:p>
+            <a:pPr>
+              <a:defRPr sz="1050">
+                <a:solidFill>
+                  <a:srgbClr val="454337"/>
+                </a:solidFill>
+                <a:latin typeface="Helvetica Neue"/>
+              </a:defRPr>
+            </a:pPr>
+            <a:r>
+              <a:t>Interfaces y automatizaciones: mismo equipo.</a:t>
+            </a:r>
+          </a:p>
+        </p:txBody>
+      </p:sp>
+      <p:sp>
+        <p:nvSpPr>
+          <p:cNvPr id="13" name="Rectangle 12"/>
+          <p:cNvSpPr/>
+          <p:nvPr/>
+        </p:nvSpPr>
+        <p:spPr>
+          <a:xfrm>
+            <a:off x="731520" y="6263640"/>
+            <a:ext cx="10728655" cy="12700"/>
+          </a:xfrm>
+          <a:prstGeom prst="rect">
+            <a:avLst/>
+          </a:prstGeom>
+          <a:solidFill>
+            <a:srgbClr val="E2DDD0"/>
+          </a:solidFill>
+          <a:ln>
+            <a:noFill/>
+          </a:ln>
+        </p:spPr>
+        <p:style>
+          <a:lnRef idx="1">
+            <a:schemeClr val="accent1"/>
+          </a:lnRef>
+          <a:fillRef idx="3">
+            <a:schemeClr val="accent1"/>
+          </a:fillRef>
+          <a:effectRef idx="2">
+            <a:schemeClr val="accent1"/>
+          </a:effectRef>
+          <a:fontRef idx="minor">
+            <a:schemeClr val="lt1"/>
+          </a:fontRef>
+        </p:style>
+        <p:txBody>
+          <a:bodyPr rtlCol="0" anchor="ctr"/>
+          <a:lstStyle/>
+          <a:p>
+            <a:pPr algn="ctr"/>
+          </a:p>
+        </p:txBody>
+      </p:sp>
+      <p:sp>
+        <p:nvSpPr>
+          <p:cNvPr id="14" name="TextBox 13"/>
+          <p:cNvSpPr txBox="1"/>
+          <p:nvPr/>
+        </p:nvSpPr>
+        <p:spPr>
+          <a:xfrm>
+            <a:off x="731520" y="6355080"/>
+            <a:ext cx="7315200" cy="320040"/>
+          </a:xfrm>
+          <a:prstGeom prst="rect">
+            <a:avLst/>
+          </a:prstGeom>
+          <a:noFill/>
+        </p:spPr>
+        <p:txBody>
+          <a:bodyPr wrap="square" lIns="0" rIns="0" tIns="0" bIns="0">
+            <a:spAutoFit/>
+          </a:bodyPr>
+          <a:lstStyle/>
+          <a:p>
+            <a:pPr>
               <a:defRPr sz="1000">
                 <a:solidFill>
                   <a:srgbClr val="736E62"/>
@@ -3894,7 +3710,7 @@
       </p:sp>
       <p:sp>
         <p:nvSpPr>
-          <p:cNvPr id="19" name="TextBox 18"/>
+          <p:cNvPr id="15" name="TextBox 14"/>
           <p:cNvSpPr txBox="1"/>
           <p:nvPr/>
         </p:nvSpPr>
@@ -3962,7 +3778,7 @@
         </p:nvSpPr>
         <p:spPr>
           <a:xfrm>
-            <a:off x="731520" y="502920"/>
+            <a:off x="731520" y="548640"/>
             <a:ext cx="10728655" cy="228600"/>
           </a:xfrm>
           <a:prstGeom prst="rect">
@@ -3998,7 +3814,7 @@
         </p:nvSpPr>
         <p:spPr>
           <a:xfrm>
-            <a:off x="731520" y="777240"/>
+            <a:off x="731520" y="822960"/>
             <a:ext cx="10728655" cy="685800"/>
           </a:xfrm>
           <a:prstGeom prst="rect">
@@ -4028,25 +3844,23 @@
       </p:sp>
       <p:sp>
         <p:nvSpPr>
-          <p:cNvPr id="4" name="Rounded Rectangle 3"/>
+          <p:cNvPr id="4" name="Rectangle 3"/>
           <p:cNvSpPr/>
           <p:nvPr/>
         </p:nvSpPr>
         <p:spPr>
           <a:xfrm>
             <a:off x="731520" y="1691640"/>
-            <a:ext cx="3328416" cy="4297680"/>
-          </a:xfrm>
-          <a:prstGeom prst="roundRect">
+            <a:ext cx="3328416" cy="25400"/>
+          </a:xfrm>
+          <a:prstGeom prst="rect">
             <a:avLst/>
           </a:prstGeom>
           <a:solidFill>
-            <a:srgbClr val="FFFFFF"/>
+            <a:srgbClr val="2B59D9"/>
           </a:solidFill>
-          <a:ln w="12700">
-            <a:solidFill>
-              <a:srgbClr val="E2DDD0"/>
-            </a:solidFill>
+          <a:ln>
+            <a:noFill/>
           </a:ln>
         </p:spPr>
         <p:style>
@@ -4079,8 +3893,8 @@
         </p:nvSpPr>
         <p:spPr>
           <a:xfrm>
-            <a:off x="1051560" y="2011680"/>
-            <a:ext cx="2688336" cy="3657600"/>
+            <a:off x="731520" y="1874520"/>
+            <a:ext cx="3328416" cy="4114800"/>
           </a:xfrm>
           <a:prstGeom prst="rect">
             <a:avLst/>
@@ -4095,7 +3909,7 @@
           <a:p>
             <a:pPr>
               <a:spcAft>
-                <a:spcPts val="1000"/>
+                <a:spcPts val="800"/>
               </a:spcAft>
               <a:defRPr sz="2000" b="1">
                 <a:solidFill>
@@ -4113,7 +3927,7 @@
               <a:spcAft>
                 <a:spcPts val="1000"/>
               </a:spcAft>
-              <a:defRPr sz="1800" b="1">
+              <a:defRPr sz="1900" b="1">
                 <a:solidFill>
                   <a:srgbClr val="16161A"/>
                 </a:solidFill>
@@ -4129,7 +3943,7 @@
               <a:spcAft>
                 <a:spcPts val="1600"/>
               </a:spcAft>
-              <a:defRPr sz="1200">
+              <a:defRPr sz="1250">
                 <a:solidFill>
                   <a:srgbClr val="454337"/>
                 </a:solidFill>
@@ -4145,7 +3959,7 @@
               <a:spcAft>
                 <a:spcPts val="800"/>
               </a:spcAft>
-              <a:defRPr sz="1150">
+              <a:defRPr sz="1200">
                 <a:solidFill>
                   <a:srgbClr val="16161A"/>
                 </a:solidFill>
@@ -4161,7 +3975,7 @@
               <a:spcAft>
                 <a:spcPts val="800"/>
               </a:spcAft>
-              <a:defRPr sz="1150">
+              <a:defRPr sz="1200">
                 <a:solidFill>
                   <a:srgbClr val="16161A"/>
                 </a:solidFill>
@@ -4177,7 +3991,7 @@
               <a:spcAft>
                 <a:spcPts val="800"/>
               </a:spcAft>
-              <a:defRPr sz="1150">
+              <a:defRPr sz="1200">
                 <a:solidFill>
                   <a:srgbClr val="16161A"/>
                 </a:solidFill>
@@ -4192,25 +4006,23 @@
       </p:sp>
       <p:sp>
         <p:nvSpPr>
-          <p:cNvPr id="6" name="Rounded Rectangle 5"/>
+          <p:cNvPr id="6" name="Rectangle 5"/>
           <p:cNvSpPr/>
           <p:nvPr/>
         </p:nvSpPr>
         <p:spPr>
           <a:xfrm>
             <a:off x="4334256" y="1691640"/>
-            <a:ext cx="3328416" cy="4297680"/>
-          </a:xfrm>
-          <a:prstGeom prst="roundRect">
+            <a:ext cx="3328416" cy="25400"/>
+          </a:xfrm>
+          <a:prstGeom prst="rect">
             <a:avLst/>
           </a:prstGeom>
           <a:solidFill>
-            <a:srgbClr val="FFFFFF"/>
+            <a:srgbClr val="D99B26"/>
           </a:solidFill>
-          <a:ln w="12700">
-            <a:solidFill>
-              <a:srgbClr val="E2DDD0"/>
-            </a:solidFill>
+          <a:ln>
+            <a:noFill/>
           </a:ln>
         </p:spPr>
         <p:style>
@@ -4243,8 +4055,8 @@
         </p:nvSpPr>
         <p:spPr>
           <a:xfrm>
-            <a:off x="4654296" y="2011680"/>
-            <a:ext cx="2688336" cy="3657600"/>
+            <a:off x="4334256" y="1874520"/>
+            <a:ext cx="3328416" cy="4114800"/>
           </a:xfrm>
           <a:prstGeom prst="rect">
             <a:avLst/>
@@ -4259,11 +4071,11 @@
           <a:p>
             <a:pPr>
               <a:spcAft>
-                <a:spcPts val="1000"/>
+                <a:spcPts val="800"/>
               </a:spcAft>
               <a:defRPr sz="2000" b="1">
                 <a:solidFill>
-                  <a:srgbClr val="2B59D9"/>
+                  <a:srgbClr val="D99B26"/>
                 </a:solidFill>
                 <a:latin typeface="Helvetica Neue"/>
               </a:defRPr>
@@ -4277,7 +4089,7 @@
               <a:spcAft>
                 <a:spcPts val="1000"/>
               </a:spcAft>
-              <a:defRPr sz="1800" b="1">
+              <a:defRPr sz="1900" b="1">
                 <a:solidFill>
                   <a:srgbClr val="16161A"/>
                 </a:solidFill>
@@ -4293,7 +4105,7 @@
               <a:spcAft>
                 <a:spcPts val="1600"/>
               </a:spcAft>
-              <a:defRPr sz="1200">
+              <a:defRPr sz="1250">
                 <a:solidFill>
                   <a:srgbClr val="454337"/>
                 </a:solidFill>
@@ -4309,7 +4121,7 @@
               <a:spcAft>
                 <a:spcPts val="800"/>
               </a:spcAft>
-              <a:defRPr sz="1150">
+              <a:defRPr sz="1200">
                 <a:solidFill>
                   <a:srgbClr val="16161A"/>
                 </a:solidFill>
@@ -4325,7 +4137,7 @@
               <a:spcAft>
                 <a:spcPts val="800"/>
               </a:spcAft>
-              <a:defRPr sz="1150">
+              <a:defRPr sz="1200">
                 <a:solidFill>
                   <a:srgbClr val="16161A"/>
                 </a:solidFill>
@@ -4341,7 +4153,7 @@
               <a:spcAft>
                 <a:spcPts val="800"/>
               </a:spcAft>
-              <a:defRPr sz="1150">
+              <a:defRPr sz="1200">
                 <a:solidFill>
                   <a:srgbClr val="16161A"/>
                 </a:solidFill>
@@ -4356,25 +4168,23 @@
       </p:sp>
       <p:sp>
         <p:nvSpPr>
-          <p:cNvPr id="8" name="Rounded Rectangle 7"/>
+          <p:cNvPr id="8" name="Rectangle 7"/>
           <p:cNvSpPr/>
           <p:nvPr/>
         </p:nvSpPr>
         <p:spPr>
           <a:xfrm>
             <a:off x="7936992" y="1691640"/>
-            <a:ext cx="3328416" cy="4297680"/>
-          </a:xfrm>
-          <a:prstGeom prst="roundRect">
+            <a:ext cx="3328416" cy="25400"/>
+          </a:xfrm>
+          <a:prstGeom prst="rect">
             <a:avLst/>
           </a:prstGeom>
           <a:solidFill>
-            <a:srgbClr val="FFFFFF"/>
+            <a:srgbClr val="2B59D9"/>
           </a:solidFill>
-          <a:ln w="12700">
-            <a:solidFill>
-              <a:srgbClr val="E2DDD0"/>
-            </a:solidFill>
+          <a:ln>
+            <a:noFill/>
           </a:ln>
         </p:spPr>
         <p:style>
@@ -4407,8 +4217,8 @@
         </p:nvSpPr>
         <p:spPr>
           <a:xfrm>
-            <a:off x="8257032" y="2011680"/>
-            <a:ext cx="2688336" cy="3657600"/>
+            <a:off x="7936992" y="1874520"/>
+            <a:ext cx="3328416" cy="4114800"/>
           </a:xfrm>
           <a:prstGeom prst="rect">
             <a:avLst/>
@@ -4423,7 +4233,7 @@
           <a:p>
             <a:pPr>
               <a:spcAft>
-                <a:spcPts val="1000"/>
+                <a:spcPts val="800"/>
               </a:spcAft>
               <a:defRPr sz="2000" b="1">
                 <a:solidFill>
@@ -4441,7 +4251,7 @@
               <a:spcAft>
                 <a:spcPts val="1000"/>
               </a:spcAft>
-              <a:defRPr sz="1800" b="1">
+              <a:defRPr sz="1900" b="1">
                 <a:solidFill>
                   <a:srgbClr val="16161A"/>
                 </a:solidFill>
@@ -4457,7 +4267,7 @@
               <a:spcAft>
                 <a:spcPts val="1600"/>
               </a:spcAft>
-              <a:defRPr sz="1200">
+              <a:defRPr sz="1250">
                 <a:solidFill>
                   <a:srgbClr val="454337"/>
                 </a:solidFill>
@@ -4473,7 +4283,7 @@
               <a:spcAft>
                 <a:spcPts val="800"/>
               </a:spcAft>
-              <a:defRPr sz="1150">
+              <a:defRPr sz="1200">
                 <a:solidFill>
                   <a:srgbClr val="16161A"/>
                 </a:solidFill>
@@ -4489,7 +4299,7 @@
               <a:spcAft>
                 <a:spcPts val="800"/>
               </a:spcAft>
-              <a:defRPr sz="1150">
+              <a:defRPr sz="1200">
                 <a:solidFill>
                   <a:srgbClr val="16161A"/>
                 </a:solidFill>
@@ -4505,7 +4315,7 @@
               <a:spcAft>
                 <a:spcPts val="800"/>
               </a:spcAft>
-              <a:defRPr sz="1150">
+              <a:defRPr sz="1200">
                 <a:solidFill>
                   <a:srgbClr val="16161A"/>
                 </a:solidFill>
@@ -4667,7 +4477,7 @@
         </p:nvSpPr>
         <p:spPr>
           <a:xfrm>
-            <a:off x="731520" y="502920"/>
+            <a:off x="731520" y="548640"/>
             <a:ext cx="10728655" cy="228600"/>
           </a:xfrm>
           <a:prstGeom prst="rect">
@@ -4703,7 +4513,7 @@
         </p:nvSpPr>
         <p:spPr>
           <a:xfrm>
-            <a:off x="731520" y="777240"/>
+            <a:off x="731520" y="822960"/>
             <a:ext cx="10728655" cy="685800"/>
           </a:xfrm>
           <a:prstGeom prst="rect">
@@ -4733,25 +4543,23 @@
       </p:sp>
       <p:sp>
         <p:nvSpPr>
-          <p:cNvPr id="4" name="Rounded Rectangle 3"/>
+          <p:cNvPr id="4" name="Rectangle 3"/>
           <p:cNvSpPr/>
           <p:nvPr/>
         </p:nvSpPr>
         <p:spPr>
           <a:xfrm>
             <a:off x="731520" y="1691640"/>
-            <a:ext cx="5157216" cy="4297680"/>
-          </a:xfrm>
-          <a:prstGeom prst="roundRect">
+            <a:ext cx="5157216" cy="25400"/>
+          </a:xfrm>
+          <a:prstGeom prst="rect">
             <a:avLst/>
           </a:prstGeom>
           <a:solidFill>
-            <a:srgbClr val="FFFFFF"/>
+            <a:srgbClr val="2B59D9"/>
           </a:solidFill>
-          <a:ln w="12700">
-            <a:solidFill>
-              <a:srgbClr val="E2DDD0"/>
-            </a:solidFill>
+          <a:ln>
+            <a:noFill/>
           </a:ln>
         </p:spPr>
         <p:style>
@@ -4784,8 +4592,8 @@
         </p:nvSpPr>
         <p:spPr>
           <a:xfrm>
-            <a:off x="1051560" y="2011680"/>
-            <a:ext cx="4517136" cy="3657600"/>
+            <a:off x="731520" y="1874520"/>
+            <a:ext cx="5157216" cy="4114800"/>
           </a:xfrm>
           <a:prstGeom prst="rect">
             <a:avLst/>
@@ -4800,7 +4608,7 @@
           <a:p>
             <a:pPr>
               <a:spcAft>
-                <a:spcPts val="1600"/>
+                <a:spcPts val="1400"/>
               </a:spcAft>
               <a:defRPr sz="1100" b="1">
                 <a:solidFill>
@@ -4818,7 +4626,7 @@
               <a:spcAft>
                 <a:spcPts val="1200"/>
               </a:spcAft>
-              <a:defRPr b="1" sz="1250">
+              <a:defRPr b="1" sz="1300">
                 <a:solidFill>
                   <a:srgbClr val="16161A"/>
                 </a:solidFill>
@@ -4842,7 +4650,7 @@
               <a:spcAft>
                 <a:spcPts val="1200"/>
               </a:spcAft>
-              <a:defRPr b="1" sz="1250">
+              <a:defRPr b="1" sz="1300">
                 <a:solidFill>
                   <a:srgbClr val="16161A"/>
                 </a:solidFill>
@@ -4866,7 +4674,7 @@
               <a:spcAft>
                 <a:spcPts val="1200"/>
               </a:spcAft>
-              <a:defRPr b="1" sz="1250">
+              <a:defRPr b="1" sz="1300">
                 <a:solidFill>
                   <a:srgbClr val="16161A"/>
                 </a:solidFill>
@@ -4890,7 +4698,7 @@
               <a:spcAft>
                 <a:spcPts val="1200"/>
               </a:spcAft>
-              <a:defRPr b="1" sz="1250">
+              <a:defRPr b="1" sz="1300">
                 <a:solidFill>
                   <a:srgbClr val="16161A"/>
                 </a:solidFill>
@@ -4913,25 +4721,23 @@
       </p:sp>
       <p:sp>
         <p:nvSpPr>
-          <p:cNvPr id="6" name="Rounded Rectangle 5"/>
+          <p:cNvPr id="6" name="Rectangle 5"/>
           <p:cNvSpPr/>
           <p:nvPr/>
         </p:nvSpPr>
         <p:spPr>
           <a:xfrm>
             <a:off x="6300216" y="1691640"/>
-            <a:ext cx="5157216" cy="4297680"/>
-          </a:xfrm>
-          <a:prstGeom prst="roundRect">
+            <a:ext cx="5157216" cy="25400"/>
+          </a:xfrm>
+          <a:prstGeom prst="rect">
             <a:avLst/>
           </a:prstGeom>
           <a:solidFill>
-            <a:srgbClr val="FFFFFF"/>
+            <a:srgbClr val="D99B26"/>
           </a:solidFill>
-          <a:ln w="12700">
-            <a:solidFill>
-              <a:srgbClr val="E2DDD0"/>
-            </a:solidFill>
+          <a:ln>
+            <a:noFill/>
           </a:ln>
         </p:spPr>
         <p:style>
@@ -4964,8 +4770,8 @@
         </p:nvSpPr>
         <p:spPr>
           <a:xfrm>
-            <a:off x="6620256" y="2011680"/>
-            <a:ext cx="4517136" cy="3657600"/>
+            <a:off x="6300216" y="1874520"/>
+            <a:ext cx="5157216" cy="4114800"/>
           </a:xfrm>
           <a:prstGeom prst="rect">
             <a:avLst/>
@@ -4980,7 +4786,7 @@
           <a:p>
             <a:pPr>
               <a:spcAft>
-                <a:spcPts val="1600"/>
+                <a:spcPts val="1400"/>
               </a:spcAft>
               <a:defRPr sz="1100" b="1">
                 <a:solidFill>
@@ -4998,7 +4804,7 @@
               <a:spcAft>
                 <a:spcPts val="1200"/>
               </a:spcAft>
-              <a:defRPr b="1" sz="1250">
+              <a:defRPr b="1" sz="1300">
                 <a:solidFill>
                   <a:srgbClr val="16161A"/>
                 </a:solidFill>
@@ -5022,7 +4828,7 @@
               <a:spcAft>
                 <a:spcPts val="1200"/>
               </a:spcAft>
-              <a:defRPr b="1" sz="1250">
+              <a:defRPr b="1" sz="1300">
                 <a:solidFill>
                   <a:srgbClr val="16161A"/>
                 </a:solidFill>
@@ -5046,7 +4852,7 @@
               <a:spcAft>
                 <a:spcPts val="1200"/>
               </a:spcAft>
-              <a:defRPr b="1" sz="1250">
+              <a:defRPr b="1" sz="1300">
                 <a:solidFill>
                   <a:srgbClr val="16161A"/>
                 </a:solidFill>
@@ -5070,7 +4876,7 @@
               <a:spcAft>
                 <a:spcPts val="1200"/>
               </a:spcAft>
-              <a:defRPr b="1" sz="1250">
+              <a:defRPr b="1" sz="1300">
                 <a:solidFill>
                   <a:srgbClr val="16161A"/>
                 </a:solidFill>
@@ -5240,7 +5046,7 @@
         </p:nvSpPr>
         <p:spPr>
           <a:xfrm>
-            <a:off x="731520" y="502920"/>
+            <a:off x="731520" y="548640"/>
             <a:ext cx="10728655" cy="228600"/>
           </a:xfrm>
           <a:prstGeom prst="rect">
@@ -5276,7 +5082,7 @@
         </p:nvSpPr>
         <p:spPr>
           <a:xfrm>
-            <a:off x="731520" y="777240"/>
+            <a:off x="731520" y="822960"/>
             <a:ext cx="10728655" cy="685800"/>
           </a:xfrm>
           <a:prstGeom prst="rect">
@@ -5306,25 +5112,23 @@
       </p:sp>
       <p:sp>
         <p:nvSpPr>
-          <p:cNvPr id="4" name="Rounded Rectangle 3"/>
+          <p:cNvPr id="4" name="Rectangle 3"/>
           <p:cNvSpPr/>
           <p:nvPr/>
         </p:nvSpPr>
         <p:spPr>
           <a:xfrm>
             <a:off x="731520" y="1691640"/>
-            <a:ext cx="10728655" cy="1261872"/>
-          </a:xfrm>
-          <a:prstGeom prst="roundRect">
+            <a:ext cx="38100" cy="1097280"/>
+          </a:xfrm>
+          <a:prstGeom prst="rect">
             <a:avLst/>
           </a:prstGeom>
           <a:solidFill>
-            <a:srgbClr val="FFFFFF"/>
+            <a:srgbClr val="2B59D9"/>
           </a:solidFill>
-          <a:ln w="12700">
-            <a:solidFill>
-              <a:srgbClr val="E2DDD0"/>
-            </a:solidFill>
+          <a:ln>
+            <a:noFill/>
           </a:ln>
         </p:spPr>
         <p:style>
@@ -5357,8 +5161,8 @@
         </p:nvSpPr>
         <p:spPr>
           <a:xfrm>
-            <a:off x="1051560" y="1874520"/>
-            <a:ext cx="10058400" cy="914400"/>
+            <a:off x="960120" y="1691640"/>
+            <a:ext cx="10500055" cy="1097280"/>
           </a:xfrm>
           <a:prstGeom prst="rect">
             <a:avLst/>
@@ -5373,7 +5177,7 @@
           <a:p>
             <a:pPr>
               <a:spcAft>
-                <a:spcPts val="600"/>
+                <a:spcPts val="400"/>
               </a:spcAft>
               <a:defRPr sz="1050" b="1">
                 <a:solidFill>
@@ -5388,7 +5192,7 @@
           </a:p>
           <a:p>
             <a:pPr>
-              <a:defRPr sz="1350">
+              <a:defRPr sz="1400">
                 <a:solidFill>
                   <a:srgbClr val="16161A"/>
                 </a:solidFill>
@@ -5403,25 +5207,23 @@
       </p:sp>
       <p:sp>
         <p:nvSpPr>
-          <p:cNvPr id="6" name="Rounded Rectangle 5"/>
+          <p:cNvPr id="6" name="Rectangle 5"/>
           <p:cNvSpPr/>
           <p:nvPr/>
         </p:nvSpPr>
         <p:spPr>
           <a:xfrm>
             <a:off x="731520" y="3108960"/>
-            <a:ext cx="10728655" cy="1261872"/>
-          </a:xfrm>
-          <a:prstGeom prst="roundRect">
+            <a:ext cx="38100" cy="1097280"/>
+          </a:xfrm>
+          <a:prstGeom prst="rect">
             <a:avLst/>
           </a:prstGeom>
           <a:solidFill>
-            <a:srgbClr val="FFFFFF"/>
+            <a:srgbClr val="D99B26"/>
           </a:solidFill>
-          <a:ln w="12700">
-            <a:solidFill>
-              <a:srgbClr val="E2DDD0"/>
-            </a:solidFill>
+          <a:ln>
+            <a:noFill/>
           </a:ln>
         </p:spPr>
         <p:style>
@@ -5454,8 +5256,8 @@
         </p:nvSpPr>
         <p:spPr>
           <a:xfrm>
-            <a:off x="1051560" y="3291840"/>
-            <a:ext cx="10058400" cy="914400"/>
+            <a:off x="960120" y="3108960"/>
+            <a:ext cx="10500055" cy="1097280"/>
           </a:xfrm>
           <a:prstGeom prst="rect">
             <a:avLst/>
@@ -5470,11 +5272,11 @@
           <a:p>
             <a:pPr>
               <a:spcAft>
-                <a:spcPts val="600"/>
+                <a:spcPts val="400"/>
               </a:spcAft>
               <a:defRPr sz="1050" b="1">
                 <a:solidFill>
-                  <a:srgbClr val="2B59D9"/>
+                  <a:srgbClr val="D99B26"/>
                 </a:solidFill>
                 <a:latin typeface="Helvetica Neue"/>
               </a:defRPr>
@@ -5485,7 +5287,7 @@
           </a:p>
           <a:p>
             <a:pPr>
-              <a:defRPr sz="1350">
+              <a:defRPr sz="1400">
                 <a:solidFill>
                   <a:srgbClr val="16161A"/>
                 </a:solidFill>
@@ -5500,25 +5302,23 @@
       </p:sp>
       <p:sp>
         <p:nvSpPr>
-          <p:cNvPr id="8" name="Rounded Rectangle 7"/>
+          <p:cNvPr id="8" name="Rectangle 7"/>
           <p:cNvSpPr/>
           <p:nvPr/>
         </p:nvSpPr>
         <p:spPr>
           <a:xfrm>
             <a:off x="731520" y="4526280"/>
-            <a:ext cx="10728655" cy="1261872"/>
-          </a:xfrm>
-          <a:prstGeom prst="roundRect">
+            <a:ext cx="38100" cy="1097280"/>
+          </a:xfrm>
+          <a:prstGeom prst="rect">
             <a:avLst/>
           </a:prstGeom>
           <a:solidFill>
-            <a:srgbClr val="FFFFFF"/>
+            <a:srgbClr val="2B59D9"/>
           </a:solidFill>
-          <a:ln w="12700">
-            <a:solidFill>
-              <a:srgbClr val="E2DDD0"/>
-            </a:solidFill>
+          <a:ln>
+            <a:noFill/>
           </a:ln>
         </p:spPr>
         <p:style>
@@ -5551,8 +5351,8 @@
         </p:nvSpPr>
         <p:spPr>
           <a:xfrm>
-            <a:off x="1051560" y="4709160"/>
-            <a:ext cx="10058400" cy="914400"/>
+            <a:off x="960120" y="4526280"/>
+            <a:ext cx="10500055" cy="1097280"/>
           </a:xfrm>
           <a:prstGeom prst="rect">
             <a:avLst/>
@@ -5567,7 +5367,7 @@
           <a:p>
             <a:pPr>
               <a:spcAft>
-                <a:spcPts val="600"/>
+                <a:spcPts val="400"/>
               </a:spcAft>
               <a:defRPr sz="1050" b="1">
                 <a:solidFill>
@@ -5582,7 +5382,7 @@
           </a:p>
           <a:p>
             <a:pPr>
-              <a:defRPr sz="1350">
+              <a:defRPr sz="1400">
                 <a:solidFill>
                   <a:srgbClr val="16161A"/>
                 </a:solidFill>
@@ -5744,7 +5544,7 @@
         </p:nvSpPr>
         <p:spPr>
           <a:xfrm>
-            <a:off x="731520" y="502920"/>
+            <a:off x="731520" y="548640"/>
             <a:ext cx="10728655" cy="228600"/>
           </a:xfrm>
           <a:prstGeom prst="rect">
@@ -5780,7 +5580,7 @@
         </p:nvSpPr>
         <p:spPr>
           <a:xfrm>
-            <a:off x="731520" y="777240"/>
+            <a:off x="731520" y="822960"/>
             <a:ext cx="10728655" cy="685800"/>
           </a:xfrm>
           <a:prstGeom prst="rect">
@@ -5810,25 +5610,23 @@
       </p:sp>
       <p:sp>
         <p:nvSpPr>
-          <p:cNvPr id="4" name="Rounded Rectangle 3"/>
+          <p:cNvPr id="4" name="Rectangle 3"/>
           <p:cNvSpPr/>
           <p:nvPr/>
         </p:nvSpPr>
         <p:spPr>
           <a:xfrm>
             <a:off x="731520" y="1691640"/>
-            <a:ext cx="3328416" cy="3246120"/>
-          </a:xfrm>
-          <a:prstGeom prst="roundRect">
+            <a:ext cx="3328416" cy="25400"/>
+          </a:xfrm>
+          <a:prstGeom prst="rect">
             <a:avLst/>
           </a:prstGeom>
           <a:solidFill>
-            <a:srgbClr val="FFFFFF"/>
+            <a:srgbClr val="D99B26"/>
           </a:solidFill>
-          <a:ln w="12700">
-            <a:solidFill>
-              <a:srgbClr val="E2DDD0"/>
-            </a:solidFill>
+          <a:ln>
+            <a:noFill/>
           </a:ln>
         </p:spPr>
         <p:style>
@@ -5861,8 +5659,8 @@
         </p:nvSpPr>
         <p:spPr>
           <a:xfrm>
-            <a:off x="1051560" y="1920240"/>
-            <a:ext cx="2688336" cy="2834640"/>
+            <a:off x="731520" y="1856232"/>
+            <a:ext cx="3328416" cy="3017520"/>
           </a:xfrm>
           <a:prstGeom prst="rect">
             <a:avLst/>
@@ -5877,24 +5675,24 @@
           <a:p>
             <a:pPr>
               <a:spcAft>
+                <a:spcPts val="800"/>
+              </a:spcAft>
+              <a:defRPr sz="1000" b="1">
+                <a:solidFill>
+                  <a:srgbClr val="D99B26"/>
+                </a:solidFill>
+                <a:latin typeface="Helvetica Neue"/>
+              </a:defRPr>
+            </a:pPr>
+            <a:r>
+              <a:t>INTEGRACIÓN EMPRESARIAL</a:t>
+            </a:r>
+          </a:p>
+          <a:p>
+            <a:pPr>
+              <a:spcAft>
                 <a:spcPts val="1000"/>
               </a:spcAft>
-              <a:defRPr sz="1000" b="1">
-                <a:solidFill>
-                  <a:srgbClr val="D99B26"/>
-                </a:solidFill>
-                <a:latin typeface="Helvetica Neue"/>
-              </a:defRPr>
-            </a:pPr>
-            <a:r>
-              <a:t>INTEGRACIÓN EMPRESARIAL</a:t>
-            </a:r>
-          </a:p>
-          <a:p>
-            <a:pPr>
-              <a:spcAft>
-                <a:spcPts val="1200"/>
-              </a:spcAft>
               <a:defRPr sz="1800" b="1">
                 <a:solidFill>
                   <a:srgbClr val="16161A"/>
@@ -5923,25 +5721,23 @@
       </p:sp>
       <p:sp>
         <p:nvSpPr>
-          <p:cNvPr id="6" name="Rounded Rectangle 5"/>
+          <p:cNvPr id="6" name="Rectangle 5"/>
           <p:cNvSpPr/>
           <p:nvPr/>
         </p:nvSpPr>
         <p:spPr>
           <a:xfrm>
             <a:off x="4334256" y="1691640"/>
-            <a:ext cx="3328416" cy="3246120"/>
-          </a:xfrm>
-          <a:prstGeom prst="roundRect">
+            <a:ext cx="3328416" cy="25400"/>
+          </a:xfrm>
+          <a:prstGeom prst="rect">
             <a:avLst/>
           </a:prstGeom>
           <a:solidFill>
-            <a:srgbClr val="FFFFFF"/>
+            <a:srgbClr val="2B59D9"/>
           </a:solidFill>
-          <a:ln w="12700">
-            <a:solidFill>
-              <a:srgbClr val="E2DDD0"/>
-            </a:solidFill>
+          <a:ln>
+            <a:noFill/>
           </a:ln>
         </p:spPr>
         <p:style>
@@ -5974,8 +5770,8 @@
         </p:nvSpPr>
         <p:spPr>
           <a:xfrm>
-            <a:off x="4654296" y="1920240"/>
-            <a:ext cx="2688336" cy="2834640"/>
+            <a:off x="4334256" y="1856232"/>
+            <a:ext cx="3328416" cy="3017520"/>
           </a:xfrm>
           <a:prstGeom prst="rect">
             <a:avLst/>
@@ -5990,24 +5786,24 @@
           <a:p>
             <a:pPr>
               <a:spcAft>
+                <a:spcPts val="800"/>
+              </a:spcAft>
+              <a:defRPr sz="1000" b="1">
+                <a:solidFill>
+                  <a:srgbClr val="2B59D9"/>
+                </a:solidFill>
+                <a:latin typeface="Helvetica Neue"/>
+              </a:defRPr>
+            </a:pPr>
+            <a:r>
+              <a:t>IA DE VOZ (HARDWARE/SOFTWARE)</a:t>
+            </a:r>
+          </a:p>
+          <a:p>
+            <a:pPr>
+              <a:spcAft>
                 <a:spcPts val="1000"/>
               </a:spcAft>
-              <a:defRPr sz="1000" b="1">
-                <a:solidFill>
-                  <a:srgbClr val="D99B26"/>
-                </a:solidFill>
-                <a:latin typeface="Helvetica Neue"/>
-              </a:defRPr>
-            </a:pPr>
-            <a:r>
-              <a:t>IA DE VOZ (HARDWARE/SOFTWARE)</a:t>
-            </a:r>
-          </a:p>
-          <a:p>
-            <a:pPr>
-              <a:spcAft>
-                <a:spcPts val="1200"/>
-              </a:spcAft>
               <a:defRPr sz="1800" b="1">
                 <a:solidFill>
                   <a:srgbClr val="16161A"/>
@@ -6036,25 +5832,23 @@
       </p:sp>
       <p:sp>
         <p:nvSpPr>
-          <p:cNvPr id="8" name="Rounded Rectangle 7"/>
+          <p:cNvPr id="8" name="Rectangle 7"/>
           <p:cNvSpPr/>
           <p:nvPr/>
         </p:nvSpPr>
         <p:spPr>
           <a:xfrm>
             <a:off x="7936992" y="1691640"/>
-            <a:ext cx="3328416" cy="3246120"/>
-          </a:xfrm>
-          <a:prstGeom prst="roundRect">
+            <a:ext cx="3328416" cy="25400"/>
+          </a:xfrm>
+          <a:prstGeom prst="rect">
             <a:avLst/>
           </a:prstGeom>
           <a:solidFill>
-            <a:srgbClr val="FFFFFF"/>
+            <a:srgbClr val="2B59D9"/>
           </a:solidFill>
-          <a:ln w="12700">
-            <a:solidFill>
-              <a:srgbClr val="E2DDD0"/>
-            </a:solidFill>
+          <a:ln>
+            <a:noFill/>
           </a:ln>
         </p:spPr>
         <p:style>
@@ -6087,8 +5881,8 @@
         </p:nvSpPr>
         <p:spPr>
           <a:xfrm>
-            <a:off x="8257032" y="1920240"/>
-            <a:ext cx="2688336" cy="2834640"/>
+            <a:off x="7936992" y="1856232"/>
+            <a:ext cx="3328416" cy="3017520"/>
           </a:xfrm>
           <a:prstGeom prst="rect">
             <a:avLst/>
@@ -6103,24 +5897,24 @@
           <a:p>
             <a:pPr>
               <a:spcAft>
+                <a:spcPts val="800"/>
+              </a:spcAft>
+              <a:defRPr sz="1000" b="1">
+                <a:solidFill>
+                  <a:srgbClr val="2B59D9"/>
+                </a:solidFill>
+                <a:latin typeface="Helvetica Neue"/>
+              </a:defRPr>
+            </a:pPr>
+            <a:r>
+              <a:t>Appt Helper · Open Cita · Border Bills</a:t>
+            </a:r>
+          </a:p>
+          <a:p>
+            <a:pPr>
+              <a:spcAft>
                 <a:spcPts val="1000"/>
               </a:spcAft>
-              <a:defRPr sz="1000" b="1">
-                <a:solidFill>
-                  <a:srgbClr val="D99B26"/>
-                </a:solidFill>
-                <a:latin typeface="Helvetica Neue"/>
-              </a:defRPr>
-            </a:pPr>
-            <a:r>
-              <a:t>Appt Helper · Open Cita · Border Bills</a:t>
-            </a:r>
-          </a:p>
-          <a:p>
-            <a:pPr>
-              <a:spcAft>
-                <a:spcPts val="1200"/>
-              </a:spcAft>
               <a:defRPr sz="1800" b="1">
                 <a:solidFill>
                   <a:srgbClr val="16161A"/>
@@ -6149,401 +5943,13 @@
       </p:sp>
       <p:sp>
         <p:nvSpPr>
-          <p:cNvPr id="10" name="Rounded Rectangle 9"/>
+          <p:cNvPr id="10" name="Rectangle 9"/>
           <p:cNvSpPr/>
           <p:nvPr/>
         </p:nvSpPr>
         <p:spPr>
           <a:xfrm>
-            <a:off x="731520" y="5120640"/>
-            <a:ext cx="2514600" cy="1005840"/>
-          </a:xfrm>
-          <a:prstGeom prst="roundRect">
-            <a:avLst/>
-          </a:prstGeom>
-          <a:solidFill>
-            <a:srgbClr val="FFFFFF"/>
-          </a:solidFill>
-          <a:ln w="12700">
-            <a:solidFill>
-              <a:srgbClr val="E2DDD0"/>
-            </a:solidFill>
-          </a:ln>
-        </p:spPr>
-        <p:style>
-          <a:lnRef idx="1">
-            <a:schemeClr val="accent1"/>
-          </a:lnRef>
-          <a:fillRef idx="3">
-            <a:schemeClr val="accent1"/>
-          </a:fillRef>
-          <a:effectRef idx="2">
-            <a:schemeClr val="accent1"/>
-          </a:effectRef>
-          <a:fontRef idx="minor">
-            <a:schemeClr val="lt1"/>
-          </a:fontRef>
-        </p:style>
-        <p:txBody>
-          <a:bodyPr rtlCol="0" anchor="ctr"/>
-          <a:lstStyle/>
-          <a:p>
-            <a:pPr algn="ctr"/>
-          </a:p>
-        </p:txBody>
-      </p:sp>
-      <p:sp>
-        <p:nvSpPr>
-          <p:cNvPr id="11" name="TextBox 10"/>
-          <p:cNvSpPr txBox="1"/>
-          <p:nvPr/>
-        </p:nvSpPr>
-        <p:spPr>
-          <a:xfrm>
-            <a:off x="896112" y="5212080"/>
-            <a:ext cx="2185416" cy="868680"/>
-          </a:xfrm>
-          <a:prstGeom prst="rect">
-            <a:avLst/>
-          </a:prstGeom>
-          <a:noFill/>
-        </p:spPr>
-        <p:txBody>
-          <a:bodyPr wrap="square" lIns="0" rIns="0" tIns="0" bIns="0">
-            <a:spAutoFit/>
-          </a:bodyPr>
-          <a:lstStyle/>
-          <a:p>
-            <a:pPr>
-              <a:defRPr sz="1250" b="1">
-                <a:solidFill>
-                  <a:srgbClr val="16161A"/>
-                </a:solidFill>
-                <a:latin typeface="Helvetica Neue"/>
-              </a:defRPr>
-            </a:pPr>
-            <a:r>
-              <a:t>En producción.</a:t>
-            </a:r>
-          </a:p>
-          <a:p>
-            <a:pPr>
-              <a:spcBef>
-                <a:spcPts val="200"/>
-              </a:spcBef>
-              <a:defRPr sz="1000">
-                <a:solidFill>
-                  <a:srgbClr val="454337"/>
-                </a:solidFill>
-                <a:latin typeface="Helvetica Neue"/>
-              </a:defRPr>
-            </a:pPr>
-            <a:r>
-              <a:t>Usuarios reales hoy en nuestros productos.</a:t>
-            </a:r>
-          </a:p>
-        </p:txBody>
-      </p:sp>
-      <p:sp>
-        <p:nvSpPr>
-          <p:cNvPr id="12" name="Rounded Rectangle 11"/>
-          <p:cNvSpPr/>
-          <p:nvPr/>
-        </p:nvSpPr>
-        <p:spPr>
-          <a:xfrm>
-            <a:off x="3429000" y="5120640"/>
-            <a:ext cx="2514600" cy="1005840"/>
-          </a:xfrm>
-          <a:prstGeom prst="roundRect">
-            <a:avLst/>
-          </a:prstGeom>
-          <a:solidFill>
-            <a:srgbClr val="FFFFFF"/>
-          </a:solidFill>
-          <a:ln w="12700">
-            <a:solidFill>
-              <a:srgbClr val="E2DDD0"/>
-            </a:solidFill>
-          </a:ln>
-        </p:spPr>
-        <p:style>
-          <a:lnRef idx="1">
-            <a:schemeClr val="accent1"/>
-          </a:lnRef>
-          <a:fillRef idx="3">
-            <a:schemeClr val="accent1"/>
-          </a:fillRef>
-          <a:effectRef idx="2">
-            <a:schemeClr val="accent1"/>
-          </a:effectRef>
-          <a:fontRef idx="minor">
-            <a:schemeClr val="lt1"/>
-          </a:fontRef>
-        </p:style>
-        <p:txBody>
-          <a:bodyPr rtlCol="0" anchor="ctr"/>
-          <a:lstStyle/>
-          <a:p>
-            <a:pPr algn="ctr"/>
-          </a:p>
-        </p:txBody>
-      </p:sp>
-      <p:sp>
-        <p:nvSpPr>
-          <p:cNvPr id="13" name="TextBox 12"/>
-          <p:cNvSpPr txBox="1"/>
-          <p:nvPr/>
-        </p:nvSpPr>
-        <p:spPr>
-          <a:xfrm>
-            <a:off x="3593592" y="5212080"/>
-            <a:ext cx="2185416" cy="868680"/>
-          </a:xfrm>
-          <a:prstGeom prst="rect">
-            <a:avLst/>
-          </a:prstGeom>
-          <a:noFill/>
-        </p:spPr>
-        <p:txBody>
-          <a:bodyPr wrap="square" lIns="0" rIns="0" tIns="0" bIns="0">
-            <a:spAutoFit/>
-          </a:bodyPr>
-          <a:lstStyle/>
-          <a:p>
-            <a:pPr>
-              <a:defRPr sz="1250" b="1">
-                <a:solidFill>
-                  <a:srgbClr val="16161A"/>
-                </a:solidFill>
-                <a:latin typeface="Helvetica Neue"/>
-              </a:defRPr>
-            </a:pPr>
-            <a:r>
-              <a:t>Equipo senior.</a:t>
-            </a:r>
-          </a:p>
-          <a:p>
-            <a:pPr>
-              <a:spcBef>
-                <a:spcPts val="200"/>
-              </a:spcBef>
-              <a:defRPr sz="1000">
-                <a:solidFill>
-                  <a:srgbClr val="454337"/>
-                </a:solidFill>
-                <a:latin typeface="Helvetica Neue"/>
-              </a:defRPr>
-            </a:pPr>
-            <a:r>
-              <a:t>Quienes presentan tu proyecto lo construyen.</a:t>
-            </a:r>
-          </a:p>
-        </p:txBody>
-      </p:sp>
-      <p:sp>
-        <p:nvSpPr>
-          <p:cNvPr id="14" name="Rounded Rectangle 13"/>
-          <p:cNvSpPr/>
-          <p:nvPr/>
-        </p:nvSpPr>
-        <p:spPr>
-          <a:xfrm>
-            <a:off x="6126480" y="5120640"/>
-            <a:ext cx="2514600" cy="1005840"/>
-          </a:xfrm>
-          <a:prstGeom prst="roundRect">
-            <a:avLst/>
-          </a:prstGeom>
-          <a:solidFill>
-            <a:srgbClr val="FFFFFF"/>
-          </a:solidFill>
-          <a:ln w="12700">
-            <a:solidFill>
-              <a:srgbClr val="E2DDD0"/>
-            </a:solidFill>
-          </a:ln>
-        </p:spPr>
-        <p:style>
-          <a:lnRef idx="1">
-            <a:schemeClr val="accent1"/>
-          </a:lnRef>
-          <a:fillRef idx="3">
-            <a:schemeClr val="accent1"/>
-          </a:fillRef>
-          <a:effectRef idx="2">
-            <a:schemeClr val="accent1"/>
-          </a:effectRef>
-          <a:fontRef idx="minor">
-            <a:schemeClr val="lt1"/>
-          </a:fontRef>
-        </p:style>
-        <p:txBody>
-          <a:bodyPr rtlCol="0" anchor="ctr"/>
-          <a:lstStyle/>
-          <a:p>
-            <a:pPr algn="ctr"/>
-          </a:p>
-        </p:txBody>
-      </p:sp>
-      <p:sp>
-        <p:nvSpPr>
-          <p:cNvPr id="15" name="TextBox 14"/>
-          <p:cNvSpPr txBox="1"/>
-          <p:nvPr/>
-        </p:nvSpPr>
-        <p:spPr>
-          <a:xfrm>
-            <a:off x="6291072" y="5212080"/>
-            <a:ext cx="2185416" cy="868680"/>
-          </a:xfrm>
-          <a:prstGeom prst="rect">
-            <a:avLst/>
-          </a:prstGeom>
-          <a:noFill/>
-        </p:spPr>
-        <p:txBody>
-          <a:bodyPr wrap="square" lIns="0" rIns="0" tIns="0" bIns="0">
-            <a:spAutoFit/>
-          </a:bodyPr>
-          <a:lstStyle/>
-          <a:p>
-            <a:pPr>
-              <a:defRPr sz="1250" b="1">
-                <a:solidFill>
-                  <a:srgbClr val="16161A"/>
-                </a:solidFill>
-                <a:latin typeface="Helvetica Neue"/>
-              </a:defRPr>
-            </a:pPr>
-            <a:r>
-              <a:t>Código primero.</a:t>
-            </a:r>
-          </a:p>
-          <a:p>
-            <a:pPr>
-              <a:spcBef>
-                <a:spcPts val="200"/>
-              </a:spcBef>
-              <a:defRPr sz="1000">
-                <a:solidFill>
-                  <a:srgbClr val="454337"/>
-                </a:solidFill>
-                <a:latin typeface="Helvetica Neue"/>
-              </a:defRPr>
-            </a:pPr>
-            <a:r>
-              <a:t>Software funcional antes que diapositivas.</a:t>
-            </a:r>
-          </a:p>
-        </p:txBody>
-      </p:sp>
-      <p:sp>
-        <p:nvSpPr>
-          <p:cNvPr id="16" name="Rounded Rectangle 15"/>
-          <p:cNvSpPr/>
-          <p:nvPr/>
-        </p:nvSpPr>
-        <p:spPr>
-          <a:xfrm>
-            <a:off x="8823960" y="5120640"/>
-            <a:ext cx="2514600" cy="1005840"/>
-          </a:xfrm>
-          <a:prstGeom prst="roundRect">
-            <a:avLst/>
-          </a:prstGeom>
-          <a:solidFill>
-            <a:srgbClr val="FFFFFF"/>
-          </a:solidFill>
-          <a:ln w="12700">
-            <a:solidFill>
-              <a:srgbClr val="E2DDD0"/>
-            </a:solidFill>
-          </a:ln>
-        </p:spPr>
-        <p:style>
-          <a:lnRef idx="1">
-            <a:schemeClr val="accent1"/>
-          </a:lnRef>
-          <a:fillRef idx="3">
-            <a:schemeClr val="accent1"/>
-          </a:fillRef>
-          <a:effectRef idx="2">
-            <a:schemeClr val="accent1"/>
-          </a:effectRef>
-          <a:fontRef idx="minor">
-            <a:schemeClr val="lt1"/>
-          </a:fontRef>
-        </p:style>
-        <p:txBody>
-          <a:bodyPr rtlCol="0" anchor="ctr"/>
-          <a:lstStyle/>
-          <a:p>
-            <a:pPr algn="ctr"/>
-          </a:p>
-        </p:txBody>
-      </p:sp>
-      <p:sp>
-        <p:nvSpPr>
-          <p:cNvPr id="17" name="TextBox 16"/>
-          <p:cNvSpPr txBox="1"/>
-          <p:nvPr/>
-        </p:nvSpPr>
-        <p:spPr>
-          <a:xfrm>
-            <a:off x="8988552" y="5212080"/>
-            <a:ext cx="2185416" cy="868680"/>
-          </a:xfrm>
-          <a:prstGeom prst="rect">
-            <a:avLst/>
-          </a:prstGeom>
-          <a:noFill/>
-        </p:spPr>
-        <p:txBody>
-          <a:bodyPr wrap="square" lIns="0" rIns="0" tIns="0" bIns="0">
-            <a:spAutoFit/>
-          </a:bodyPr>
-          <a:lstStyle/>
-          <a:p>
-            <a:pPr>
-              <a:defRPr sz="1250" b="1">
-                <a:solidFill>
-                  <a:srgbClr val="16161A"/>
-                </a:solidFill>
-                <a:latin typeface="Helvetica Neue"/>
-              </a:defRPr>
-            </a:pPr>
-            <a:r>
-              <a:t>Un solo equipo.</a:t>
-            </a:r>
-          </a:p>
-          <a:p>
-            <a:pPr>
-              <a:spcBef>
-                <a:spcPts val="200"/>
-              </a:spcBef>
-              <a:defRPr sz="1000">
-                <a:solidFill>
-                  <a:srgbClr val="454337"/>
-                </a:solidFill>
-                <a:latin typeface="Helvetica Neue"/>
-              </a:defRPr>
-            </a:pPr>
-            <a:r>
-              <a:t>Interfaces y automatizaciones: mismo equipo.</a:t>
-            </a:r>
-          </a:p>
-        </p:txBody>
-      </p:sp>
-      <p:sp>
-        <p:nvSpPr>
-          <p:cNvPr id="18" name="Rectangle 17"/>
-          <p:cNvSpPr/>
-          <p:nvPr/>
-        </p:nvSpPr>
-        <p:spPr>
-          <a:xfrm>
-            <a:off x="731520" y="6263640"/>
+            <a:off x="731520" y="4983480"/>
             <a:ext cx="10728655" cy="12700"/>
           </a:xfrm>
           <a:prstGeom prst="rect">
@@ -6580,14 +5986,14 @@
       </p:sp>
       <p:sp>
         <p:nvSpPr>
-          <p:cNvPr id="19" name="TextBox 18"/>
+          <p:cNvPr id="11" name="TextBox 10"/>
           <p:cNvSpPr txBox="1"/>
           <p:nvPr/>
         </p:nvSpPr>
         <p:spPr>
           <a:xfrm>
-            <a:off x="731520" y="6355080"/>
-            <a:ext cx="7315200" cy="320040"/>
+            <a:off x="731520" y="5120640"/>
+            <a:ext cx="2514600" cy="1005840"/>
           </a:xfrm>
           <a:prstGeom prst="rect">
             <a:avLst/>
@@ -6601,8 +6007,259 @@
           <a:lstStyle/>
           <a:p>
             <a:pPr>
+              <a:defRPr sz="1250" b="1">
+                <a:solidFill>
+                  <a:srgbClr val="16161A"/>
+                </a:solidFill>
+                <a:latin typeface="Helvetica Neue"/>
+              </a:defRPr>
+            </a:pPr>
+            <a:r>
+              <a:t>En producción.</a:t>
+            </a:r>
+          </a:p>
+          <a:p>
+            <a:pPr>
+              <a:spcBef>
+                <a:spcPts val="200"/>
+              </a:spcBef>
               <a:defRPr sz="1000">
                 <a:solidFill>
+                  <a:srgbClr val="454337"/>
+                </a:solidFill>
+                <a:latin typeface="Helvetica Neue"/>
+              </a:defRPr>
+            </a:pPr>
+            <a:r>
+              <a:t>Usuarios reales hoy en nuestros productos.</a:t>
+            </a:r>
+          </a:p>
+        </p:txBody>
+      </p:sp>
+      <p:sp>
+        <p:nvSpPr>
+          <p:cNvPr id="12" name="TextBox 11"/>
+          <p:cNvSpPr txBox="1"/>
+          <p:nvPr/>
+        </p:nvSpPr>
+        <p:spPr>
+          <a:xfrm>
+            <a:off x="3429000" y="5120640"/>
+            <a:ext cx="2514600" cy="1005840"/>
+          </a:xfrm>
+          <a:prstGeom prst="rect">
+            <a:avLst/>
+          </a:prstGeom>
+          <a:noFill/>
+        </p:spPr>
+        <p:txBody>
+          <a:bodyPr wrap="square" lIns="0" rIns="0" tIns="0" bIns="0">
+            <a:spAutoFit/>
+          </a:bodyPr>
+          <a:lstStyle/>
+          <a:p>
+            <a:pPr>
+              <a:defRPr sz="1250" b="1">
+                <a:solidFill>
+                  <a:srgbClr val="16161A"/>
+                </a:solidFill>
+                <a:latin typeface="Helvetica Neue"/>
+              </a:defRPr>
+            </a:pPr>
+            <a:r>
+              <a:t>Equipo senior.</a:t>
+            </a:r>
+          </a:p>
+          <a:p>
+            <a:pPr>
+              <a:spcBef>
+                <a:spcPts val="200"/>
+              </a:spcBef>
+              <a:defRPr sz="1000">
+                <a:solidFill>
+                  <a:srgbClr val="454337"/>
+                </a:solidFill>
+                <a:latin typeface="Helvetica Neue"/>
+              </a:defRPr>
+            </a:pPr>
+            <a:r>
+              <a:t>Quienes presentan tu proyecto lo construyen.</a:t>
+            </a:r>
+          </a:p>
+        </p:txBody>
+      </p:sp>
+      <p:sp>
+        <p:nvSpPr>
+          <p:cNvPr id="13" name="TextBox 12"/>
+          <p:cNvSpPr txBox="1"/>
+          <p:nvPr/>
+        </p:nvSpPr>
+        <p:spPr>
+          <a:xfrm>
+            <a:off x="6126480" y="5120640"/>
+            <a:ext cx="2514600" cy="1005840"/>
+          </a:xfrm>
+          <a:prstGeom prst="rect">
+            <a:avLst/>
+          </a:prstGeom>
+          <a:noFill/>
+        </p:spPr>
+        <p:txBody>
+          <a:bodyPr wrap="square" lIns="0" rIns="0" tIns="0" bIns="0">
+            <a:spAutoFit/>
+          </a:bodyPr>
+          <a:lstStyle/>
+          <a:p>
+            <a:pPr>
+              <a:defRPr sz="1250" b="1">
+                <a:solidFill>
+                  <a:srgbClr val="16161A"/>
+                </a:solidFill>
+                <a:latin typeface="Helvetica Neue"/>
+              </a:defRPr>
+            </a:pPr>
+            <a:r>
+              <a:t>Código primero.</a:t>
+            </a:r>
+          </a:p>
+          <a:p>
+            <a:pPr>
+              <a:spcBef>
+                <a:spcPts val="200"/>
+              </a:spcBef>
+              <a:defRPr sz="1000">
+                <a:solidFill>
+                  <a:srgbClr val="454337"/>
+                </a:solidFill>
+                <a:latin typeface="Helvetica Neue"/>
+              </a:defRPr>
+            </a:pPr>
+            <a:r>
+              <a:t>Software funcional antes que diapositivas.</a:t>
+            </a:r>
+          </a:p>
+        </p:txBody>
+      </p:sp>
+      <p:sp>
+        <p:nvSpPr>
+          <p:cNvPr id="14" name="TextBox 13"/>
+          <p:cNvSpPr txBox="1"/>
+          <p:nvPr/>
+        </p:nvSpPr>
+        <p:spPr>
+          <a:xfrm>
+            <a:off x="8823960" y="5120640"/>
+            <a:ext cx="2514600" cy="1005840"/>
+          </a:xfrm>
+          <a:prstGeom prst="rect">
+            <a:avLst/>
+          </a:prstGeom>
+          <a:noFill/>
+        </p:spPr>
+        <p:txBody>
+          <a:bodyPr wrap="square" lIns="0" rIns="0" tIns="0" bIns="0">
+            <a:spAutoFit/>
+          </a:bodyPr>
+          <a:lstStyle/>
+          <a:p>
+            <a:pPr>
+              <a:defRPr sz="1250" b="1">
+                <a:solidFill>
+                  <a:srgbClr val="16161A"/>
+                </a:solidFill>
+                <a:latin typeface="Helvetica Neue"/>
+              </a:defRPr>
+            </a:pPr>
+            <a:r>
+              <a:t>Un solo equipo.</a:t>
+            </a:r>
+          </a:p>
+          <a:p>
+            <a:pPr>
+              <a:spcBef>
+                <a:spcPts val="200"/>
+              </a:spcBef>
+              <a:defRPr sz="1000">
+                <a:solidFill>
+                  <a:srgbClr val="454337"/>
+                </a:solidFill>
+                <a:latin typeface="Helvetica Neue"/>
+              </a:defRPr>
+            </a:pPr>
+            <a:r>
+              <a:t>Interfaces y automatizaciones: mismo equipo.</a:t>
+            </a:r>
+          </a:p>
+        </p:txBody>
+      </p:sp>
+      <p:sp>
+        <p:nvSpPr>
+          <p:cNvPr id="15" name="Rectangle 14"/>
+          <p:cNvSpPr/>
+          <p:nvPr/>
+        </p:nvSpPr>
+        <p:spPr>
+          <a:xfrm>
+            <a:off x="731520" y="6263640"/>
+            <a:ext cx="10728655" cy="12700"/>
+          </a:xfrm>
+          <a:prstGeom prst="rect">
+            <a:avLst/>
+          </a:prstGeom>
+          <a:solidFill>
+            <a:srgbClr val="E2DDD0"/>
+          </a:solidFill>
+          <a:ln>
+            <a:noFill/>
+          </a:ln>
+        </p:spPr>
+        <p:style>
+          <a:lnRef idx="1">
+            <a:schemeClr val="accent1"/>
+          </a:lnRef>
+          <a:fillRef idx="3">
+            <a:schemeClr val="accent1"/>
+          </a:fillRef>
+          <a:effectRef idx="2">
+            <a:schemeClr val="accent1"/>
+          </a:effectRef>
+          <a:fontRef idx="minor">
+            <a:schemeClr val="lt1"/>
+          </a:fontRef>
+        </p:style>
+        <p:txBody>
+          <a:bodyPr rtlCol="0" anchor="ctr"/>
+          <a:lstStyle/>
+          <a:p>
+            <a:pPr algn="ctr"/>
+          </a:p>
+        </p:txBody>
+      </p:sp>
+      <p:sp>
+        <p:nvSpPr>
+          <p:cNvPr id="16" name="TextBox 15"/>
+          <p:cNvSpPr txBox="1"/>
+          <p:nvPr/>
+        </p:nvSpPr>
+        <p:spPr>
+          <a:xfrm>
+            <a:off x="731520" y="6355080"/>
+            <a:ext cx="7315200" cy="320040"/>
+          </a:xfrm>
+          <a:prstGeom prst="rect">
+            <a:avLst/>
+          </a:prstGeom>
+          <a:noFill/>
+        </p:spPr>
+        <p:txBody>
+          <a:bodyPr wrap="square" lIns="0" rIns="0" tIns="0" bIns="0">
+            <a:spAutoFit/>
+          </a:bodyPr>
+          <a:lstStyle/>
+          <a:p>
+            <a:pPr>
+              <a:defRPr sz="1000">
+                <a:solidFill>
                   <a:srgbClr val="736E62"/>
                 </a:solidFill>
                 <a:latin typeface="Helvetica Neue"/>
@@ -6616,7 +6273,7 @@
       </p:sp>
       <p:sp>
         <p:nvSpPr>
-          <p:cNvPr id="20" name="TextBox 19"/>
+          <p:cNvPr id="17" name="TextBox 16"/>
           <p:cNvSpPr txBox="1"/>
           <p:nvPr/>
         </p:nvSpPr>
@@ -6684,7 +6341,7 @@
         </p:nvSpPr>
         <p:spPr>
           <a:xfrm>
-            <a:off x="731520" y="502920"/>
+            <a:off x="731520" y="548640"/>
             <a:ext cx="10728655" cy="228600"/>
           </a:xfrm>
           <a:prstGeom prst="rect">
@@ -6720,7 +6377,7 @@
         </p:nvSpPr>
         <p:spPr>
           <a:xfrm>
-            <a:off x="731520" y="777240"/>
+            <a:off x="731520" y="822960"/>
             <a:ext cx="10728655" cy="685800"/>
           </a:xfrm>
           <a:prstGeom prst="rect">
@@ -6750,25 +6407,23 @@
       </p:sp>
       <p:sp>
         <p:nvSpPr>
-          <p:cNvPr id="4" name="Rounded Rectangle 3"/>
+          <p:cNvPr id="4" name="Rectangle 3"/>
           <p:cNvSpPr/>
           <p:nvPr/>
         </p:nvSpPr>
         <p:spPr>
           <a:xfrm>
             <a:off x="731520" y="1691640"/>
-            <a:ext cx="5157216" cy="4297680"/>
-          </a:xfrm>
-          <a:prstGeom prst="roundRect">
+            <a:ext cx="38100" cy="4114800"/>
+          </a:xfrm>
+          <a:prstGeom prst="rect">
             <a:avLst/>
           </a:prstGeom>
           <a:solidFill>
-            <a:srgbClr val="FFFFFF"/>
+            <a:srgbClr val="DC2626"/>
           </a:solidFill>
           <a:ln>
-            <a:solidFill>
-              <a:srgbClr val="FECACA"/>
-            </a:solidFill>
+            <a:noFill/>
           </a:ln>
         </p:spPr>
         <p:style>
@@ -6801,8 +6456,8 @@
         </p:nvSpPr>
         <p:spPr>
           <a:xfrm>
-            <a:off x="1051560" y="2011680"/>
-            <a:ext cx="4517136" cy="3657600"/>
+            <a:off x="960120" y="1691640"/>
+            <a:ext cx="4928616" cy="4114800"/>
           </a:xfrm>
           <a:prstGeom prst="rect">
             <a:avLst/>
@@ -6898,25 +6553,23 @@
       </p:sp>
       <p:sp>
         <p:nvSpPr>
-          <p:cNvPr id="6" name="Rounded Rectangle 5"/>
+          <p:cNvPr id="6" name="Rectangle 5"/>
           <p:cNvSpPr/>
           <p:nvPr/>
         </p:nvSpPr>
         <p:spPr>
           <a:xfrm>
             <a:off x="6300216" y="1691640"/>
-            <a:ext cx="5157216" cy="4297680"/>
-          </a:xfrm>
-          <a:prstGeom prst="roundRect">
+            <a:ext cx="38100" cy="4114800"/>
+          </a:xfrm>
+          <a:prstGeom prst="rect">
             <a:avLst/>
           </a:prstGeom>
           <a:solidFill>
-            <a:srgbClr val="FFFFFF"/>
+            <a:srgbClr val="DC2626"/>
           </a:solidFill>
           <a:ln>
-            <a:solidFill>
-              <a:srgbClr val="FECACA"/>
-            </a:solidFill>
+            <a:noFill/>
           </a:ln>
         </p:spPr>
         <p:style>
@@ -6949,8 +6602,8 @@
         </p:nvSpPr>
         <p:spPr>
           <a:xfrm>
-            <a:off x="6620256" y="2011680"/>
-            <a:ext cx="4517136" cy="3657600"/>
+            <a:off x="6528816" y="1691640"/>
+            <a:ext cx="4928616" cy="4114800"/>
           </a:xfrm>
           <a:prstGeom prst="rect">
             <a:avLst/>
@@ -7193,7 +6846,7 @@
         </p:nvSpPr>
         <p:spPr>
           <a:xfrm>
-            <a:off x="731520" y="502920"/>
+            <a:off x="731520" y="548640"/>
             <a:ext cx="10728655" cy="228600"/>
           </a:xfrm>
           <a:prstGeom prst="rect">
@@ -7229,7 +6882,7 @@
         </p:nvSpPr>
         <p:spPr>
           <a:xfrm>
-            <a:off x="731520" y="777240"/>
+            <a:off x="731520" y="822960"/>
             <a:ext cx="10728655" cy="685800"/>
           </a:xfrm>
           <a:prstGeom prst="rect">
@@ -7259,25 +6912,23 @@
       </p:sp>
       <p:sp>
         <p:nvSpPr>
-          <p:cNvPr id="4" name="Rounded Rectangle 3"/>
+          <p:cNvPr id="4" name="Rectangle 3"/>
           <p:cNvSpPr/>
           <p:nvPr/>
         </p:nvSpPr>
         <p:spPr>
           <a:xfrm>
             <a:off x="731520" y="1691640"/>
-            <a:ext cx="3328416" cy="4297680"/>
-          </a:xfrm>
-          <a:prstGeom prst="roundRect">
+            <a:ext cx="3328416" cy="25400"/>
+          </a:xfrm>
+          <a:prstGeom prst="rect">
             <a:avLst/>
           </a:prstGeom>
           <a:solidFill>
-            <a:srgbClr val="FFFFFF"/>
+            <a:srgbClr val="2B59D9"/>
           </a:solidFill>
-          <a:ln w="12700">
-            <a:solidFill>
-              <a:srgbClr val="E2DDD0"/>
-            </a:solidFill>
+          <a:ln>
+            <a:noFill/>
           </a:ln>
         </p:spPr>
         <p:style>
@@ -7310,8 +6961,8 @@
         </p:nvSpPr>
         <p:spPr>
           <a:xfrm>
-            <a:off x="1051560" y="2011680"/>
-            <a:ext cx="2688336" cy="3657600"/>
+            <a:off x="731520" y="1856232"/>
+            <a:ext cx="3328416" cy="4114800"/>
           </a:xfrm>
           <a:prstGeom prst="rect">
             <a:avLst/>
@@ -7342,7 +6993,7 @@
           <a:p>
             <a:pPr>
               <a:spcAft>
-                <a:spcPts val="1400"/>
+                <a:spcPts val="1200"/>
               </a:spcAft>
               <a:defRPr sz="1800" b="1">
                 <a:solidFill>
@@ -7372,25 +7023,23 @@
       </p:sp>
       <p:sp>
         <p:nvSpPr>
-          <p:cNvPr id="6" name="Rounded Rectangle 5"/>
+          <p:cNvPr id="6" name="Rectangle 5"/>
           <p:cNvSpPr/>
           <p:nvPr/>
         </p:nvSpPr>
         <p:spPr>
           <a:xfrm>
             <a:off x="4334256" y="1691640"/>
-            <a:ext cx="3328416" cy="4297680"/>
-          </a:xfrm>
-          <a:prstGeom prst="roundRect">
+            <a:ext cx="3328416" cy="25400"/>
+          </a:xfrm>
+          <a:prstGeom prst="rect">
             <a:avLst/>
           </a:prstGeom>
           <a:solidFill>
-            <a:srgbClr val="FFFFFF"/>
+            <a:srgbClr val="2B59D9"/>
           </a:solidFill>
-          <a:ln w="12700">
-            <a:solidFill>
-              <a:srgbClr val="E2DDD0"/>
-            </a:solidFill>
+          <a:ln>
+            <a:noFill/>
           </a:ln>
         </p:spPr>
         <p:style>
@@ -7423,8 +7072,8 @@
         </p:nvSpPr>
         <p:spPr>
           <a:xfrm>
-            <a:off x="4654296" y="2011680"/>
-            <a:ext cx="2688336" cy="3657600"/>
+            <a:off x="4334256" y="1856232"/>
+            <a:ext cx="3328416" cy="4114800"/>
           </a:xfrm>
           <a:prstGeom prst="rect">
             <a:avLst/>
@@ -7455,7 +7104,7 @@
           <a:p>
             <a:pPr>
               <a:spcAft>
-                <a:spcPts val="1400"/>
+                <a:spcPts val="1200"/>
               </a:spcAft>
               <a:defRPr sz="1800" b="1">
                 <a:solidFill>
@@ -7485,25 +7134,23 @@
       </p:sp>
       <p:sp>
         <p:nvSpPr>
-          <p:cNvPr id="8" name="Rounded Rectangle 7"/>
+          <p:cNvPr id="8" name="Rectangle 7"/>
           <p:cNvSpPr/>
           <p:nvPr/>
         </p:nvSpPr>
         <p:spPr>
           <a:xfrm>
             <a:off x="7936992" y="1691640"/>
-            <a:ext cx="3328416" cy="4297680"/>
-          </a:xfrm>
-          <a:prstGeom prst="roundRect">
+            <a:ext cx="3328416" cy="25400"/>
+          </a:xfrm>
+          <a:prstGeom prst="rect">
             <a:avLst/>
           </a:prstGeom>
           <a:solidFill>
-            <a:srgbClr val="FFFFFF"/>
+            <a:srgbClr val="2B59D9"/>
           </a:solidFill>
-          <a:ln w="12700">
-            <a:solidFill>
-              <a:srgbClr val="E2DDD0"/>
-            </a:solidFill>
+          <a:ln>
+            <a:noFill/>
           </a:ln>
         </p:spPr>
         <p:style>
@@ -7536,8 +7183,8 @@
         </p:nvSpPr>
         <p:spPr>
           <a:xfrm>
-            <a:off x="8257032" y="2011680"/>
-            <a:ext cx="2688336" cy="3657600"/>
+            <a:off x="7936992" y="1856232"/>
+            <a:ext cx="3328416" cy="4114800"/>
           </a:xfrm>
           <a:prstGeom prst="rect">
             <a:avLst/>
@@ -7568,7 +7215,7 @@
           <a:p>
             <a:pPr>
               <a:spcAft>
-                <a:spcPts val="1400"/>
+                <a:spcPts val="1200"/>
               </a:spcAft>
               <a:defRPr sz="1800" b="1">
                 <a:solidFill>
@@ -7745,7 +7392,7 @@
         </p:nvSpPr>
         <p:spPr>
           <a:xfrm>
-            <a:off x="731520" y="502920"/>
+            <a:off x="731520" y="548640"/>
             <a:ext cx="10728655" cy="228600"/>
           </a:xfrm>
           <a:prstGeom prst="rect">
@@ -7781,7 +7428,7 @@
         </p:nvSpPr>
         <p:spPr>
           <a:xfrm>
-            <a:off x="731520" y="777240"/>
+            <a:off x="731520" y="822960"/>
             <a:ext cx="10728655" cy="685800"/>
           </a:xfrm>
           <a:prstGeom prst="rect">
@@ -7811,25 +7458,23 @@
       </p:sp>
       <p:sp>
         <p:nvSpPr>
-          <p:cNvPr id="4" name="Rounded Rectangle 3"/>
+          <p:cNvPr id="4" name="Rectangle 3"/>
           <p:cNvSpPr/>
           <p:nvPr/>
         </p:nvSpPr>
         <p:spPr>
           <a:xfrm>
             <a:off x="731520" y="1691640"/>
-            <a:ext cx="10728655" cy="3200400"/>
-          </a:xfrm>
-          <a:prstGeom prst="roundRect">
+            <a:ext cx="38100" cy="2926080"/>
+          </a:xfrm>
+          <a:prstGeom prst="rect">
             <a:avLst/>
           </a:prstGeom>
           <a:solidFill>
-            <a:srgbClr val="FFFFFF"/>
+            <a:srgbClr val="D99B26"/>
           </a:solidFill>
-          <a:ln w="12700">
-            <a:solidFill>
-              <a:srgbClr val="E2DDD0"/>
-            </a:solidFill>
+          <a:ln>
+            <a:noFill/>
           </a:ln>
         </p:spPr>
         <p:style>
@@ -7862,8 +7507,8 @@
         </p:nvSpPr>
         <p:spPr>
           <a:xfrm>
-            <a:off x="1097280" y="1965960"/>
-            <a:ext cx="9997135" cy="2651760"/>
+            <a:off x="960120" y="1691640"/>
+            <a:ext cx="10500055" cy="2926080"/>
           </a:xfrm>
           <a:prstGeom prst="rect">
             <a:avLst/>
@@ -7896,7 +7541,7 @@
               <a:spcAft>
                 <a:spcPts val="1000"/>
               </a:spcAft>
-              <a:defRPr sz="1500">
+              <a:defRPr sz="1550">
                 <a:solidFill>
                   <a:srgbClr val="16161A"/>
                 </a:solidFill>
@@ -7909,7 +7554,7 @@
           </a:p>
           <a:p>
             <a:pPr>
-              <a:defRPr sz="1500">
+              <a:defRPr sz="1550">
                 <a:solidFill>
                   <a:srgbClr val="16161A"/>
                 </a:solidFill>
@@ -7924,65 +7569,13 @@
       </p:sp>
       <p:sp>
         <p:nvSpPr>
-          <p:cNvPr id="6" name="TextBox 5"/>
-          <p:cNvSpPr txBox="1"/>
-          <p:nvPr/>
-        </p:nvSpPr>
-        <p:spPr>
-          <a:xfrm>
-            <a:off x="731520" y="5166360"/>
-            <a:ext cx="10728655" cy="914400"/>
-          </a:xfrm>
-          <a:prstGeom prst="rect">
-            <a:avLst/>
-          </a:prstGeom>
-          <a:noFill/>
-        </p:spPr>
-        <p:txBody>
-          <a:bodyPr wrap="square" lIns="0" rIns="0" tIns="0" bIns="0">
-            <a:spAutoFit/>
-          </a:bodyPr>
-          <a:lstStyle/>
-          <a:p>
-            <a:pPr>
-              <a:defRPr sz="1800" b="1">
-                <a:solidFill>
-                  <a:srgbClr val="16161A"/>
-                </a:solidFill>
-                <a:latin typeface="Helvetica Neue"/>
-              </a:defRPr>
-            </a:pPr>
-            <a:r>
-              <a:t>Roberto Guido  |  Technology Consultants</a:t>
-            </a:r>
-          </a:p>
-          <a:p>
-            <a:pPr>
-              <a:spcBef>
-                <a:spcPts val="400"/>
-              </a:spcBef>
-              <a:defRPr sz="1300">
-                <a:solidFill>
-                  <a:srgbClr val="2B59D9"/>
-                </a:solidFill>
-                <a:latin typeface="Helvetica Neue"/>
-              </a:defRPr>
-            </a:pPr>
-            <a:r>
-              <a:t>Sitio web: technologyconsultants.ventures   ·   San Diego y Tijuana</a:t>
-            </a:r>
-          </a:p>
-        </p:txBody>
-      </p:sp>
-      <p:sp>
-        <p:nvSpPr>
-          <p:cNvPr id="7" name="Rectangle 6"/>
+          <p:cNvPr id="6" name="Rectangle 5"/>
           <p:cNvSpPr/>
           <p:nvPr/>
         </p:nvSpPr>
         <p:spPr>
           <a:xfrm>
-            <a:off x="731520" y="6263640"/>
+            <a:off x="731520" y="4892040"/>
             <a:ext cx="10728655" cy="12700"/>
           </a:xfrm>
           <a:prstGeom prst="rect">
@@ -8019,14 +7612,14 @@
       </p:sp>
       <p:sp>
         <p:nvSpPr>
-          <p:cNvPr id="8" name="TextBox 7"/>
+          <p:cNvPr id="7" name="TextBox 6"/>
           <p:cNvSpPr txBox="1"/>
           <p:nvPr/>
         </p:nvSpPr>
         <p:spPr>
           <a:xfrm>
-            <a:off x="731520" y="6355080"/>
-            <a:ext cx="7315200" cy="320040"/>
+            <a:off x="731520" y="5074920"/>
+            <a:ext cx="10728655" cy="914400"/>
           </a:xfrm>
           <a:prstGeom prst="rect">
             <a:avLst/>
@@ -8040,6 +7633,100 @@
           <a:lstStyle/>
           <a:p>
             <a:pPr>
+              <a:defRPr sz="1800" b="1">
+                <a:solidFill>
+                  <a:srgbClr val="16161A"/>
+                </a:solidFill>
+                <a:latin typeface="Helvetica Neue"/>
+              </a:defRPr>
+            </a:pPr>
+            <a:r>
+              <a:t>Roberto Guido  |  Technology Consultants</a:t>
+            </a:r>
+          </a:p>
+          <a:p>
+            <a:pPr>
+              <a:spcBef>
+                <a:spcPts val="400"/>
+              </a:spcBef>
+              <a:defRPr sz="1300">
+                <a:solidFill>
+                  <a:srgbClr val="2B59D9"/>
+                </a:solidFill>
+              </a:defRPr>
+            </a:pPr>
+            <a:r>
+              <a:t>Sitio web: technologyconsultants.ventures   ·   San Diego y Tijuana</a:t>
+            </a:r>
+          </a:p>
+        </p:txBody>
+      </p:sp>
+      <p:sp>
+        <p:nvSpPr>
+          <p:cNvPr id="8" name="Rectangle 7"/>
+          <p:cNvSpPr/>
+          <p:nvPr/>
+        </p:nvSpPr>
+        <p:spPr>
+          <a:xfrm>
+            <a:off x="731520" y="6263640"/>
+            <a:ext cx="10728655" cy="12700"/>
+          </a:xfrm>
+          <a:prstGeom prst="rect">
+            <a:avLst/>
+          </a:prstGeom>
+          <a:solidFill>
+            <a:srgbClr val="E2DDD0"/>
+          </a:solidFill>
+          <a:ln>
+            <a:noFill/>
+          </a:ln>
+        </p:spPr>
+        <p:style>
+          <a:lnRef idx="1">
+            <a:schemeClr val="accent1"/>
+          </a:lnRef>
+          <a:fillRef idx="3">
+            <a:schemeClr val="accent1"/>
+          </a:fillRef>
+          <a:effectRef idx="2">
+            <a:schemeClr val="accent1"/>
+          </a:effectRef>
+          <a:fontRef idx="minor">
+            <a:schemeClr val="lt1"/>
+          </a:fontRef>
+        </p:style>
+        <p:txBody>
+          <a:bodyPr rtlCol="0" anchor="ctr"/>
+          <a:lstStyle/>
+          <a:p>
+            <a:pPr algn="ctr"/>
+          </a:p>
+        </p:txBody>
+      </p:sp>
+      <p:sp>
+        <p:nvSpPr>
+          <p:cNvPr id="9" name="TextBox 8"/>
+          <p:cNvSpPr txBox="1"/>
+          <p:nvPr/>
+        </p:nvSpPr>
+        <p:spPr>
+          <a:xfrm>
+            <a:off x="731520" y="6355080"/>
+            <a:ext cx="7315200" cy="320040"/>
+          </a:xfrm>
+          <a:prstGeom prst="rect">
+            <a:avLst/>
+          </a:prstGeom>
+          <a:noFill/>
+        </p:spPr>
+        <p:txBody>
+          <a:bodyPr wrap="square" lIns="0" rIns="0" tIns="0" bIns="0">
+            <a:spAutoFit/>
+          </a:bodyPr>
+          <a:lstStyle/>
+          <a:p>
+            <a:pPr>
               <a:defRPr sz="1000">
                 <a:solidFill>
                   <a:srgbClr val="736E62"/>
@@ -8055,7 +7742,7 @@
       </p:sp>
       <p:sp>
         <p:nvSpPr>
-          <p:cNvPr id="9" name="TextBox 8"/>
+          <p:cNvPr id="10" name="TextBox 9"/>
           <p:cNvSpPr txBox="1"/>
           <p:nvPr/>
         </p:nvSpPr>

</xml_diff>

<commit_message>
Calibrate presentation typography scale (40pt display title, 30pt slide titles, 16pt lede, 11pt eyebrows, 13.5pt body) to match website typography hierarchy
</commit_message>
<xml_diff>
--- a/Technology_Consultants_A_Quien_Enviarme_MX.pptx
+++ b/Technology_Consultants_A_Quien_Enviarme_MX.pptx
@@ -3111,7 +3111,7 @@
         </p:nvSpPr>
         <p:spPr>
           <a:xfrm>
-            <a:off x="731520" y="640080"/>
+            <a:off x="731520" y="594360"/>
             <a:ext cx="10728655" cy="274320"/>
           </a:xfrm>
           <a:prstGeom prst="rect">
@@ -3147,8 +3147,8 @@
         </p:nvSpPr>
         <p:spPr>
           <a:xfrm>
-            <a:off x="731520" y="1051560"/>
-            <a:ext cx="10728655" cy="1280160"/>
+            <a:off x="731520" y="960120"/>
+            <a:ext cx="10728655" cy="1371600"/>
           </a:xfrm>
           <a:prstGeom prst="rect">
             <a:avLst/>
@@ -3162,7 +3162,7 @@
           <a:lstStyle/>
           <a:p>
             <a:pPr>
-              <a:defRPr sz="3600" b="1">
+              <a:defRPr sz="4000" b="1">
                 <a:solidFill>
                   <a:srgbClr val="16161A"/>
                 </a:solidFill>
@@ -3183,7 +3183,7 @@
         </p:nvSpPr>
         <p:spPr>
           <a:xfrm>
-            <a:off x="731520" y="2423160"/>
+            <a:off x="731520" y="2468880"/>
             <a:ext cx="10728655" cy="822960"/>
           </a:xfrm>
           <a:prstGeom prst="rect">
@@ -3198,7 +3198,7 @@
           <a:lstStyle/>
           <a:p>
             <a:pPr>
-              <a:defRPr sz="1450">
+              <a:defRPr sz="1600">
                 <a:solidFill>
                   <a:srgbClr val="454337"/>
                 </a:solidFill>
@@ -3219,7 +3219,7 @@
         </p:nvSpPr>
         <p:spPr>
           <a:xfrm>
-            <a:off x="731520" y="3429000"/>
+            <a:off x="731520" y="3520440"/>
             <a:ext cx="10728655" cy="12700"/>
           </a:xfrm>
           <a:prstGeom prst="rect">
@@ -3262,8 +3262,8 @@
         </p:nvSpPr>
         <p:spPr>
           <a:xfrm>
-            <a:off x="731520" y="3611880"/>
-            <a:ext cx="5157216" cy="1371600"/>
+            <a:off x="731520" y="3703320"/>
+            <a:ext cx="5157216" cy="1280160"/>
           </a:xfrm>
           <a:prstGeom prst="rect">
             <a:avLst/>
@@ -3280,7 +3280,7 @@
               <a:spcAft>
                 <a:spcPts val="600"/>
               </a:spcAft>
-              <a:defRPr sz="1050" b="1">
+              <a:defRPr sz="1100" b="1">
                 <a:solidFill>
                   <a:srgbClr val="2B59D9"/>
                 </a:solidFill>
@@ -3293,7 +3293,7 @@
           </a:p>
           <a:p>
             <a:pPr>
-              <a:defRPr sz="1250">
+              <a:defRPr sz="1400">
                 <a:solidFill>
                   <a:srgbClr val="16161A"/>
                 </a:solidFill>
@@ -3314,8 +3314,8 @@
         </p:nvSpPr>
         <p:spPr>
           <a:xfrm>
-            <a:off x="6300216" y="3611880"/>
-            <a:ext cx="5157216" cy="1371600"/>
+            <a:off x="6300216" y="3703320"/>
+            <a:ext cx="5157216" cy="1280160"/>
           </a:xfrm>
           <a:prstGeom prst="rect">
             <a:avLst/>
@@ -3332,7 +3332,7 @@
               <a:spcAft>
                 <a:spcPts val="600"/>
               </a:spcAft>
-              <a:defRPr sz="1050" b="1">
+              <a:defRPr sz="1100" b="1">
                 <a:solidFill>
                   <a:srgbClr val="D99B26"/>
                 </a:solidFill>
@@ -3348,7 +3348,7 @@
               <a:spcAft>
                 <a:spcPts val="400"/>
               </a:spcAft>
-              <a:defRPr sz="1300" b="1">
+              <a:defRPr sz="1400" b="1">
                 <a:solidFill>
                   <a:srgbClr val="16161A"/>
                 </a:solidFill>
@@ -3361,7 +3361,7 @@
           </a:p>
           <a:p>
             <a:pPr>
-              <a:defRPr sz="1150">
+              <a:defRPr sz="1250">
                 <a:solidFill>
                   <a:srgbClr val="454337"/>
                 </a:solidFill>
@@ -3447,7 +3447,7 @@
               <a:spcAft>
                 <a:spcPts val="200"/>
               </a:spcAft>
-              <a:defRPr sz="1300" b="1">
+              <a:defRPr sz="1500" b="1">
                 <a:solidFill>
                   <a:srgbClr val="16161A"/>
                 </a:solidFill>
@@ -3460,7 +3460,7 @@
           </a:p>
           <a:p>
             <a:pPr>
-              <a:defRPr sz="1050">
+              <a:defRPr sz="1200">
                 <a:solidFill>
                   <a:srgbClr val="454337"/>
                 </a:solidFill>
@@ -3499,7 +3499,7 @@
               <a:spcAft>
                 <a:spcPts val="200"/>
               </a:spcAft>
-              <a:defRPr sz="1300" b="1">
+              <a:defRPr sz="1500" b="1">
                 <a:solidFill>
                   <a:srgbClr val="16161A"/>
                 </a:solidFill>
@@ -3512,7 +3512,7 @@
           </a:p>
           <a:p>
             <a:pPr>
-              <a:defRPr sz="1050">
+              <a:defRPr sz="1200">
                 <a:solidFill>
                   <a:srgbClr val="454337"/>
                 </a:solidFill>
@@ -3551,7 +3551,7 @@
               <a:spcAft>
                 <a:spcPts val="200"/>
               </a:spcAft>
-              <a:defRPr sz="1300" b="1">
+              <a:defRPr sz="1500" b="1">
                 <a:solidFill>
                   <a:srgbClr val="16161A"/>
                 </a:solidFill>
@@ -3564,7 +3564,7 @@
           </a:p>
           <a:p>
             <a:pPr>
-              <a:defRPr sz="1050">
+              <a:defRPr sz="1200">
                 <a:solidFill>
                   <a:srgbClr val="454337"/>
                 </a:solidFill>
@@ -3603,7 +3603,7 @@
               <a:spcAft>
                 <a:spcPts val="200"/>
               </a:spcAft>
-              <a:defRPr sz="1300" b="1">
+              <a:defRPr sz="1500" b="1">
                 <a:solidFill>
                   <a:srgbClr val="16161A"/>
                 </a:solidFill>
@@ -3616,7 +3616,7 @@
           </a:p>
           <a:p>
             <a:pPr>
-              <a:defRPr sz="1050">
+              <a:defRPr sz="1200">
                 <a:solidFill>
                   <a:srgbClr val="454337"/>
                 </a:solidFill>
@@ -3695,7 +3695,7 @@
           <a:lstStyle/>
           <a:p>
             <a:pPr>
-              <a:defRPr sz="1000">
+              <a:defRPr sz="1050">
                 <a:solidFill>
                   <a:srgbClr val="736E62"/>
                 </a:solidFill>
@@ -3731,7 +3731,7 @@
           <a:lstStyle/>
           <a:p>
             <a:pPr algn="r">
-              <a:defRPr sz="1000">
+              <a:defRPr sz="1050">
                 <a:solidFill>
                   <a:srgbClr val="736E62"/>
                 </a:solidFill>
@@ -3778,7 +3778,7 @@
         </p:nvSpPr>
         <p:spPr>
           <a:xfrm>
-            <a:off x="731520" y="548640"/>
+            <a:off x="731520" y="502920"/>
             <a:ext cx="10728655" cy="228600"/>
           </a:xfrm>
           <a:prstGeom prst="rect">
@@ -3793,7 +3793,7 @@
           <a:lstStyle/>
           <a:p>
             <a:pPr>
-              <a:defRPr sz="1050" b="1">
+              <a:defRPr sz="1100" b="1">
                 <a:solidFill>
                   <a:srgbClr val="2B59D9"/>
                 </a:solidFill>
@@ -3814,8 +3814,8 @@
         </p:nvSpPr>
         <p:spPr>
           <a:xfrm>
-            <a:off x="731520" y="822960"/>
-            <a:ext cx="10728655" cy="685800"/>
+            <a:off x="731520" y="777240"/>
+            <a:ext cx="10728655" cy="731520"/>
           </a:xfrm>
           <a:prstGeom prst="rect">
             <a:avLst/>
@@ -3829,7 +3829,7 @@
           <a:lstStyle/>
           <a:p>
             <a:pPr>
-              <a:defRPr sz="2600" b="1">
+              <a:defRPr sz="3000" b="1">
                 <a:solidFill>
                   <a:srgbClr val="16161A"/>
                 </a:solidFill>
@@ -3911,7 +3911,7 @@
               <a:spcAft>
                 <a:spcPts val="800"/>
               </a:spcAft>
-              <a:defRPr sz="2000" b="1">
+              <a:defRPr sz="2800" b="1">
                 <a:solidFill>
                   <a:srgbClr val="2B59D9"/>
                 </a:solidFill>
@@ -3927,7 +3927,7 @@
               <a:spcAft>
                 <a:spcPts val="1000"/>
               </a:spcAft>
-              <a:defRPr sz="1900" b="1">
+              <a:defRPr sz="2000" b="1">
                 <a:solidFill>
                   <a:srgbClr val="16161A"/>
                 </a:solidFill>
@@ -3943,7 +3943,7 @@
               <a:spcAft>
                 <a:spcPts val="1600"/>
               </a:spcAft>
-              <a:defRPr sz="1250">
+              <a:defRPr sz="1350">
                 <a:solidFill>
                   <a:srgbClr val="454337"/>
                 </a:solidFill>
@@ -3959,7 +3959,7 @@
               <a:spcAft>
                 <a:spcPts val="800"/>
               </a:spcAft>
-              <a:defRPr sz="1200">
+              <a:defRPr sz="1350">
                 <a:solidFill>
                   <a:srgbClr val="16161A"/>
                 </a:solidFill>
@@ -3975,7 +3975,7 @@
               <a:spcAft>
                 <a:spcPts val="800"/>
               </a:spcAft>
-              <a:defRPr sz="1200">
+              <a:defRPr sz="1350">
                 <a:solidFill>
                   <a:srgbClr val="16161A"/>
                 </a:solidFill>
@@ -3991,7 +3991,7 @@
               <a:spcAft>
                 <a:spcPts val="800"/>
               </a:spcAft>
-              <a:defRPr sz="1200">
+              <a:defRPr sz="1350">
                 <a:solidFill>
                   <a:srgbClr val="16161A"/>
                 </a:solidFill>
@@ -4073,7 +4073,7 @@
               <a:spcAft>
                 <a:spcPts val="800"/>
               </a:spcAft>
-              <a:defRPr sz="2000" b="1">
+              <a:defRPr sz="2800" b="1">
                 <a:solidFill>
                   <a:srgbClr val="D99B26"/>
                 </a:solidFill>
@@ -4089,7 +4089,7 @@
               <a:spcAft>
                 <a:spcPts val="1000"/>
               </a:spcAft>
-              <a:defRPr sz="1900" b="1">
+              <a:defRPr sz="2000" b="1">
                 <a:solidFill>
                   <a:srgbClr val="16161A"/>
                 </a:solidFill>
@@ -4105,7 +4105,7 @@
               <a:spcAft>
                 <a:spcPts val="1600"/>
               </a:spcAft>
-              <a:defRPr sz="1250">
+              <a:defRPr sz="1350">
                 <a:solidFill>
                   <a:srgbClr val="454337"/>
                 </a:solidFill>
@@ -4121,7 +4121,7 @@
               <a:spcAft>
                 <a:spcPts val="800"/>
               </a:spcAft>
-              <a:defRPr sz="1200">
+              <a:defRPr sz="1350">
                 <a:solidFill>
                   <a:srgbClr val="16161A"/>
                 </a:solidFill>
@@ -4137,7 +4137,7 @@
               <a:spcAft>
                 <a:spcPts val="800"/>
               </a:spcAft>
-              <a:defRPr sz="1200">
+              <a:defRPr sz="1350">
                 <a:solidFill>
                   <a:srgbClr val="16161A"/>
                 </a:solidFill>
@@ -4153,7 +4153,7 @@
               <a:spcAft>
                 <a:spcPts val="800"/>
               </a:spcAft>
-              <a:defRPr sz="1200">
+              <a:defRPr sz="1350">
                 <a:solidFill>
                   <a:srgbClr val="16161A"/>
                 </a:solidFill>
@@ -4235,7 +4235,7 @@
               <a:spcAft>
                 <a:spcPts val="800"/>
               </a:spcAft>
-              <a:defRPr sz="2000" b="1">
+              <a:defRPr sz="2800" b="1">
                 <a:solidFill>
                   <a:srgbClr val="2B59D9"/>
                 </a:solidFill>
@@ -4251,7 +4251,7 @@
               <a:spcAft>
                 <a:spcPts val="1000"/>
               </a:spcAft>
-              <a:defRPr sz="1900" b="1">
+              <a:defRPr sz="2000" b="1">
                 <a:solidFill>
                   <a:srgbClr val="16161A"/>
                 </a:solidFill>
@@ -4267,7 +4267,7 @@
               <a:spcAft>
                 <a:spcPts val="1600"/>
               </a:spcAft>
-              <a:defRPr sz="1250">
+              <a:defRPr sz="1350">
                 <a:solidFill>
                   <a:srgbClr val="454337"/>
                 </a:solidFill>
@@ -4283,7 +4283,7 @@
               <a:spcAft>
                 <a:spcPts val="800"/>
               </a:spcAft>
-              <a:defRPr sz="1200">
+              <a:defRPr sz="1350">
                 <a:solidFill>
                   <a:srgbClr val="16161A"/>
                 </a:solidFill>
@@ -4299,7 +4299,7 @@
               <a:spcAft>
                 <a:spcPts val="800"/>
               </a:spcAft>
-              <a:defRPr sz="1200">
+              <a:defRPr sz="1350">
                 <a:solidFill>
                   <a:srgbClr val="16161A"/>
                 </a:solidFill>
@@ -4315,7 +4315,7 @@
               <a:spcAft>
                 <a:spcPts val="800"/>
               </a:spcAft>
-              <a:defRPr sz="1200">
+              <a:defRPr sz="1350">
                 <a:solidFill>
                   <a:srgbClr val="16161A"/>
                 </a:solidFill>
@@ -4394,7 +4394,7 @@
           <a:lstStyle/>
           <a:p>
             <a:pPr>
-              <a:defRPr sz="1000">
+              <a:defRPr sz="1050">
                 <a:solidFill>
                   <a:srgbClr val="736E62"/>
                 </a:solidFill>
@@ -4430,7 +4430,7 @@
           <a:lstStyle/>
           <a:p>
             <a:pPr algn="r">
-              <a:defRPr sz="1000">
+              <a:defRPr sz="1050">
                 <a:solidFill>
                   <a:srgbClr val="736E62"/>
                 </a:solidFill>
@@ -4477,7 +4477,7 @@
         </p:nvSpPr>
         <p:spPr>
           <a:xfrm>
-            <a:off x="731520" y="548640"/>
+            <a:off x="731520" y="502920"/>
             <a:ext cx="10728655" cy="228600"/>
           </a:xfrm>
           <a:prstGeom prst="rect">
@@ -4492,7 +4492,7 @@
           <a:lstStyle/>
           <a:p>
             <a:pPr>
-              <a:defRPr sz="1050" b="1">
+              <a:defRPr sz="1100" b="1">
                 <a:solidFill>
                   <a:srgbClr val="2B59D9"/>
                 </a:solidFill>
@@ -4513,8 +4513,8 @@
         </p:nvSpPr>
         <p:spPr>
           <a:xfrm>
-            <a:off x="731520" y="822960"/>
-            <a:ext cx="10728655" cy="685800"/>
+            <a:off x="731520" y="777240"/>
+            <a:ext cx="10728655" cy="731520"/>
           </a:xfrm>
           <a:prstGeom prst="rect">
             <a:avLst/>
@@ -4528,7 +4528,7 @@
           <a:lstStyle/>
           <a:p>
             <a:pPr>
-              <a:defRPr sz="2600" b="1">
+              <a:defRPr sz="3000" b="1">
                 <a:solidFill>
                   <a:srgbClr val="16161A"/>
                 </a:solidFill>
@@ -4626,7 +4626,7 @@
               <a:spcAft>
                 <a:spcPts val="1200"/>
               </a:spcAft>
-              <a:defRPr b="1" sz="1300">
+              <a:defRPr b="1" sz="1400">
                 <a:solidFill>
                   <a:srgbClr val="16161A"/>
                 </a:solidFill>
@@ -4637,7 +4637,7 @@
               <a:t>•  Empresas Medianas (Mid-Market): </a:t>
             </a:r>
             <a:r>
-              <a:rPr b="0">
+              <a:rPr b="0" sz="1350">
                 <a:solidFill>
                   <a:srgbClr val="454337"/>
                 </a:solidFill>
@@ -4650,7 +4650,7 @@
               <a:spcAft>
                 <a:spcPts val="1200"/>
               </a:spcAft>
-              <a:defRPr b="1" sz="1300">
+              <a:defRPr b="1" sz="1400">
                 <a:solidFill>
                   <a:srgbClr val="16161A"/>
                 </a:solidFill>
@@ -4661,7 +4661,7 @@
               <a:t>•  PyMEs en Aceleración: </a:t>
             </a:r>
             <a:r>
-              <a:rPr b="0">
+              <a:rPr b="0" sz="1350">
                 <a:solidFill>
                   <a:srgbClr val="454337"/>
                 </a:solidFill>
@@ -4674,7 +4674,7 @@
               <a:spcAft>
                 <a:spcPts val="1200"/>
               </a:spcAft>
-              <a:defRPr b="1" sz="1300">
+              <a:defRPr b="1" sz="1400">
                 <a:solidFill>
                   <a:srgbClr val="16161A"/>
                 </a:solidFill>
@@ -4685,7 +4685,7 @@
               <a:t>•  Startups con VC: </a:t>
             </a:r>
             <a:r>
-              <a:rPr b="0">
+              <a:rPr b="0" sz="1350">
                 <a:solidFill>
                   <a:srgbClr val="454337"/>
                 </a:solidFill>
@@ -4698,7 +4698,7 @@
               <a:spcAft>
                 <a:spcPts val="1200"/>
               </a:spcAft>
-              <a:defRPr b="1" sz="1300">
+              <a:defRPr b="1" sz="1400">
                 <a:solidFill>
                   <a:srgbClr val="16161A"/>
                 </a:solidFill>
@@ -4709,7 +4709,7 @@
               <a:t>•  Portafolio de PE / VC: </a:t>
             </a:r>
             <a:r>
-              <a:rPr b="0">
+              <a:rPr b="0" sz="1350">
                 <a:solidFill>
                   <a:srgbClr val="454337"/>
                 </a:solidFill>
@@ -4804,7 +4804,7 @@
               <a:spcAft>
                 <a:spcPts val="1200"/>
               </a:spcAft>
-              <a:defRPr b="1" sz="1300">
+              <a:defRPr b="1" sz="1400">
                 <a:solidFill>
                   <a:srgbClr val="16161A"/>
                 </a:solidFill>
@@ -4815,7 +4815,7 @@
               <a:t>•  CTOs y VPs de Ingeniería: </a:t>
             </a:r>
             <a:r>
-              <a:rPr b="0">
+              <a:rPr b="0" sz="1350">
                 <a:solidFill>
                   <a:srgbClr val="454337"/>
                 </a:solidFill>
@@ -4828,7 +4828,7 @@
               <a:spcAft>
                 <a:spcPts val="1200"/>
               </a:spcAft>
-              <a:defRPr b="1" sz="1300">
+              <a:defRPr b="1" sz="1400">
                 <a:solidFill>
                   <a:srgbClr val="16161A"/>
                 </a:solidFill>
@@ -4839,7 +4839,7 @@
               <a:t>•  CFOs y Directores de Finanzas: </a:t>
             </a:r>
             <a:r>
-              <a:rPr b="0">
+              <a:rPr b="0" sz="1350">
                 <a:solidFill>
                   <a:srgbClr val="454337"/>
                 </a:solidFill>
@@ -4852,7 +4852,7 @@
               <a:spcAft>
                 <a:spcPts val="1200"/>
               </a:spcAft>
-              <a:defRPr b="1" sz="1300">
+              <a:defRPr b="1" sz="1400">
                 <a:solidFill>
                   <a:srgbClr val="16161A"/>
                 </a:solidFill>
@@ -4863,7 +4863,7 @@
               <a:t>•  VPs de Operaciones: </a:t>
             </a:r>
             <a:r>
-              <a:rPr b="0">
+              <a:rPr b="0" sz="1350">
                 <a:solidFill>
                   <a:srgbClr val="454337"/>
                 </a:solidFill>
@@ -4876,7 +4876,7 @@
               <a:spcAft>
                 <a:spcPts val="1200"/>
               </a:spcAft>
-              <a:defRPr b="1" sz="1300">
+              <a:defRPr b="1" sz="1400">
                 <a:solidFill>
                   <a:srgbClr val="16161A"/>
                 </a:solidFill>
@@ -4887,7 +4887,7 @@
               <a:t>•  Fundadores y Líderes de Producto: </a:t>
             </a:r>
             <a:r>
-              <a:rPr b="0">
+              <a:rPr b="0" sz="1350">
                 <a:solidFill>
                   <a:srgbClr val="454337"/>
                 </a:solidFill>
@@ -4963,7 +4963,7 @@
           <a:lstStyle/>
           <a:p>
             <a:pPr>
-              <a:defRPr sz="1000">
+              <a:defRPr sz="1050">
                 <a:solidFill>
                   <a:srgbClr val="736E62"/>
                 </a:solidFill>
@@ -4999,7 +4999,7 @@
           <a:lstStyle/>
           <a:p>
             <a:pPr algn="r">
-              <a:defRPr sz="1000">
+              <a:defRPr sz="1050">
                 <a:solidFill>
                   <a:srgbClr val="736E62"/>
                 </a:solidFill>
@@ -5046,7 +5046,7 @@
         </p:nvSpPr>
         <p:spPr>
           <a:xfrm>
-            <a:off x="731520" y="548640"/>
+            <a:off x="731520" y="502920"/>
             <a:ext cx="10728655" cy="228600"/>
           </a:xfrm>
           <a:prstGeom prst="rect">
@@ -5061,7 +5061,7 @@
           <a:lstStyle/>
           <a:p>
             <a:pPr>
-              <a:defRPr sz="1050" b="1">
+              <a:defRPr sz="1100" b="1">
                 <a:solidFill>
                   <a:srgbClr val="2B59D9"/>
                 </a:solidFill>
@@ -5082,8 +5082,8 @@
         </p:nvSpPr>
         <p:spPr>
           <a:xfrm>
-            <a:off x="731520" y="822960"/>
-            <a:ext cx="10728655" cy="685800"/>
+            <a:off x="731520" y="777240"/>
+            <a:ext cx="10728655" cy="731520"/>
           </a:xfrm>
           <a:prstGeom prst="rect">
             <a:avLst/>
@@ -5097,7 +5097,7 @@
           <a:lstStyle/>
           <a:p>
             <a:pPr>
-              <a:defRPr sz="2600" b="1">
+              <a:defRPr sz="3000" b="1">
                 <a:solidFill>
                   <a:srgbClr val="16161A"/>
                 </a:solidFill>
@@ -5179,7 +5179,7 @@
               <a:spcAft>
                 <a:spcPts val="400"/>
               </a:spcAft>
-              <a:defRPr sz="1050" b="1">
+              <a:defRPr sz="1100" b="1">
                 <a:solidFill>
                   <a:srgbClr val="2B59D9"/>
                 </a:solidFill>
@@ -5192,7 +5192,7 @@
           </a:p>
           <a:p>
             <a:pPr>
-              <a:defRPr sz="1400">
+              <a:defRPr sz="1550">
                 <a:solidFill>
                   <a:srgbClr val="16161A"/>
                 </a:solidFill>
@@ -5274,7 +5274,7 @@
               <a:spcAft>
                 <a:spcPts val="400"/>
               </a:spcAft>
-              <a:defRPr sz="1050" b="1">
+              <a:defRPr sz="1100" b="1">
                 <a:solidFill>
                   <a:srgbClr val="D99B26"/>
                 </a:solidFill>
@@ -5287,7 +5287,7 @@
           </a:p>
           <a:p>
             <a:pPr>
-              <a:defRPr sz="1400">
+              <a:defRPr sz="1550">
                 <a:solidFill>
                   <a:srgbClr val="16161A"/>
                 </a:solidFill>
@@ -5369,7 +5369,7 @@
               <a:spcAft>
                 <a:spcPts val="400"/>
               </a:spcAft>
-              <a:defRPr sz="1050" b="1">
+              <a:defRPr sz="1100" b="1">
                 <a:solidFill>
                   <a:srgbClr val="2B59D9"/>
                 </a:solidFill>
@@ -5382,7 +5382,7 @@
           </a:p>
           <a:p>
             <a:pPr>
-              <a:defRPr sz="1400">
+              <a:defRPr sz="1550">
                 <a:solidFill>
                   <a:srgbClr val="16161A"/>
                 </a:solidFill>
@@ -5461,7 +5461,7 @@
           <a:lstStyle/>
           <a:p>
             <a:pPr>
-              <a:defRPr sz="1000">
+              <a:defRPr sz="1050">
                 <a:solidFill>
                   <a:srgbClr val="736E62"/>
                 </a:solidFill>
@@ -5497,7 +5497,7 @@
           <a:lstStyle/>
           <a:p>
             <a:pPr algn="r">
-              <a:defRPr sz="1000">
+              <a:defRPr sz="1050">
                 <a:solidFill>
                   <a:srgbClr val="736E62"/>
                 </a:solidFill>
@@ -5544,7 +5544,7 @@
         </p:nvSpPr>
         <p:spPr>
           <a:xfrm>
-            <a:off x="731520" y="548640"/>
+            <a:off x="731520" y="502920"/>
             <a:ext cx="10728655" cy="228600"/>
           </a:xfrm>
           <a:prstGeom prst="rect">
@@ -5559,7 +5559,7 @@
           <a:lstStyle/>
           <a:p>
             <a:pPr>
-              <a:defRPr sz="1050" b="1">
+              <a:defRPr sz="1100" b="1">
                 <a:solidFill>
                   <a:srgbClr val="2B59D9"/>
                 </a:solidFill>
@@ -5580,8 +5580,8 @@
         </p:nvSpPr>
         <p:spPr>
           <a:xfrm>
-            <a:off x="731520" y="822960"/>
-            <a:ext cx="10728655" cy="685800"/>
+            <a:off x="731520" y="777240"/>
+            <a:ext cx="10728655" cy="731520"/>
           </a:xfrm>
           <a:prstGeom prst="rect">
             <a:avLst/>
@@ -5595,7 +5595,7 @@
           <a:lstStyle/>
           <a:p>
             <a:pPr>
-              <a:defRPr sz="2600" b="1">
+              <a:defRPr sz="3000" b="1">
                 <a:solidFill>
                   <a:srgbClr val="16161A"/>
                 </a:solidFill>
@@ -5677,7 +5677,7 @@
               <a:spcAft>
                 <a:spcPts val="800"/>
               </a:spcAft>
-              <a:defRPr sz="1000" b="1">
+              <a:defRPr sz="1100" b="1">
                 <a:solidFill>
                   <a:srgbClr val="D99B26"/>
                 </a:solidFill>
@@ -5693,7 +5693,7 @@
               <a:spcAft>
                 <a:spcPts val="1000"/>
               </a:spcAft>
-              <a:defRPr sz="1800" b="1">
+              <a:defRPr sz="2000" b="1">
                 <a:solidFill>
                   <a:srgbClr val="16161A"/>
                 </a:solidFill>
@@ -5706,7 +5706,7 @@
           </a:p>
           <a:p>
             <a:pPr>
-              <a:defRPr sz="1250">
+              <a:defRPr sz="1350">
                 <a:solidFill>
                   <a:srgbClr val="454337"/>
                 </a:solidFill>
@@ -5788,7 +5788,7 @@
               <a:spcAft>
                 <a:spcPts val="800"/>
               </a:spcAft>
-              <a:defRPr sz="1000" b="1">
+              <a:defRPr sz="1100" b="1">
                 <a:solidFill>
                   <a:srgbClr val="2B59D9"/>
                 </a:solidFill>
@@ -5804,7 +5804,7 @@
               <a:spcAft>
                 <a:spcPts val="1000"/>
               </a:spcAft>
-              <a:defRPr sz="1800" b="1">
+              <a:defRPr sz="2000" b="1">
                 <a:solidFill>
                   <a:srgbClr val="16161A"/>
                 </a:solidFill>
@@ -5817,7 +5817,7 @@
           </a:p>
           <a:p>
             <a:pPr>
-              <a:defRPr sz="1250">
+              <a:defRPr sz="1350">
                 <a:solidFill>
                   <a:srgbClr val="454337"/>
                 </a:solidFill>
@@ -5899,7 +5899,7 @@
               <a:spcAft>
                 <a:spcPts val="800"/>
               </a:spcAft>
-              <a:defRPr sz="1000" b="1">
+              <a:defRPr sz="1100" b="1">
                 <a:solidFill>
                   <a:srgbClr val="2B59D9"/>
                 </a:solidFill>
@@ -5915,7 +5915,7 @@
               <a:spcAft>
                 <a:spcPts val="1000"/>
               </a:spcAft>
-              <a:defRPr sz="1800" b="1">
+              <a:defRPr sz="2000" b="1">
                 <a:solidFill>
                   <a:srgbClr val="16161A"/>
                 </a:solidFill>
@@ -5928,7 +5928,7 @@
           </a:p>
           <a:p>
             <a:pPr>
-              <a:defRPr sz="1250">
+              <a:defRPr sz="1350">
                 <a:solidFill>
                   <a:srgbClr val="454337"/>
                 </a:solidFill>
@@ -6007,7 +6007,7 @@
           <a:lstStyle/>
           <a:p>
             <a:pPr>
-              <a:defRPr sz="1250" b="1">
+              <a:defRPr sz="1500" b="1">
                 <a:solidFill>
                   <a:srgbClr val="16161A"/>
                 </a:solidFill>
@@ -6023,7 +6023,7 @@
               <a:spcBef>
                 <a:spcPts val="200"/>
               </a:spcBef>
-              <a:defRPr sz="1000">
+              <a:defRPr sz="1200">
                 <a:solidFill>
                   <a:srgbClr val="454337"/>
                 </a:solidFill>
@@ -6059,7 +6059,7 @@
           <a:lstStyle/>
           <a:p>
             <a:pPr>
-              <a:defRPr sz="1250" b="1">
+              <a:defRPr sz="1500" b="1">
                 <a:solidFill>
                   <a:srgbClr val="16161A"/>
                 </a:solidFill>
@@ -6075,7 +6075,7 @@
               <a:spcBef>
                 <a:spcPts val="200"/>
               </a:spcBef>
-              <a:defRPr sz="1000">
+              <a:defRPr sz="1200">
                 <a:solidFill>
                   <a:srgbClr val="454337"/>
                 </a:solidFill>
@@ -6111,7 +6111,7 @@
           <a:lstStyle/>
           <a:p>
             <a:pPr>
-              <a:defRPr sz="1250" b="1">
+              <a:defRPr sz="1500" b="1">
                 <a:solidFill>
                   <a:srgbClr val="16161A"/>
                 </a:solidFill>
@@ -6127,7 +6127,7 @@
               <a:spcBef>
                 <a:spcPts val="200"/>
               </a:spcBef>
-              <a:defRPr sz="1000">
+              <a:defRPr sz="1200">
                 <a:solidFill>
                   <a:srgbClr val="454337"/>
                 </a:solidFill>
@@ -6163,7 +6163,7 @@
           <a:lstStyle/>
           <a:p>
             <a:pPr>
-              <a:defRPr sz="1250" b="1">
+              <a:defRPr sz="1500" b="1">
                 <a:solidFill>
                   <a:srgbClr val="16161A"/>
                 </a:solidFill>
@@ -6179,7 +6179,7 @@
               <a:spcBef>
                 <a:spcPts val="200"/>
               </a:spcBef>
-              <a:defRPr sz="1000">
+              <a:defRPr sz="1200">
                 <a:solidFill>
                   <a:srgbClr val="454337"/>
                 </a:solidFill>
@@ -6258,7 +6258,7 @@
           <a:lstStyle/>
           <a:p>
             <a:pPr>
-              <a:defRPr sz="1000">
+              <a:defRPr sz="1050">
                 <a:solidFill>
                   <a:srgbClr val="736E62"/>
                 </a:solidFill>
@@ -6294,7 +6294,7 @@
           <a:lstStyle/>
           <a:p>
             <a:pPr algn="r">
-              <a:defRPr sz="1000">
+              <a:defRPr sz="1050">
                 <a:solidFill>
                   <a:srgbClr val="736E62"/>
                 </a:solidFill>
@@ -6341,7 +6341,7 @@
         </p:nvSpPr>
         <p:spPr>
           <a:xfrm>
-            <a:off x="731520" y="548640"/>
+            <a:off x="731520" y="502920"/>
             <a:ext cx="10728655" cy="228600"/>
           </a:xfrm>
           <a:prstGeom prst="rect">
@@ -6356,7 +6356,7 @@
           <a:lstStyle/>
           <a:p>
             <a:pPr>
-              <a:defRPr sz="1050" b="1">
+              <a:defRPr sz="1100" b="1">
                 <a:solidFill>
                   <a:srgbClr val="2B59D9"/>
                 </a:solidFill>
@@ -6377,8 +6377,8 @@
         </p:nvSpPr>
         <p:spPr>
           <a:xfrm>
-            <a:off x="731520" y="822960"/>
-            <a:ext cx="10728655" cy="685800"/>
+            <a:off x="731520" y="777240"/>
+            <a:ext cx="10728655" cy="731520"/>
           </a:xfrm>
           <a:prstGeom prst="rect">
             <a:avLst/>
@@ -6392,7 +6392,7 @@
           <a:lstStyle/>
           <a:p>
             <a:pPr>
-              <a:defRPr sz="2600" b="1">
+              <a:defRPr sz="3000" b="1">
                 <a:solidFill>
                   <a:srgbClr val="16161A"/>
                 </a:solidFill>
@@ -6490,7 +6490,7 @@
               <a:spcAft>
                 <a:spcPts val="1000"/>
               </a:spcAft>
-              <a:defRPr sz="1250">
+              <a:defRPr sz="1350">
                 <a:solidFill>
                   <a:srgbClr val="454337"/>
                 </a:solidFill>
@@ -6506,7 +6506,7 @@
               <a:spcAft>
                 <a:spcPts val="1000"/>
               </a:spcAft>
-              <a:defRPr sz="1250">
+              <a:defRPr sz="1350">
                 <a:solidFill>
                   <a:srgbClr val="454337"/>
                 </a:solidFill>
@@ -6522,7 +6522,7 @@
               <a:spcAft>
                 <a:spcPts val="1000"/>
               </a:spcAft>
-              <a:defRPr sz="1250">
+              <a:defRPr sz="1350">
                 <a:solidFill>
                   <a:srgbClr val="454337"/>
                 </a:solidFill>
@@ -6538,7 +6538,7 @@
               <a:spcAft>
                 <a:spcPts val="1000"/>
               </a:spcAft>
-              <a:defRPr sz="1250">
+              <a:defRPr sz="1350">
                 <a:solidFill>
                   <a:srgbClr val="454337"/>
                 </a:solidFill>
@@ -6636,7 +6636,7 @@
               <a:spcAft>
                 <a:spcPts val="1000"/>
               </a:spcAft>
-              <a:defRPr sz="1250">
+              <a:defRPr sz="1350">
                 <a:solidFill>
                   <a:srgbClr val="454337"/>
                 </a:solidFill>
@@ -6652,7 +6652,7 @@
               <a:spcAft>
                 <a:spcPts val="1000"/>
               </a:spcAft>
-              <a:defRPr sz="1250">
+              <a:defRPr sz="1350">
                 <a:solidFill>
                   <a:srgbClr val="454337"/>
                 </a:solidFill>
@@ -6668,7 +6668,7 @@
               <a:spcAft>
                 <a:spcPts val="1000"/>
               </a:spcAft>
-              <a:defRPr sz="1250">
+              <a:defRPr sz="1350">
                 <a:solidFill>
                   <a:srgbClr val="454337"/>
                 </a:solidFill>
@@ -6684,7 +6684,7 @@
               <a:spcAft>
                 <a:spcPts val="1000"/>
               </a:spcAft>
-              <a:defRPr sz="1250">
+              <a:defRPr sz="1350">
                 <a:solidFill>
                   <a:srgbClr val="454337"/>
                 </a:solidFill>
@@ -6763,7 +6763,7 @@
           <a:lstStyle/>
           <a:p>
             <a:pPr>
-              <a:defRPr sz="1000">
+              <a:defRPr sz="1050">
                 <a:solidFill>
                   <a:srgbClr val="736E62"/>
                 </a:solidFill>
@@ -6799,7 +6799,7 @@
           <a:lstStyle/>
           <a:p>
             <a:pPr algn="r">
-              <a:defRPr sz="1000">
+              <a:defRPr sz="1050">
                 <a:solidFill>
                   <a:srgbClr val="736E62"/>
                 </a:solidFill>
@@ -6846,7 +6846,7 @@
         </p:nvSpPr>
         <p:spPr>
           <a:xfrm>
-            <a:off x="731520" y="548640"/>
+            <a:off x="731520" y="502920"/>
             <a:ext cx="10728655" cy="228600"/>
           </a:xfrm>
           <a:prstGeom prst="rect">
@@ -6861,7 +6861,7 @@
           <a:lstStyle/>
           <a:p>
             <a:pPr>
-              <a:defRPr sz="1050" b="1">
+              <a:defRPr sz="1100" b="1">
                 <a:solidFill>
                   <a:srgbClr val="2B59D9"/>
                 </a:solidFill>
@@ -6882,8 +6882,8 @@
         </p:nvSpPr>
         <p:spPr>
           <a:xfrm>
-            <a:off x="731520" y="822960"/>
-            <a:ext cx="10728655" cy="685800"/>
+            <a:off x="731520" y="777240"/>
+            <a:ext cx="10728655" cy="731520"/>
           </a:xfrm>
           <a:prstGeom prst="rect">
             <a:avLst/>
@@ -6897,7 +6897,7 @@
           <a:lstStyle/>
           <a:p>
             <a:pPr>
-              <a:defRPr sz="2600" b="1">
+              <a:defRPr sz="3000" b="1">
                 <a:solidFill>
                   <a:srgbClr val="16161A"/>
                 </a:solidFill>
@@ -6979,7 +6979,7 @@
               <a:spcAft>
                 <a:spcPts val="1000"/>
               </a:spcAft>
-              <a:defRPr sz="1050" b="1">
+              <a:defRPr sz="1100" b="1">
                 <a:solidFill>
                   <a:srgbClr val="2B59D9"/>
                 </a:solidFill>
@@ -6995,7 +6995,7 @@
               <a:spcAft>
                 <a:spcPts val="1200"/>
               </a:spcAft>
-              <a:defRPr sz="1800" b="1">
+              <a:defRPr sz="2000" b="1">
                 <a:solidFill>
                   <a:srgbClr val="16161A"/>
                 </a:solidFill>
@@ -7008,7 +7008,7 @@
           </a:p>
           <a:p>
             <a:pPr>
-              <a:defRPr sz="1300">
+              <a:defRPr sz="1400">
                 <a:solidFill>
                   <a:srgbClr val="454337"/>
                 </a:solidFill>
@@ -7090,7 +7090,7 @@
               <a:spcAft>
                 <a:spcPts val="1000"/>
               </a:spcAft>
-              <a:defRPr sz="1050" b="1">
+              <a:defRPr sz="1100" b="1">
                 <a:solidFill>
                   <a:srgbClr val="2B59D9"/>
                 </a:solidFill>
@@ -7106,7 +7106,7 @@
               <a:spcAft>
                 <a:spcPts val="1200"/>
               </a:spcAft>
-              <a:defRPr sz="1800" b="1">
+              <a:defRPr sz="2000" b="1">
                 <a:solidFill>
                   <a:srgbClr val="16161A"/>
                 </a:solidFill>
@@ -7119,7 +7119,7 @@
           </a:p>
           <a:p>
             <a:pPr>
-              <a:defRPr sz="1300">
+              <a:defRPr sz="1400">
                 <a:solidFill>
                   <a:srgbClr val="454337"/>
                 </a:solidFill>
@@ -7201,7 +7201,7 @@
               <a:spcAft>
                 <a:spcPts val="1000"/>
               </a:spcAft>
-              <a:defRPr sz="1050" b="1">
+              <a:defRPr sz="1100" b="1">
                 <a:solidFill>
                   <a:srgbClr val="2B59D9"/>
                 </a:solidFill>
@@ -7217,7 +7217,7 @@
               <a:spcAft>
                 <a:spcPts val="1200"/>
               </a:spcAft>
-              <a:defRPr sz="1800" b="1">
+              <a:defRPr sz="2000" b="1">
                 <a:solidFill>
                   <a:srgbClr val="16161A"/>
                 </a:solidFill>
@@ -7230,7 +7230,7 @@
           </a:p>
           <a:p>
             <a:pPr>
-              <a:defRPr sz="1300">
+              <a:defRPr sz="1400">
                 <a:solidFill>
                   <a:srgbClr val="454337"/>
                 </a:solidFill>
@@ -7309,7 +7309,7 @@
           <a:lstStyle/>
           <a:p>
             <a:pPr>
-              <a:defRPr sz="1000">
+              <a:defRPr sz="1050">
                 <a:solidFill>
                   <a:srgbClr val="736E62"/>
                 </a:solidFill>
@@ -7345,7 +7345,7 @@
           <a:lstStyle/>
           <a:p>
             <a:pPr algn="r">
-              <a:defRPr sz="1000">
+              <a:defRPr sz="1050">
                 <a:solidFill>
                   <a:srgbClr val="736E62"/>
                 </a:solidFill>
@@ -7392,7 +7392,7 @@
         </p:nvSpPr>
         <p:spPr>
           <a:xfrm>
-            <a:off x="731520" y="548640"/>
+            <a:off x="731520" y="502920"/>
             <a:ext cx="10728655" cy="228600"/>
           </a:xfrm>
           <a:prstGeom prst="rect">
@@ -7407,7 +7407,7 @@
           <a:lstStyle/>
           <a:p>
             <a:pPr>
-              <a:defRPr sz="1050" b="1">
+              <a:defRPr sz="1100" b="1">
                 <a:solidFill>
                   <a:srgbClr val="2B59D9"/>
                 </a:solidFill>
@@ -7428,8 +7428,8 @@
         </p:nvSpPr>
         <p:spPr>
           <a:xfrm>
-            <a:off x="731520" y="822960"/>
-            <a:ext cx="10728655" cy="685800"/>
+            <a:off x="731520" y="777240"/>
+            <a:ext cx="10728655" cy="731520"/>
           </a:xfrm>
           <a:prstGeom prst="rect">
             <a:avLst/>
@@ -7443,7 +7443,7 @@
           <a:lstStyle/>
           <a:p>
             <a:pPr>
-              <a:defRPr sz="2600" b="1">
+              <a:defRPr sz="3000" b="1">
                 <a:solidFill>
                   <a:srgbClr val="16161A"/>
                 </a:solidFill>
@@ -7541,7 +7541,7 @@
               <a:spcAft>
                 <a:spcPts val="1000"/>
               </a:spcAft>
-              <a:defRPr sz="1550">
+              <a:defRPr sz="1600">
                 <a:solidFill>
                   <a:srgbClr val="16161A"/>
                 </a:solidFill>
@@ -7554,7 +7554,7 @@
           </a:p>
           <a:p>
             <a:pPr>
-              <a:defRPr sz="1550">
+              <a:defRPr sz="1600">
                 <a:solidFill>
                   <a:srgbClr val="16161A"/>
                 </a:solidFill>
@@ -7633,7 +7633,7 @@
           <a:lstStyle/>
           <a:p>
             <a:pPr>
-              <a:defRPr sz="1800" b="1">
+              <a:defRPr sz="2000" b="1">
                 <a:solidFill>
                   <a:srgbClr val="16161A"/>
                 </a:solidFill>
@@ -7649,10 +7649,11 @@
               <a:spcBef>
                 <a:spcPts val="400"/>
               </a:spcBef>
-              <a:defRPr sz="1300">
+              <a:defRPr sz="1400">
                 <a:solidFill>
                   <a:srgbClr val="2B59D9"/>
                 </a:solidFill>
+                <a:latin typeface="Helvetica Neue"/>
               </a:defRPr>
             </a:pPr>
             <a:r>
@@ -7727,7 +7728,7 @@
           <a:lstStyle/>
           <a:p>
             <a:pPr>
-              <a:defRPr sz="1000">
+              <a:defRPr sz="1050">
                 <a:solidFill>
                   <a:srgbClr val="736E62"/>
                 </a:solidFill>
@@ -7763,7 +7764,7 @@
           <a:lstStyle/>
           <a:p>
             <a:pPr algn="r">
-              <a:defRPr sz="1000">
+              <a:defRPr sz="1050">
                 <a:solidFill>
                   <a:srgbClr val="736E62"/>
                 </a:solidFill>

</xml_diff>

<commit_message>
Redesign presentation Cover Slide (Slide 1) with clean formal title 'Who to Send My Way' / '¿A quién enviarme?' and motto quote callout block
</commit_message>
<xml_diff>
--- a/Technology_Consultants_A_Quien_Enviarme_MX.pptx
+++ b/Technology_Consultants_A_Quien_Enviarme_MX.pptx
@@ -3134,7 +3134,7 @@
               </a:defRPr>
             </a:pPr>
             <a:r>
-              <a:t>TECHNOLOGY CONSULTANTS  ·  GUÍA DE REFERENCIAS PARA SOCIOS</a:t>
+              <a:t>TECHNOLOGY CONSULTANTS  ·  RESUMEN DE PRÁCTICA Y GUÍA DE REFERENCIAS</a:t>
             </a:r>
           </a:p>
         </p:txBody>
@@ -3148,7 +3148,7 @@
         <p:spPr>
           <a:xfrm>
             <a:off x="731520" y="960120"/>
-            <a:ext cx="10728655" cy="1371600"/>
+            <a:ext cx="10728655" cy="685800"/>
           </a:xfrm>
           <a:prstGeom prst="rect">
             <a:avLst/>
@@ -3162,7 +3162,7 @@
           <a:lstStyle/>
           <a:p>
             <a:pPr>
-              <a:defRPr sz="4000" b="1">
+              <a:defRPr sz="3800" b="1">
                 <a:solidFill>
                   <a:srgbClr val="16161A"/>
                 </a:solidFill>
@@ -3170,7 +3170,7 @@
               </a:defRPr>
             </a:pPr>
             <a:r>
-              <a:t>Desarrollamos tecnología alrededor de tu equipo — no para reemplazarlo.</a:t>
+              <a:t>¿A quién enviarme?</a:t>
             </a:r>
           </a:p>
         </p:txBody>
@@ -3183,8 +3183,8 @@
         </p:nvSpPr>
         <p:spPr>
           <a:xfrm>
-            <a:off x="731520" y="2468880"/>
-            <a:ext cx="10728655" cy="822960"/>
+            <a:off x="731520" y="1691640"/>
+            <a:ext cx="10728655" cy="411480"/>
           </a:xfrm>
           <a:prstGeom prst="rect">
             <a:avLst/>
@@ -3198,7 +3198,7 @@
           <a:lstStyle/>
           <a:p>
             <a:pPr>
-              <a:defRPr sz="1600">
+              <a:defRPr sz="1800">
                 <a:solidFill>
                   <a:srgbClr val="454337"/>
                 </a:solidFill>
@@ -3206,7 +3206,7 @@
               </a:defRPr>
             </a:pPr>
             <a:r>
-              <a:t>Desarrollamos software que elimina tareas repetitivas de tu equipo — desde aplicaciones web automatizadas hasta agentes de IA con supervisión humana en cada proceso clave donde el dinero, la confianza o el criterio importan.</a:t>
+              <a:t>Guía de Referencias para Socios y Perfil de Cliente Ideal</a:t>
             </a:r>
           </a:p>
         </p:txBody>
@@ -3219,7 +3219,102 @@
         </p:nvSpPr>
         <p:spPr>
           <a:xfrm>
-            <a:off x="731520" y="3520440"/>
+            <a:off x="731520" y="2331720"/>
+            <a:ext cx="38100" cy="868680"/>
+          </a:xfrm>
+          <a:prstGeom prst="rect">
+            <a:avLst/>
+          </a:prstGeom>
+          <a:solidFill>
+            <a:srgbClr val="2B59D9"/>
+          </a:solidFill>
+          <a:ln>
+            <a:noFill/>
+          </a:ln>
+        </p:spPr>
+        <p:style>
+          <a:lnRef idx="1">
+            <a:schemeClr val="accent1"/>
+          </a:lnRef>
+          <a:fillRef idx="3">
+            <a:schemeClr val="accent1"/>
+          </a:fillRef>
+          <a:effectRef idx="2">
+            <a:schemeClr val="accent1"/>
+          </a:effectRef>
+          <a:fontRef idx="minor">
+            <a:schemeClr val="lt1"/>
+          </a:fontRef>
+        </p:style>
+        <p:txBody>
+          <a:bodyPr rtlCol="0" anchor="ctr"/>
+          <a:lstStyle/>
+          <a:p>
+            <a:pPr algn="ctr"/>
+          </a:p>
+        </p:txBody>
+      </p:sp>
+      <p:sp>
+        <p:nvSpPr>
+          <p:cNvPr id="6" name="TextBox 5"/>
+          <p:cNvSpPr txBox="1"/>
+          <p:nvPr/>
+        </p:nvSpPr>
+        <p:spPr>
+          <a:xfrm>
+            <a:off x="960120" y="2331720"/>
+            <a:ext cx="10500055" cy="868680"/>
+          </a:xfrm>
+          <a:prstGeom prst="rect">
+            <a:avLst/>
+          </a:prstGeom>
+          <a:noFill/>
+        </p:spPr>
+        <p:txBody>
+          <a:bodyPr wrap="square" lIns="0" rIns="0" tIns="0" bIns="0">
+            <a:spAutoFit/>
+          </a:bodyPr>
+          <a:lstStyle/>
+          <a:p>
+            <a:pPr>
+              <a:spcAft>
+                <a:spcPts val="400"/>
+              </a:spcAft>
+              <a:defRPr sz="1600" b="1" i="1">
+                <a:solidFill>
+                  <a:srgbClr val="16161A"/>
+                </a:solidFill>
+                <a:latin typeface="Helvetica Neue"/>
+              </a:defRPr>
+            </a:pPr>
+            <a:r>
+              <a:t>“Desarrollamos tecnología alrededor de tu equipo — no para reemplazarlo.”</a:t>
+            </a:r>
+          </a:p>
+          <a:p>
+            <a:pPr>
+              <a:defRPr sz="1300">
+                <a:solidFill>
+                  <a:srgbClr val="454337"/>
+                </a:solidFill>
+                <a:latin typeface="Helvetica Neue"/>
+              </a:defRPr>
+            </a:pPr>
+            <a:r>
+              <a:t>Aplicaciones Web en React  ·  Integraciones en Workday Finance y ERP  ·  Agentes de IA con Supervisión Humana</a:t>
+            </a:r>
+          </a:p>
+        </p:txBody>
+      </p:sp>
+      <p:sp>
+        <p:nvSpPr>
+          <p:cNvPr id="7" name="Rectangle 6"/>
+          <p:cNvSpPr/>
+          <p:nvPr/>
+        </p:nvSpPr>
+        <p:spPr>
+          <a:xfrm>
+            <a:off x="731520" y="3429000"/>
             <a:ext cx="10728655" cy="12700"/>
           </a:xfrm>
           <a:prstGeom prst="rect">
@@ -3256,13 +3351,13 @@
       </p:sp>
       <p:sp>
         <p:nvSpPr>
-          <p:cNvPr id="6" name="TextBox 5"/>
+          <p:cNvPr id="8" name="TextBox 7"/>
           <p:cNvSpPr txBox="1"/>
           <p:nvPr/>
         </p:nvSpPr>
         <p:spPr>
           <a:xfrm>
-            <a:off x="731520" y="3703320"/>
+            <a:off x="731520" y="3611880"/>
             <a:ext cx="5157216" cy="1280160"/>
           </a:xfrm>
           <a:prstGeom prst="rect">
@@ -3280,7 +3375,7 @@
               <a:spcAft>
                 <a:spcPts val="600"/>
               </a:spcAft>
-              <a:defRPr sz="1100" b="1">
+              <a:defRPr sz="1050" b="1">
                 <a:solidFill>
                   <a:srgbClr val="2B59D9"/>
                 </a:solidFill>
@@ -3288,59 +3383,7 @@
               </a:defRPr>
             </a:pPr>
             <a:r>
-              <a:t>CAPACIDADES CLAVE</a:t>
-            </a:r>
-          </a:p>
-          <a:p>
-            <a:pPr>
-              <a:defRPr sz="1400">
-                <a:solidFill>
-                  <a:srgbClr val="16161A"/>
-                </a:solidFill>
-                <a:latin typeface="Helvetica Neue"/>
-              </a:defRPr>
-            </a:pPr>
-            <a:r>
-              <a:t>Aplicaciones Web en React y TypeScript  ·  Integraciones en Workday Finance y Adaptive  ·  Agentes de IA con Supervisión Humana (HITL)</a:t>
-            </a:r>
-          </a:p>
-        </p:txBody>
-      </p:sp>
-      <p:sp>
-        <p:nvSpPr>
-          <p:cNvPr id="7" name="TextBox 6"/>
-          <p:cNvSpPr txBox="1"/>
-          <p:nvPr/>
-        </p:nvSpPr>
-        <p:spPr>
-          <a:xfrm>
-            <a:off x="6300216" y="3703320"/>
-            <a:ext cx="5157216" cy="1280160"/>
-          </a:xfrm>
-          <a:prstGeom prst="rect">
-            <a:avLst/>
-          </a:prstGeom>
-          <a:noFill/>
-        </p:spPr>
-        <p:txBody>
-          <a:bodyPr wrap="square" lIns="0" rIns="0" tIns="0" bIns="0">
-            <a:spAutoFit/>
-          </a:bodyPr>
-          <a:lstStyle/>
-          <a:p>
-            <a:pPr>
-              <a:spcAft>
-                <a:spcPts val="600"/>
-              </a:spcAft>
-              <a:defRPr sz="1100" b="1">
-                <a:solidFill>
-                  <a:srgbClr val="D99B26"/>
-                </a:solidFill>
-                <a:latin typeface="Helvetica Neue"/>
-              </a:defRPr>
-            </a:pPr>
-            <a:r>
-              <a:t>LIDERAZGO DE LA PRÁCTICA</a:t>
+              <a:t>PRESENTADO POR</a:t>
             </a:r>
           </a:p>
           <a:p>
@@ -3371,16 +3414,80 @@
             <a:r>
               <a:t>Ingeniero Eléctrico (UC San Diego)  ·  MBA (NYU Stern)</a:t>
             </a:r>
-            <a:br/>
-            <a:r>
-              <a:t>Operando en San Diego, CA y Tijuana, MX</a:t>
-            </a:r>
-          </a:p>
-        </p:txBody>
-      </p:sp>
-      <p:sp>
-        <p:nvSpPr>
-          <p:cNvPr id="8" name="Rectangle 7"/>
+          </a:p>
+        </p:txBody>
+      </p:sp>
+      <p:sp>
+        <p:nvSpPr>
+          <p:cNvPr id="9" name="TextBox 8"/>
+          <p:cNvSpPr txBox="1"/>
+          <p:nvPr/>
+        </p:nvSpPr>
+        <p:spPr>
+          <a:xfrm>
+            <a:off x="6300216" y="3611880"/>
+            <a:ext cx="5157216" cy="1280160"/>
+          </a:xfrm>
+          <a:prstGeom prst="rect">
+            <a:avLst/>
+          </a:prstGeom>
+          <a:noFill/>
+        </p:spPr>
+        <p:txBody>
+          <a:bodyPr wrap="square" lIns="0" rIns="0" tIns="0" bIns="0">
+            <a:spAutoFit/>
+          </a:bodyPr>
+          <a:lstStyle/>
+          <a:p>
+            <a:pPr>
+              <a:spcAft>
+                <a:spcPts val="600"/>
+              </a:spcAft>
+              <a:defRPr sz="1050" b="1">
+                <a:solidFill>
+                  <a:srgbClr val="D99B26"/>
+                </a:solidFill>
+                <a:latin typeface="Helvetica Neue"/>
+              </a:defRPr>
+            </a:pPr>
+            <a:r>
+              <a:t>UBICACIÓN DE LA PRÁCTICA Y CONTACTO</a:t>
+            </a:r>
+          </a:p>
+          <a:p>
+            <a:pPr>
+              <a:spcAft>
+                <a:spcPts val="400"/>
+              </a:spcAft>
+              <a:defRPr sz="1400" b="1">
+                <a:solidFill>
+                  <a:srgbClr val="16161A"/>
+                </a:solidFill>
+                <a:latin typeface="Helvetica Neue"/>
+              </a:defRPr>
+            </a:pPr>
+            <a:r>
+              <a:t>San Diego, CA y Tijuana, MX</a:t>
+            </a:r>
+          </a:p>
+          <a:p>
+            <a:pPr>
+              <a:defRPr sz="1250">
+                <a:solidFill>
+                  <a:srgbClr val="2B59D9"/>
+                </a:solidFill>
+                <a:latin typeface="Helvetica Neue"/>
+              </a:defRPr>
+            </a:pPr>
+            <a:r>
+              <a:t>technologyconsultants.ventures</a:t>
+            </a:r>
+          </a:p>
+        </p:txBody>
+      </p:sp>
+      <p:sp>
+        <p:nvSpPr>
+          <p:cNvPr id="10" name="Rectangle 9"/>
           <p:cNvSpPr/>
           <p:nvPr/>
         </p:nvSpPr>
@@ -3423,7 +3530,7 @@
       </p:sp>
       <p:sp>
         <p:nvSpPr>
-          <p:cNvPr id="9" name="TextBox 8"/>
+          <p:cNvPr id="11" name="TextBox 10"/>
           <p:cNvSpPr txBox="1"/>
           <p:nvPr/>
         </p:nvSpPr>
@@ -3475,7 +3582,7 @@
       </p:sp>
       <p:sp>
         <p:nvSpPr>
-          <p:cNvPr id="10" name="TextBox 9"/>
+          <p:cNvPr id="12" name="TextBox 11"/>
           <p:cNvSpPr txBox="1"/>
           <p:nvPr/>
         </p:nvSpPr>
@@ -3527,7 +3634,7 @@
       </p:sp>
       <p:sp>
         <p:nvSpPr>
-          <p:cNvPr id="11" name="TextBox 10"/>
+          <p:cNvPr id="13" name="TextBox 12"/>
           <p:cNvSpPr txBox="1"/>
           <p:nvPr/>
         </p:nvSpPr>
@@ -3579,7 +3686,7 @@
       </p:sp>
       <p:sp>
         <p:nvSpPr>
-          <p:cNvPr id="12" name="TextBox 11"/>
+          <p:cNvPr id="14" name="TextBox 13"/>
           <p:cNvSpPr txBox="1"/>
           <p:nvPr/>
         </p:nvSpPr>
@@ -3631,7 +3738,7 @@
       </p:sp>
       <p:sp>
         <p:nvSpPr>
-          <p:cNvPr id="13" name="Rectangle 12"/>
+          <p:cNvPr id="15" name="Rectangle 14"/>
           <p:cNvSpPr/>
           <p:nvPr/>
         </p:nvSpPr>
@@ -3674,7 +3781,7 @@
       </p:sp>
       <p:sp>
         <p:nvSpPr>
-          <p:cNvPr id="14" name="TextBox 13"/>
+          <p:cNvPr id="16" name="TextBox 15"/>
           <p:cNvSpPr txBox="1"/>
           <p:nvPr/>
         </p:nvSpPr>
@@ -3710,7 +3817,7 @@
       </p:sp>
       <p:sp>
         <p:nvSpPr>
-          <p:cNvPr id="15" name="TextBox 14"/>
+          <p:cNvPr id="17" name="TextBox 16"/>
           <p:cNvSpPr txBox="1"/>
           <p:nvPr/>
         </p:nvSpPr>
@@ -3829,7 +3936,7 @@
           <a:lstStyle/>
           <a:p>
             <a:pPr>
-              <a:defRPr sz="3000" b="1">
+              <a:defRPr sz="2800" b="1">
                 <a:solidFill>
                   <a:srgbClr val="16161A"/>
                 </a:solidFill>
@@ -4528,7 +4635,7 @@
           <a:lstStyle/>
           <a:p>
             <a:pPr>
-              <a:defRPr sz="3000" b="1">
+              <a:defRPr sz="2800" b="1">
                 <a:solidFill>
                   <a:srgbClr val="16161A"/>
                 </a:solidFill>
@@ -5097,7 +5204,7 @@
           <a:lstStyle/>
           <a:p>
             <a:pPr>
-              <a:defRPr sz="3000" b="1">
+              <a:defRPr sz="2800" b="1">
                 <a:solidFill>
                   <a:srgbClr val="16161A"/>
                 </a:solidFill>
@@ -5595,7 +5702,7 @@
           <a:lstStyle/>
           <a:p>
             <a:pPr>
-              <a:defRPr sz="3000" b="1">
+              <a:defRPr sz="2800" b="1">
                 <a:solidFill>
                   <a:srgbClr val="16161A"/>
                 </a:solidFill>
@@ -6392,7 +6499,7 @@
           <a:lstStyle/>
           <a:p>
             <a:pPr>
-              <a:defRPr sz="3000" b="1">
+              <a:defRPr sz="2800" b="1">
                 <a:solidFill>
                   <a:srgbClr val="16161A"/>
                 </a:solidFill>
@@ -6897,7 +7004,7 @@
           <a:lstStyle/>
           <a:p>
             <a:pPr>
-              <a:defRPr sz="3000" b="1">
+              <a:defRPr sz="2800" b="1">
                 <a:solidFill>
                   <a:srgbClr val="16161A"/>
                 </a:solidFill>
@@ -7443,7 +7550,7 @@
           <a:lstStyle/>
           <a:p>
             <a:pPr>
-              <a:defRPr sz="3000" b="1">
+              <a:defRPr sz="2800" b="1">
                 <a:solidFill>
                   <a:srgbClr val="16161A"/>
                 </a:solidFill>

</xml_diff>

<commit_message>
Replace generic 'Bridging X with Y' placeholder slide title with specific practice headline 'Custom Web Apps, Enterprise Integrations & AI Agents'
</commit_message>
<xml_diff>
--- a/Technology_Consultants_A_Quien_Enviarme_MX.pptx
+++ b/Technology_Consultants_A_Quien_Enviarme_MX.pptx
@@ -3375,7 +3375,7 @@
               <a:spcAft>
                 <a:spcPts val="600"/>
               </a:spcAft>
-              <a:defRPr sz="1050" b="1">
+              <a:defRPr sz="1100" b="1">
                 <a:solidFill>
                   <a:srgbClr val="2B59D9"/>
                 </a:solidFill>
@@ -3443,7 +3443,7 @@
               <a:spcAft>
                 <a:spcPts val="600"/>
               </a:spcAft>
-              <a:defRPr sz="1050" b="1">
+              <a:defRPr sz="1100" b="1">
                 <a:solidFill>
                   <a:srgbClr val="D99B26"/>
                 </a:solidFill>
@@ -3944,7 +3944,7 @@
               </a:defRPr>
             </a:pPr>
             <a:r>
-              <a:t>De la Ingeniería a los Resultados de Negocio</a:t>
+              <a:t>Aplicaciones Web, Integraciones Empresariales y Agentes de IA</a:t>
             </a:r>
           </a:p>
         </p:txBody>
@@ -4643,7 +4643,7 @@
               </a:defRPr>
             </a:pPr>
             <a:r>
-              <a:t>¿Quiénes se benefician más de nuestra práctica?</a:t>
+              <a:t>Organizaciones Objetivo y Tomadores de Decisión</a:t>
             </a:r>
           </a:p>
         </p:txBody>
@@ -5212,7 +5212,7 @@
               </a:defRPr>
             </a:pPr>
             <a:r>
-              <a:t>Lo que dicen los clientes justo antes de necesitar nuestro apoyo</a:t>
+              <a:t>Señales de Dolor Operativo que Indican un Buen Perfil</a:t>
             </a:r>
           </a:p>
         </p:txBody>
@@ -5710,7 +5710,7 @@
               </a:defRPr>
             </a:pPr>
             <a:r>
-              <a:t>Probado en Entornos Operativos Reales</a:t>
+              <a:t>Integraciones Empresariales y Productos Propios</a:t>
             </a:r>
           </a:p>
         </p:txBody>
@@ -6507,7 +6507,7 @@
               </a:defRPr>
             </a:pPr>
             <a:r>
-              <a:t>¿Quiénes NO son un buen perfil? (Cuida la Calidad)</a:t>
+              <a:t>Proyectos No Adecuados que Declinamos Educadamente</a:t>
             </a:r>
           </a:p>
         </p:txBody>
@@ -7012,7 +7012,7 @@
               </a:defRPr>
             </a:pPr>
             <a:r>
-              <a:t>Modelos Flexibles de Colaboración</a:t>
+              <a:t>Opciones por Sprint, Proyecto y Retainer Mensual</a:t>
             </a:r>
           </a:p>
         </p:txBody>
@@ -7558,7 +7558,7 @@
               </a:defRPr>
             </a:pPr>
             <a:r>
-              <a:t>Cómo Hacer la Introducción</a:t>
+              <a:t>Plantilla Recomendada de Introducción por Correo</a:t>
             </a:r>
           </a:p>
         </p:txBody>

</xml_diff>